<commit_message>
refactor: update pricing, sizing calculations, and documentation for AWS Bedrock and infrastructure components
</commit_message>
<xml_diff>
--- a/G03_slide.pptx
+++ b/G03_slide.pptx
@@ -2,14 +2,14 @@
 <file path=ppt/presentation.xml><?xml version="1.0" encoding="utf-8"?>
 <p:presentation xmlns:p="http://schemas.openxmlformats.org/presentationml/2006/main">
   <p:sldMasterIdLst>
-    <p:sldMasterId xmlns:r="http://schemas.openxmlformats.org/officeDocument/2006/relationships" id="2147483648" r:id="Rbe3524bbf7ba4c26"/>
+    <p:sldMasterId xmlns:r="http://schemas.openxmlformats.org/officeDocument/2006/relationships" id="2147483648" r:id="R146dcbcbe65d4986"/>
   </p:sldMasterIdLst>
   <p:notesMasterIdLst>
-    <p:notesMasterId xmlns:r="http://schemas.openxmlformats.org/officeDocument/2006/relationships" r:id="R58485cda683a4276"/>
+    <p:notesMasterId xmlns:r="http://schemas.openxmlformats.org/officeDocument/2006/relationships" r:id="Rf31ed27a2fae4ae4"/>
   </p:notesMasterIdLst>
   <p:sldIdLst>
-    <p:sldId xmlns:r="http://schemas.openxmlformats.org/officeDocument/2006/relationships" id="256" r:id="Rc661eab64f9e49d8"/>
-    <p:sldId xmlns:r="http://schemas.openxmlformats.org/officeDocument/2006/relationships" id="257" r:id="R9cc5ca3ab4a04474"/>
+    <p:sldId xmlns:r="http://schemas.openxmlformats.org/officeDocument/2006/relationships" id="256" r:id="R77e8c457ac384b29"/>
+    <p:sldId xmlns:r="http://schemas.openxmlformats.org/officeDocument/2006/relationships" id="257" r:id="Rf85a221e7cb246c1"/>
   </p:sldIdLst>
   <p:sldSz cx="12192000" cy="6858000"/>
   <p:notesSz cx="6858000" cy="9144000"/>
@@ -552,7 +552,7 @@
           <p:cNvPr id="3" name="Title">
             <a:extLst xmlns:a="http://schemas.openxmlformats.org/drawingml/2006/main">
               <a:ext uri="{FF2B5EF4-FFF2-40B4-BE49-F238E27FC236}">
-                <a16:creationId xmlns:a16="http://schemas.microsoft.com/office/drawing/2014/main" id="{AF096C2B-4746-4EF7-8453-B10B310A7658}"/>
+                <a16:creationId xmlns:a16="http://schemas.microsoft.com/office/drawing/2014/main" id="{36CF4E87-FD27-44D5-BCC7-6DC170464891}"/>
               </a:ext>
             </a:extLst>
           </p:cNvPr>
@@ -709,7 +709,7 @@
           <p:cNvPr id="2" name="Subtitle">
             <a:extLst xmlns:a="http://schemas.openxmlformats.org/drawingml/2006/main">
               <a:ext uri="{FF2B5EF4-FFF2-40B4-BE49-F238E27FC236}">
-                <a16:creationId xmlns:a16="http://schemas.microsoft.com/office/drawing/2014/main" id="{925CF3C3-ED8E-45D7-814C-B4D80E5C88E3}"/>
+                <a16:creationId xmlns:a16="http://schemas.microsoft.com/office/drawing/2014/main" id="{743AB708-CB94-4F4D-9094-E8D4D54FDD9D}"/>
               </a:ext>
             </a:extLst>
           </p:cNvPr>
@@ -883,7 +883,7 @@
           <p:cNvPr id="2" name="Section title">
             <a:extLst xmlns:a="http://schemas.openxmlformats.org/drawingml/2006/main">
               <a:ext uri="{FF2B5EF4-FFF2-40B4-BE49-F238E27FC236}">
-                <a16:creationId xmlns:a16="http://schemas.microsoft.com/office/drawing/2014/main" id="{C38AA290-C9A7-4B2E-A66B-BB960F145A6F}"/>
+                <a16:creationId xmlns:a16="http://schemas.microsoft.com/office/drawing/2014/main" id="{23020810-0C64-4F89-9FAA-905B5982B4C2}"/>
               </a:ext>
             </a:extLst>
           </p:cNvPr>
@@ -1057,7 +1057,7 @@
           <p:cNvPr id="3" name="Title">
             <a:extLst xmlns:a="http://schemas.openxmlformats.org/drawingml/2006/main">
               <a:ext uri="{FF2B5EF4-FFF2-40B4-BE49-F238E27FC236}">
-                <a16:creationId xmlns:a16="http://schemas.microsoft.com/office/drawing/2014/main" id="{0CAD3753-F200-44CB-A37B-704B20C18CFA}"/>
+                <a16:creationId xmlns:a16="http://schemas.microsoft.com/office/drawing/2014/main" id="{0F3E0C1B-E5CC-4595-9591-72470FDA0339}"/>
               </a:ext>
             </a:extLst>
           </p:cNvPr>
@@ -1214,7 +1214,7 @@
           <p:cNvPr id="2" name="Body">
             <a:extLst xmlns:a="http://schemas.openxmlformats.org/drawingml/2006/main">
               <a:ext uri="{FF2B5EF4-FFF2-40B4-BE49-F238E27FC236}">
-                <a16:creationId xmlns:a16="http://schemas.microsoft.com/office/drawing/2014/main" id="{331A7FA4-4AAD-4A17-8316-17E69A9BFD31}"/>
+                <a16:creationId xmlns:a16="http://schemas.microsoft.com/office/drawing/2014/main" id="{AFA23D25-E0C1-409B-9039-55D962A80E4E}"/>
               </a:ext>
             </a:extLst>
           </p:cNvPr>
@@ -1388,7 +1388,7 @@
           <p:cNvPr id="4" name="Title">
             <a:extLst xmlns:a="http://schemas.openxmlformats.org/drawingml/2006/main">
               <a:ext uri="{FF2B5EF4-FFF2-40B4-BE49-F238E27FC236}">
-                <a16:creationId xmlns:a16="http://schemas.microsoft.com/office/drawing/2014/main" id="{A333CF53-5105-4749-8E30-A2321AB0C1C0}"/>
+                <a16:creationId xmlns:a16="http://schemas.microsoft.com/office/drawing/2014/main" id="{24258F05-AADD-4CA8-B633-CF55E1B39504}"/>
               </a:ext>
             </a:extLst>
           </p:cNvPr>
@@ -1545,7 +1545,7 @@
           <p:cNvPr id="2" name="Left column">
             <a:extLst xmlns:a="http://schemas.openxmlformats.org/drawingml/2006/main">
               <a:ext uri="{FF2B5EF4-FFF2-40B4-BE49-F238E27FC236}">
-                <a16:creationId xmlns:a16="http://schemas.microsoft.com/office/drawing/2014/main" id="{30F4977C-E6D9-4C33-9CC3-BA25B9097BB2}"/>
+                <a16:creationId xmlns:a16="http://schemas.microsoft.com/office/drawing/2014/main" id="{F98B85E6-FA4F-49B8-A511-97E7A5190418}"/>
               </a:ext>
             </a:extLst>
           </p:cNvPr>
@@ -1702,7 +1702,7 @@
           <p:cNvPr id="3" name="Right column">
             <a:extLst xmlns:a="http://schemas.openxmlformats.org/drawingml/2006/main">
               <a:ext uri="{FF2B5EF4-FFF2-40B4-BE49-F238E27FC236}">
-                <a16:creationId xmlns:a16="http://schemas.microsoft.com/office/drawing/2014/main" id="{F9B2E0C8-8CEE-4848-AABC-CC33B35B27C7}"/>
+                <a16:creationId xmlns:a16="http://schemas.microsoft.com/office/drawing/2014/main" id="{37378C09-17FB-4DB0-9381-F1CD7174911A}"/>
               </a:ext>
             </a:extLst>
           </p:cNvPr>
@@ -1876,7 +1876,7 @@
           <p:cNvPr id="3" name="Title">
             <a:extLst xmlns:a="http://schemas.openxmlformats.org/drawingml/2006/main">
               <a:ext uri="{FF2B5EF4-FFF2-40B4-BE49-F238E27FC236}">
-                <a16:creationId xmlns:a16="http://schemas.microsoft.com/office/drawing/2014/main" id="{52B62295-E93E-4D00-9B8E-4E79F8592126}"/>
+                <a16:creationId xmlns:a16="http://schemas.microsoft.com/office/drawing/2014/main" id="{33BD5826-27FA-4C7D-8DBD-011812D548B3}"/>
               </a:ext>
             </a:extLst>
           </p:cNvPr>
@@ -2033,7 +2033,7 @@
           <p:cNvPr id="2" name="Left column">
             <a:extLst xmlns:a="http://schemas.openxmlformats.org/drawingml/2006/main">
               <a:ext uri="{FF2B5EF4-FFF2-40B4-BE49-F238E27FC236}">
-                <a16:creationId xmlns:a16="http://schemas.microsoft.com/office/drawing/2014/main" id="{9A2DDC66-EC6A-402E-A13C-B3E7B464BFA8}"/>
+                <a16:creationId xmlns:a16="http://schemas.microsoft.com/office/drawing/2014/main" id="{9A0C3138-993B-4008-A8E5-D6E5669D689F}"/>
               </a:ext>
             </a:extLst>
           </p:cNvPr>
@@ -2228,12 +2228,12 @@
   </p:cSld>
   <p:clrMap bg1="lt1" tx1="dk1" bg2="lt2" tx2="dk2" accent1="accent1" accent2="accent2" accent3="accent3" accent4="accent4" accent5="accent5" accent6="accent6" hlink="hlink" folHlink="folHlink"/>
   <p:sldLayoutIdLst>
-    <p:sldLayoutId xmlns:r="http://schemas.openxmlformats.org/officeDocument/2006/relationships" id="2147483649" r:id="R9a024e1bfdc8418a"/>
-    <p:sldLayoutId xmlns:r="http://schemas.openxmlformats.org/officeDocument/2006/relationships" id="2147483650" r:id="Rebe182de5ec644ef"/>
-    <p:sldLayoutId xmlns:r="http://schemas.openxmlformats.org/officeDocument/2006/relationships" id="2147483651" r:id="R4f96ee9bb2594a73"/>
-    <p:sldLayoutId xmlns:r="http://schemas.openxmlformats.org/officeDocument/2006/relationships" id="2147483652" r:id="Ra1c29cf24317454e"/>
-    <p:sldLayoutId xmlns:r="http://schemas.openxmlformats.org/officeDocument/2006/relationships" id="2147483653" r:id="Rbb84e409c4c141f3"/>
-    <p:sldLayoutId xmlns:r="http://schemas.openxmlformats.org/officeDocument/2006/relationships" id="2147483654" r:id="R3b8fd3b7c36c4381"/>
+    <p:sldLayoutId xmlns:r="http://schemas.openxmlformats.org/officeDocument/2006/relationships" id="2147483649" r:id="R83dd212d813548a8"/>
+    <p:sldLayoutId xmlns:r="http://schemas.openxmlformats.org/officeDocument/2006/relationships" id="2147483650" r:id="R7eb8ac48aeda4bef"/>
+    <p:sldLayoutId xmlns:r="http://schemas.openxmlformats.org/officeDocument/2006/relationships" id="2147483651" r:id="Ra17e80568a514106"/>
+    <p:sldLayoutId xmlns:r="http://schemas.openxmlformats.org/officeDocument/2006/relationships" id="2147483652" r:id="R5633715b3d624449"/>
+    <p:sldLayoutId xmlns:r="http://schemas.openxmlformats.org/officeDocument/2006/relationships" id="2147483653" r:id="Rf7ce13f67abb462e"/>
+    <p:sldLayoutId xmlns:r="http://schemas.openxmlformats.org/officeDocument/2006/relationships" id="2147483654" r:id="R60fe6dea5e554f8c"/>
   </p:sldLayoutIdLst>
   <p:txStyles>
     <p:titleStyle>
@@ -2784,7 +2784,7 @@
           <p:cNvPr id="14" name="">
             <a:extLst xmlns:a="http://schemas.openxmlformats.org/drawingml/2006/main">
               <a:ext uri="{FF2B5EF4-FFF2-40B4-BE49-F238E27FC236}">
-                <a16:creationId xmlns:a16="http://schemas.microsoft.com/office/drawing/2014/main" id="{7FFC2803-DE97-49F0-BEA9-56F57B254F4E}"/>
+                <a16:creationId xmlns:a16="http://schemas.microsoft.com/office/drawing/2014/main" id="{D8146625-4FA7-4DF3-8652-9B4B8232F521}"/>
               </a:ext>
             </a:extLst>
           </p:cNvPr>
@@ -2842,7 +2842,7 @@
           <p:cNvPr id="2" name="">
             <a:extLst xmlns:a="http://schemas.openxmlformats.org/drawingml/2006/main">
               <a:ext uri="{FF2B5EF4-FFF2-40B4-BE49-F238E27FC236}">
-                <a16:creationId xmlns:a16="http://schemas.microsoft.com/office/drawing/2014/main" id="{E6B0A979-F5F6-45DE-9CEC-F2182A9B079F}"/>
+                <a16:creationId xmlns:a16="http://schemas.microsoft.com/office/drawing/2014/main" id="{575A355F-D763-4A64-B316-051A260EE339}"/>
               </a:ext>
             </a:extLst>
           </p:cNvPr>
@@ -2900,7 +2900,7 @@
           <p:cNvPr id="3" name="">
             <a:extLst xmlns:a="http://schemas.openxmlformats.org/drawingml/2006/main">
               <a:ext uri="{FF2B5EF4-FFF2-40B4-BE49-F238E27FC236}">
-                <a16:creationId xmlns:a16="http://schemas.microsoft.com/office/drawing/2014/main" id="{47F9CBFB-0B2C-44B6-AE16-925A9A6785A0}"/>
+                <a16:creationId xmlns:a16="http://schemas.microsoft.com/office/drawing/2014/main" id="{C3AF6852-A669-401B-B623-84BBDE793A74}"/>
               </a:ext>
             </a:extLst>
           </p:cNvPr>
@@ -2912,7 +2912,7 @@
         <p:spPr>
           <a:xfrm xmlns:a="http://schemas.openxmlformats.org/drawingml/2006/main">
             <a:off x="609600" y="1381125"/>
-            <a:ext cx="7239000" cy="266700"/>
+            <a:ext cx="8572500" cy="266700"/>
           </a:xfrm>
           <a:prstGeom xmlns:a="http://schemas.openxmlformats.org/drawingml/2006/main" prst="rect">
             <a:avLst/>
@@ -2948,7 +2948,7 @@
                   <a:srgbClr val="4F6270"/>
                 </a:solidFill>
               </a:rPr>
-              <a:t>2.000 DAU · AWS ap-southeast-1 · 2 AZ · chưa VAT</a:t>
+              <a:t>2.000 DAU · AWS ap-southeast-1 · APAC Geo Cross-Region · chưa VAT</a:t>
             </a:r>
           </a:p>
         </p:txBody>
@@ -2958,7 +2958,7 @@
           <p:cNvPr id="4" name="">
             <a:extLst xmlns:a="http://schemas.openxmlformats.org/drawingml/2006/main">
               <a:ext uri="{FF2B5EF4-FFF2-40B4-BE49-F238E27FC236}">
-                <a16:creationId xmlns:a16="http://schemas.microsoft.com/office/drawing/2014/main" id="{8B4DD2F9-2D2B-470A-9010-6445CAE50146}"/>
+                <a16:creationId xmlns:a16="http://schemas.microsoft.com/office/drawing/2014/main" id="{3B2A3AA1-93D0-43C8-AA0B-C3E486068C4A}"/>
               </a:ext>
             </a:extLst>
           </p:cNvPr>
@@ -3039,7 +3039,7 @@
           <p:cNvPr id="5" name="">
             <a:extLst xmlns:a="http://schemas.openxmlformats.org/drawingml/2006/main">
               <a:ext uri="{FF2B5EF4-FFF2-40B4-BE49-F238E27FC236}">
-                <a16:creationId xmlns:a16="http://schemas.microsoft.com/office/drawing/2014/main" id="{589A4171-6056-40C5-A7AD-527C6DE0EFA6}"/>
+                <a16:creationId xmlns:a16="http://schemas.microsoft.com/office/drawing/2014/main" id="{E454DFEC-5BD0-4961-9601-7C80B27BBD27}"/>
               </a:ext>
             </a:extLst>
           </p:cNvPr>
@@ -3120,7 +3120,7 @@
           <p:cNvPr id="6" name="">
             <a:extLst xmlns:a="http://schemas.openxmlformats.org/drawingml/2006/main">
               <a:ext uri="{FF2B5EF4-FFF2-40B4-BE49-F238E27FC236}">
-                <a16:creationId xmlns:a16="http://schemas.microsoft.com/office/drawing/2014/main" id="{95C2B37E-F0F0-49AE-B6A2-817C144567BA}"/>
+                <a16:creationId xmlns:a16="http://schemas.microsoft.com/office/drawing/2014/main" id="{86FD8513-386C-43EB-893A-E5D1384AC507}"/>
               </a:ext>
             </a:extLst>
           </p:cNvPr>
@@ -3201,7 +3201,7 @@
           <p:cNvPr id="7" name="">
             <a:extLst xmlns:a="http://schemas.openxmlformats.org/drawingml/2006/main">
               <a:ext uri="{FF2B5EF4-FFF2-40B4-BE49-F238E27FC236}">
-                <a16:creationId xmlns:a16="http://schemas.microsoft.com/office/drawing/2014/main" id="{6134FE84-F522-4C2B-996E-F8F990325A58}"/>
+                <a16:creationId xmlns:a16="http://schemas.microsoft.com/office/drawing/2014/main" id="{D372E7F1-1A7B-4C23-AC2B-81BA262ECA95}"/>
               </a:ext>
             </a:extLst>
           </p:cNvPr>
@@ -3282,7 +3282,7 @@
           <p:cNvPr id="8" name="">
             <a:extLst xmlns:a="http://schemas.openxmlformats.org/drawingml/2006/main">
               <a:ext uri="{FF2B5EF4-FFF2-40B4-BE49-F238E27FC236}">
-                <a16:creationId xmlns:a16="http://schemas.microsoft.com/office/drawing/2014/main" id="{B19C6575-9727-4EF5-9A90-928F4F962768}"/>
+                <a16:creationId xmlns:a16="http://schemas.microsoft.com/office/drawing/2014/main" id="{AD438042-97E5-44F1-9E7F-F36FC90C52AC}"/>
               </a:ext>
             </a:extLst>
           </p:cNvPr>
@@ -3336,7 +3336,7 @@
                   <a:srgbClr val="0D1B26"/>
                 </a:solidFill>
               </a:rPr>
-              <a:t>6,000 GB</a:t>
+              <a:t>6,100 GB</a:t>
             </a:r>
           </a:p>
           <a:p xmlns:a="http://schemas.openxmlformats.org/drawingml/2006/main">
@@ -3363,7 +3363,7 @@
           <p:cNvPr id="9" name="">
             <a:extLst xmlns:a="http://schemas.openxmlformats.org/drawingml/2006/main">
               <a:ext uri="{FF2B5EF4-FFF2-40B4-BE49-F238E27FC236}">
-                <a16:creationId xmlns:a16="http://schemas.microsoft.com/office/drawing/2014/main" id="{E315506D-F76D-424A-896E-7DB442C9EB48}"/>
+                <a16:creationId xmlns:a16="http://schemas.microsoft.com/office/drawing/2014/main" id="{B73BEEF2-5E45-4D62-B750-C69F5C71099E}"/>
               </a:ext>
             </a:extLst>
           </p:cNvPr>
@@ -3421,7 +3421,7 @@
           <p:cNvPr id="10" name="">
             <a:extLst xmlns:a="http://schemas.openxmlformats.org/drawingml/2006/main">
               <a:ext uri="{FF2B5EF4-FFF2-40B4-BE49-F238E27FC236}">
-                <a16:creationId xmlns:a16="http://schemas.microsoft.com/office/drawing/2014/main" id="{D53FEB9A-F3BB-4EB0-BFC6-06F36AE6B64C}"/>
+                <a16:creationId xmlns:a16="http://schemas.microsoft.com/office/drawing/2014/main" id="{4600CFE5-B552-4DD5-AF3E-0617D11F4F26}"/>
               </a:ext>
             </a:extLst>
           </p:cNvPr>
@@ -3520,7 +3520,7 @@
                   <a:srgbClr val="0D1B26"/>
                 </a:solidFill>
               </a:rPr>
-              <a:t>2,000 × 3 GB = 6,000 GB</a:t>
+              <a:t>2,000 × 3 GB + 100 GB staging = 6,100 GB</a:t>
             </a:r>
           </a:p>
         </p:txBody>
@@ -3530,7 +3530,7 @@
           <p:cNvPr id="11" name="">
             <a:extLst xmlns:a="http://schemas.openxmlformats.org/drawingml/2006/main">
               <a:ext uri="{FF2B5EF4-FFF2-40B4-BE49-F238E27FC236}">
-                <a16:creationId xmlns:a16="http://schemas.microsoft.com/office/drawing/2014/main" id="{F11C623F-7CF8-443F-BF53-DCC0F74F1179}"/>
+                <a16:creationId xmlns:a16="http://schemas.microsoft.com/office/drawing/2014/main" id="{793B9935-B9CF-4958-9D65-0A63FFE4EF2E}"/>
               </a:ext>
             </a:extLst>
           </p:cNvPr>
@@ -3588,7 +3588,7 @@
           <p:cNvPr id="12" name="">
             <a:extLst xmlns:a="http://schemas.openxmlformats.org/drawingml/2006/main">
               <a:ext uri="{FF2B5EF4-FFF2-40B4-BE49-F238E27FC236}">
-                <a16:creationId xmlns:a16="http://schemas.microsoft.com/office/drawing/2014/main" id="{F2D5622C-F6DC-4D0B-9386-AE54ADCFC6DC}"/>
+                <a16:creationId xmlns:a16="http://schemas.microsoft.com/office/drawing/2014/main" id="{EE653B82-2149-4B5E-AD4D-C926995568D2}"/>
               </a:ext>
             </a:extLst>
           </p:cNvPr>
@@ -3600,7 +3600,7 @@
         <p:spPr>
           <a:xfrm xmlns:a="http://schemas.openxmlformats.org/drawingml/2006/main">
             <a:off x="6667500" y="4171950"/>
-            <a:ext cx="4857750" cy="1524000"/>
+            <a:ext cx="4857750" cy="1714500"/>
           </a:xfrm>
           <a:prstGeom xmlns:a="http://schemas.openxmlformats.org/drawingml/2006/main" prst="rect">
             <a:avLst/>
@@ -3615,7 +3615,7 @@
           <a:bodyPr xmlns:a="http://schemas.openxmlformats.org/drawingml/2006/main"/>
           <a:lstStyle xmlns:a="http://schemas.openxmlformats.org/drawingml/2006/main">
             <a:defPPr>
-              <a:defRPr sz="1500" b="0">
+              <a:defRPr sz="1350" b="0">
                 <a:solidFill>
                   <a:srgbClr val="0D1B26"/>
                 </a:solidFill>
@@ -3624,70 +3624,70 @@
           </a:lstStyle>
           <a:p xmlns:a="http://schemas.openxmlformats.org/drawingml/2006/main">
             <a:pPr>
-              <a:defRPr sz="1500" b="0">
-                <a:solidFill>
-                  <a:srgbClr val="0D1B26"/>
-                </a:solidFill>
-              </a:defRPr>
-            </a:pPr>
-            <a:r>
-              <a:rPr sz="1500" b="0">
-                <a:solidFill>
-                  <a:srgbClr val="0D1B26"/>
-                </a:solidFill>
-              </a:rPr>
-              <a:t>• Bedrock API: không giữ GPU chạy 24/7</a:t>
-            </a:r>
-          </a:p>
-          <a:p xmlns:a="http://schemas.openxmlformats.org/drawingml/2006/main">
-            <a:pPr>
-              <a:defRPr sz="1500" b="0">
-                <a:solidFill>
-                  <a:srgbClr val="0D1B26"/>
-                </a:solidFill>
-              </a:defRPr>
-            </a:pPr>
-            <a:r>
-              <a:rPr sz="1500" b="0">
-                <a:solidFill>
-                  <a:srgbClr val="0D1B26"/>
-                </a:solidFill>
-              </a:rPr>
-              <a:t>• Nova Lite cho Cấp 1–3; Nova Pro cho Cấp 4–5</a:t>
-            </a:r>
-          </a:p>
-          <a:p xmlns:a="http://schemas.openxmlformats.org/drawingml/2006/main">
-            <a:pPr>
-              <a:defRPr sz="1500" b="0">
-                <a:solidFill>
-                  <a:srgbClr val="0D1B26"/>
-                </a:solidFill>
-              </a:defRPr>
-            </a:pPr>
-            <a:r>
-              <a:rPr sz="1500" b="0">
-                <a:solidFill>
-                  <a:srgbClr val="0D1B26"/>
-                </a:solidFill>
-              </a:rPr>
-              <a:t>• Fargate scale theo request; sandbox TTL 30s</a:t>
-            </a:r>
-          </a:p>
-          <a:p xmlns:a="http://schemas.openxmlformats.org/drawingml/2006/main">
-            <a:pPr>
-              <a:defRPr sz="1500" b="0">
-                <a:solidFill>
-                  <a:srgbClr val="0D1B26"/>
-                </a:solidFill>
-              </a:defRPr>
-            </a:pPr>
-            <a:r>
-              <a:rPr sz="1500" b="0">
-                <a:solidFill>
-                  <a:srgbClr val="0D1B26"/>
-                </a:solidFill>
-              </a:rPr>
-              <a:t>• S3 + pgvector trong Aurora để giảm dịch vụ riêng</a:t>
+              <a:defRPr sz="1350" b="0">
+                <a:solidFill>
+                  <a:srgbClr val="0D1B26"/>
+                </a:solidFill>
+              </a:defRPr>
+            </a:pPr>
+            <a:r>
+              <a:rPr sz="1350" b="0">
+                <a:solidFill>
+                  <a:srgbClr val="0D1B26"/>
+                </a:solidFill>
+              </a:rPr>
+              <a:t>• Bedrock API qua PrivateLink; không giữ GPU chạy 24/7</a:t>
+            </a:r>
+          </a:p>
+          <a:p xmlns:a="http://schemas.openxmlformats.org/drawingml/2006/main">
+            <a:pPr>
+              <a:defRPr sz="1350" b="0">
+                <a:solidFill>
+                  <a:srgbClr val="0D1B26"/>
+                </a:solidFill>
+              </a:defRPr>
+            </a:pPr>
+            <a:r>
+              <a:rPr sz="1350" b="0">
+                <a:solidFill>
+                  <a:srgbClr val="0D1B26"/>
+                </a:solidFill>
+              </a:rPr>
+              <a:t>• APAC Geo: Lite C1–3; Pro C4–5; agent steps C3=2, C4=3, C5=4</a:t>
+            </a:r>
+          </a:p>
+          <a:p xmlns:a="http://schemas.openxmlformats.org/drawingml/2006/main">
+            <a:pPr>
+              <a:defRPr sz="1350" b="0">
+                <a:solidFill>
+                  <a:srgbClr val="0D1B26"/>
+                </a:solidFill>
+              </a:defRPr>
+            </a:pPr>
+            <a:r>
+              <a:rPr sz="1350" b="0">
+                <a:solidFill>
+                  <a:srgbClr val="0D1B26"/>
+                </a:solidFill>
+              </a:rPr>
+              <a:t>• Titan Image G1 v2 không dùng: legacy/EOL; Nova sinh SVG/HTML render sandbox</a:t>
+            </a:r>
+          </a:p>
+          <a:p xmlns:a="http://schemas.openxmlformats.org/drawingml/2006/main">
+            <a:pPr>
+              <a:defRPr sz="1350" b="0">
+                <a:solidFill>
+                  <a:srgbClr val="0D1B26"/>
+                </a:solidFill>
+              </a:defRPr>
+            </a:pPr>
+            <a:r>
+              <a:rPr sz="1350" b="0">
+                <a:solidFill>
+                  <a:srgbClr val="0D1B26"/>
+                </a:solidFill>
+              </a:rPr>
+              <a:t>• Titan Embeddings V2 + S3 + pgvector trong Aurora</a:t>
             </a:r>
           </a:p>
         </p:txBody>
@@ -3697,7 +3697,7 @@
           <p:cNvPr id="13" name="">
             <a:extLst xmlns:a="http://schemas.openxmlformats.org/drawingml/2006/main">
               <a:ext uri="{FF2B5EF4-FFF2-40B4-BE49-F238E27FC236}">
-                <a16:creationId xmlns:a16="http://schemas.microsoft.com/office/drawing/2014/main" id="{66DB9AA9-3CEC-4C22-80C5-625356874C38}"/>
+                <a16:creationId xmlns:a16="http://schemas.microsoft.com/office/drawing/2014/main" id="{F4E31B59-3925-493C-9841-E8AC79A22C4A}"/>
               </a:ext>
             </a:extLst>
           </p:cNvPr>
@@ -3745,7 +3745,7 @@
                   <a:srgbClr val="B45309"/>
                 </a:solidFill>
               </a:rPr>
-              <a:t>TOTAL 11,674.74 USD/tháng · 5.84 USD/DAU/tháng</a:t>
+              <a:t>TOTAL 15,001.24 USD/tháng · 7.50 USD/DAU/tháng</a:t>
             </a:r>
           </a:p>
         </p:txBody>
@@ -3753,7 +3753,7 @@
     </p:spTree>
     <p:extLst>
       <p:ext uri="{BB962C8B-B14F-4D97-AF65-F5344CB8AC3E}">
-        <p14:creationId xmlns:p14="http://schemas.microsoft.com/office/powerpoint/2010/main" val="2007530874"/>
+        <p14:creationId xmlns:p14="http://schemas.microsoft.com/office/powerpoint/2010/main" val="1862336159"/>
       </p:ext>
     </p:extLst>
   </p:cSld>
@@ -3784,7 +3784,7 @@
           <p:cNvPr id="22" name="">
             <a:extLst xmlns:a="http://schemas.openxmlformats.org/drawingml/2006/main">
               <a:ext uri="{FF2B5EF4-FFF2-40B4-BE49-F238E27FC236}">
-                <a16:creationId xmlns:a16="http://schemas.microsoft.com/office/drawing/2014/main" id="{52202157-3B17-4DD7-B57A-05B371FCA978}"/>
+                <a16:creationId xmlns:a16="http://schemas.microsoft.com/office/drawing/2014/main" id="{42D63A21-D401-44D1-ABD9-494814BF10AA}"/>
               </a:ext>
             </a:extLst>
           </p:cNvPr>
@@ -3842,7 +3842,7 @@
           <p:cNvPr id="2" name="">
             <a:extLst xmlns:a="http://schemas.openxmlformats.org/drawingml/2006/main">
               <a:ext uri="{FF2B5EF4-FFF2-40B4-BE49-F238E27FC236}">
-                <a16:creationId xmlns:a16="http://schemas.microsoft.com/office/drawing/2014/main" id="{87238FE2-D2F9-455A-9F0D-96EEDCACEC45}"/>
+                <a16:creationId xmlns:a16="http://schemas.microsoft.com/office/drawing/2014/main" id="{322F76EE-5817-4559-BF50-38D07775A923}"/>
               </a:ext>
             </a:extLst>
           </p:cNvPr>
@@ -3900,7 +3900,7 @@
           <p:cNvPr id="3" name="">
             <a:extLst xmlns:a="http://schemas.openxmlformats.org/drawingml/2006/main">
               <a:ext uri="{FF2B5EF4-FFF2-40B4-BE49-F238E27FC236}">
-                <a16:creationId xmlns:a16="http://schemas.microsoft.com/office/drawing/2014/main" id="{DADE30F9-5B41-498A-A5F8-15AA2EFBDA54}"/>
+                <a16:creationId xmlns:a16="http://schemas.microsoft.com/office/drawing/2014/main" id="{E3FC589D-D6A5-445D-970F-2D95058C5478}"/>
               </a:ext>
             </a:extLst>
           </p:cNvPr>
@@ -3912,7 +3912,7 @@
         <p:spPr>
           <a:xfrm xmlns:a="http://schemas.openxmlformats.org/drawingml/2006/main">
             <a:off x="609600" y="1381125"/>
-            <a:ext cx="7239000" cy="266700"/>
+            <a:ext cx="10001250" cy="266700"/>
           </a:xfrm>
           <a:prstGeom xmlns:a="http://schemas.openxmlformats.org/drawingml/2006/main" prst="rect">
             <a:avLst/>
@@ -3927,7 +3927,7 @@
           <a:bodyPr xmlns:a="http://schemas.openxmlformats.org/drawingml/2006/main"/>
           <a:lstStyle xmlns:a="http://schemas.openxmlformats.org/drawingml/2006/main">
             <a:defPPr>
-              <a:defRPr sz="1425" b="0">
+              <a:defRPr sz="1350" b="0">
                 <a:solidFill>
                   <a:srgbClr val="4F6270"/>
                 </a:solidFill>
@@ -3936,19 +3936,19 @@
           </a:lstStyle>
           <a:p xmlns:a="http://schemas.openxmlformats.org/drawingml/2006/main">
             <a:pPr>
-              <a:defRPr sz="1425" b="0">
+              <a:defRPr sz="1350" b="0">
                 <a:solidFill>
                   <a:srgbClr val="4F6270"/>
                 </a:solidFill>
               </a:defRPr>
             </a:pPr>
             <a:r>
-              <a:rPr sz="1425" b="0">
+              <a:rPr sz="1350" b="0">
                 <a:solidFill>
                   <a:srgbClr val="4F6270"/>
                 </a:solidFill>
               </a:rPr>
-              <a:t>H1–H8 được gắn vào node, dữ liệu và guardrail</a:t>
+              <a:t>H1–H8 được gắn vào node, dữ liệu và guardrail; benchmark là gate trước production</a:t>
             </a:r>
           </a:p>
         </p:txBody>
@@ -3958,7 +3958,7 @@
           <p:cNvPr id="4" name="">
             <a:extLst xmlns:a="http://schemas.openxmlformats.org/drawingml/2006/main">
               <a:ext uri="{FF2B5EF4-FFF2-40B4-BE49-F238E27FC236}">
-                <a16:creationId xmlns:a16="http://schemas.microsoft.com/office/drawing/2014/main" id="{13F81BD4-1F4F-4BF0-8545-154D96C3370D}"/>
+                <a16:creationId xmlns:a16="http://schemas.microsoft.com/office/drawing/2014/main" id="{909E7E0C-71E2-4992-8B75-CDB6B8844A5D}"/>
               </a:ext>
             </a:extLst>
           </p:cNvPr>
@@ -4056,7 +4056,7 @@
           <p:cNvPr id="5" name="">
             <a:extLst xmlns:a="http://schemas.openxmlformats.org/drawingml/2006/main">
               <a:ext uri="{FF2B5EF4-FFF2-40B4-BE49-F238E27FC236}">
-                <a16:creationId xmlns:a16="http://schemas.microsoft.com/office/drawing/2014/main" id="{29AC5306-3C21-496F-8C13-5489E90A8CF5}"/>
+                <a16:creationId xmlns:a16="http://schemas.microsoft.com/office/drawing/2014/main" id="{DE99FBD2-EBD5-481C-A628-9C0A5C564642}"/>
               </a:ext>
             </a:extLst>
           </p:cNvPr>
@@ -4114,7 +4114,7 @@
           <p:cNvPr id="6" name="">
             <a:extLst xmlns:a="http://schemas.openxmlformats.org/drawingml/2006/main">
               <a:ext uri="{FF2B5EF4-FFF2-40B4-BE49-F238E27FC236}">
-                <a16:creationId xmlns:a16="http://schemas.microsoft.com/office/drawing/2014/main" id="{B4335148-B5D1-48DA-81D3-757DB10C5FF0}"/>
+                <a16:creationId xmlns:a16="http://schemas.microsoft.com/office/drawing/2014/main" id="{84001B4F-A802-4699-BCCB-CE965B466881}"/>
               </a:ext>
             </a:extLst>
           </p:cNvPr>
@@ -4195,7 +4195,7 @@
           <p:cNvPr id="7" name="">
             <a:extLst xmlns:a="http://schemas.openxmlformats.org/drawingml/2006/main">
               <a:ext uri="{FF2B5EF4-FFF2-40B4-BE49-F238E27FC236}">
-                <a16:creationId xmlns:a16="http://schemas.microsoft.com/office/drawing/2014/main" id="{7F3D0556-35E4-4B3E-ADF8-1161947D6953}"/>
+                <a16:creationId xmlns:a16="http://schemas.microsoft.com/office/drawing/2014/main" id="{B5018289-DB65-480F-B1D1-1F77D3CBC9D2}"/>
               </a:ext>
             </a:extLst>
           </p:cNvPr>
@@ -4253,7 +4253,7 @@
           <p:cNvPr id="8" name="">
             <a:extLst xmlns:a="http://schemas.openxmlformats.org/drawingml/2006/main">
               <a:ext uri="{FF2B5EF4-FFF2-40B4-BE49-F238E27FC236}">
-                <a16:creationId xmlns:a16="http://schemas.microsoft.com/office/drawing/2014/main" id="{17285832-069B-41F7-A7DE-CD70E82A3161}"/>
+                <a16:creationId xmlns:a16="http://schemas.microsoft.com/office/drawing/2014/main" id="{12D34371-0202-449A-8FC6-BE3C6750BA8C}"/>
               </a:ext>
             </a:extLst>
           </p:cNvPr>
@@ -4334,7 +4334,7 @@
           <p:cNvPr id="9" name="">
             <a:extLst xmlns:a="http://schemas.openxmlformats.org/drawingml/2006/main">
               <a:ext uri="{FF2B5EF4-FFF2-40B4-BE49-F238E27FC236}">
-                <a16:creationId xmlns:a16="http://schemas.microsoft.com/office/drawing/2014/main" id="{21807458-CCBE-4BDB-8B11-7A2C0C48F007}"/>
+                <a16:creationId xmlns:a16="http://schemas.microsoft.com/office/drawing/2014/main" id="{21F525F1-DA79-4F8C-AE73-8AAB0D92D40A}"/>
               </a:ext>
             </a:extLst>
           </p:cNvPr>
@@ -4392,7 +4392,7 @@
           <p:cNvPr id="10" name="">
             <a:extLst xmlns:a="http://schemas.openxmlformats.org/drawingml/2006/main">
               <a:ext uri="{FF2B5EF4-FFF2-40B4-BE49-F238E27FC236}">
-                <a16:creationId xmlns:a16="http://schemas.microsoft.com/office/drawing/2014/main" id="{E00F87FA-CE38-41D3-B964-0DF66C3213C3}"/>
+                <a16:creationId xmlns:a16="http://schemas.microsoft.com/office/drawing/2014/main" id="{A974E5E6-F477-478F-BDDF-7CD18BAB0B93}"/>
               </a:ext>
             </a:extLst>
           </p:cNvPr>
@@ -4425,7 +4425,7 @@
           <a:bodyPr xmlns:a="http://schemas.openxmlformats.org/drawingml/2006/main"/>
           <a:lstStyle xmlns:a="http://schemas.openxmlformats.org/drawingml/2006/main">
             <a:defPPr>
-              <a:defRPr sz="1350" b="1">
+              <a:defRPr sz="1275" b="1">
                 <a:solidFill>
                   <a:srgbClr val="0D1B26"/>
                 </a:solidFill>
@@ -4434,31 +4434,31 @@
           </a:lstStyle>
           <a:p xmlns:a="http://schemas.openxmlformats.org/drawingml/2006/main">
             <a:pPr>
-              <a:defRPr sz="1350" b="1">
-                <a:solidFill>
-                  <a:srgbClr val="0D1B26"/>
-                </a:solidFill>
-              </a:defRPr>
-            </a:pPr>
-            <a:r>
-              <a:rPr sz="1350" b="1">
-                <a:solidFill>
-                  <a:srgbClr val="0D1B26"/>
-                </a:solidFill>
-              </a:rPr>
-              <a:t>Bedrock</a:t>
-            </a:r>
-          </a:p>
-          <a:p xmlns:a="http://schemas.openxmlformats.org/drawingml/2006/main">
-            <a:pPr>
-              <a:defRPr sz="1350" b="1">
-                <a:solidFill>
-                  <a:srgbClr val="0D1B26"/>
-                </a:solidFill>
-              </a:defRPr>
-            </a:pPr>
-            <a:r>
-              <a:rPr sz="1350" b="1">
+              <a:defRPr sz="1275" b="1">
+                <a:solidFill>
+                  <a:srgbClr val="0D1B26"/>
+                </a:solidFill>
+              </a:defRPr>
+            </a:pPr>
+            <a:r>
+              <a:rPr sz="1275" b="1">
+                <a:solidFill>
+                  <a:srgbClr val="0D1B26"/>
+                </a:solidFill>
+              </a:rPr>
+              <a:t>Bedrock APAC Geo</a:t>
+            </a:r>
+          </a:p>
+          <a:p xmlns:a="http://schemas.openxmlformats.org/drawingml/2006/main">
+            <a:pPr>
+              <a:defRPr sz="1275" b="1">
+                <a:solidFill>
+                  <a:srgbClr val="0D1B26"/>
+                </a:solidFill>
+              </a:defRPr>
+            </a:pPr>
+            <a:r>
+              <a:rPr sz="1275" b="1">
                 <a:solidFill>
                   <a:srgbClr val="0D1B26"/>
                 </a:solidFill>
@@ -4473,7 +4473,7 @@
           <p:cNvPr id="11" name="">
             <a:extLst xmlns:a="http://schemas.openxmlformats.org/drawingml/2006/main">
               <a:ext uri="{FF2B5EF4-FFF2-40B4-BE49-F238E27FC236}">
-                <a16:creationId xmlns:a16="http://schemas.microsoft.com/office/drawing/2014/main" id="{D98BC42F-D7A7-4124-8AF5-24F3DE3F8BC2}"/>
+                <a16:creationId xmlns:a16="http://schemas.microsoft.com/office/drawing/2014/main" id="{6B839EE3-BC39-4758-A0B0-CD04C38B1F6B}"/>
               </a:ext>
             </a:extLst>
           </p:cNvPr>
@@ -4531,7 +4531,7 @@
           <p:cNvPr id="12" name="">
             <a:extLst xmlns:a="http://schemas.openxmlformats.org/drawingml/2006/main">
               <a:ext uri="{FF2B5EF4-FFF2-40B4-BE49-F238E27FC236}">
-                <a16:creationId xmlns:a16="http://schemas.microsoft.com/office/drawing/2014/main" id="{36D45901-932B-478F-9EA8-16C19E21056A}"/>
+                <a16:creationId xmlns:a16="http://schemas.microsoft.com/office/drawing/2014/main" id="{CA23A181-F109-4364-BC45-611E26B8F71D}"/>
               </a:ext>
             </a:extLst>
           </p:cNvPr>
@@ -4612,7 +4612,7 @@
           <p:cNvPr id="13" name="">
             <a:extLst xmlns:a="http://schemas.openxmlformats.org/drawingml/2006/main">
               <a:ext uri="{FF2B5EF4-FFF2-40B4-BE49-F238E27FC236}">
-                <a16:creationId xmlns:a16="http://schemas.microsoft.com/office/drawing/2014/main" id="{0ADBAB61-6974-4C4B-A8BB-B9C588BD2279}"/>
+                <a16:creationId xmlns:a16="http://schemas.microsoft.com/office/drawing/2014/main" id="{02B0528D-7BDB-4687-A794-EA0ADDFEC550}"/>
               </a:ext>
             </a:extLst>
           </p:cNvPr>
@@ -4710,7 +4710,7 @@
           <p:cNvPr id="14" name="">
             <a:extLst xmlns:a="http://schemas.openxmlformats.org/drawingml/2006/main">
               <a:ext uri="{FF2B5EF4-FFF2-40B4-BE49-F238E27FC236}">
-                <a16:creationId xmlns:a16="http://schemas.microsoft.com/office/drawing/2014/main" id="{BA1C9B6D-5133-42D8-ACEC-B856827C8D84}"/>
+                <a16:creationId xmlns:a16="http://schemas.microsoft.com/office/drawing/2014/main" id="{20FBB908-B19A-4B37-AD34-F15804618271}"/>
               </a:ext>
             </a:extLst>
           </p:cNvPr>
@@ -4808,7 +4808,7 @@
           <p:cNvPr id="15" name="">
             <a:extLst xmlns:a="http://schemas.openxmlformats.org/drawingml/2006/main">
               <a:ext uri="{FF2B5EF4-FFF2-40B4-BE49-F238E27FC236}">
-                <a16:creationId xmlns:a16="http://schemas.microsoft.com/office/drawing/2014/main" id="{8B2781F2-63FD-4101-B650-88E2E3D6584B}"/>
+                <a16:creationId xmlns:a16="http://schemas.microsoft.com/office/drawing/2014/main" id="{BB3AF825-8D93-4003-B2A3-6275B8B64746}"/>
               </a:ext>
             </a:extLst>
           </p:cNvPr>
@@ -4906,7 +4906,7 @@
           <p:cNvPr id="16" name="">
             <a:extLst xmlns:a="http://schemas.openxmlformats.org/drawingml/2006/main">
               <a:ext uri="{FF2B5EF4-FFF2-40B4-BE49-F238E27FC236}">
-                <a16:creationId xmlns:a16="http://schemas.microsoft.com/office/drawing/2014/main" id="{83A25A9A-6E99-4120-B114-5A9F4654B6FF}"/>
+                <a16:creationId xmlns:a16="http://schemas.microsoft.com/office/drawing/2014/main" id="{4F7B9538-2719-44CF-9C9A-DA5D407DC015}"/>
               </a:ext>
             </a:extLst>
           </p:cNvPr>
@@ -5004,7 +5004,7 @@
           <p:cNvPr id="17" name="">
             <a:extLst xmlns:a="http://schemas.openxmlformats.org/drawingml/2006/main">
               <a:ext uri="{FF2B5EF4-FFF2-40B4-BE49-F238E27FC236}">
-                <a16:creationId xmlns:a16="http://schemas.microsoft.com/office/drawing/2014/main" id="{6C923843-8159-4599-8DCD-B67D6116736E}"/>
+                <a16:creationId xmlns:a16="http://schemas.microsoft.com/office/drawing/2014/main" id="{FC9C4A7C-9D4B-45D7-92E8-1DB24904C4CF}"/>
               </a:ext>
             </a:extLst>
           </p:cNvPr>
@@ -5031,7 +5031,7 @@
           <a:bodyPr xmlns:a="http://schemas.openxmlformats.org/drawingml/2006/main"/>
           <a:lstStyle xmlns:a="http://schemas.openxmlformats.org/drawingml/2006/main">
             <a:defPPr>
-              <a:defRPr sz="1275" b="0">
+              <a:defRPr sz="1200" b="0">
                 <a:solidFill>
                   <a:srgbClr val="4F6270"/>
                 </a:solidFill>
@@ -5040,19 +5040,19 @@
           </a:lstStyle>
           <a:p xmlns:a="http://schemas.openxmlformats.org/drawingml/2006/main">
             <a:pPr>
-              <a:defRPr sz="1275" b="0">
+              <a:defRPr sz="1200" b="0">
                 <a:solidFill>
                   <a:srgbClr val="4F6270"/>
                 </a:solidFill>
               </a:defRPr>
             </a:pPr>
             <a:r>
-              <a:rPr sz="1275" b="0">
+              <a:rPr sz="1200" b="0">
                 <a:solidFill>
                   <a:srgbClr val="4F6270"/>
                 </a:solidFill>
               </a:rPr>
-              <a:t>Fargate app gọi dữ liệu theo ACL; sandbox trả result; user xác nhận hành động ghi</a:t>
+              <a:t>PrivateLink giữ entry point ở Singapore; APAC Geo có thể xử lý ở destination APAC; sandbox trả result; user xác nhận hành động ghi</a:t>
             </a:r>
           </a:p>
         </p:txBody>
@@ -5062,7 +5062,7 @@
           <p:cNvPr id="18" name="">
             <a:extLst xmlns:a="http://schemas.openxmlformats.org/drawingml/2006/main">
               <a:ext uri="{FF2B5EF4-FFF2-40B4-BE49-F238E27FC236}">
-                <a16:creationId xmlns:a16="http://schemas.microsoft.com/office/drawing/2014/main" id="{1B41B212-6892-4DFD-BE52-3D882F3C680A}"/>
+                <a16:creationId xmlns:a16="http://schemas.microsoft.com/office/drawing/2014/main" id="{1778ECA3-0EA5-499E-B947-D325F0A87D7A}"/>
               </a:ext>
             </a:extLst>
           </p:cNvPr>
@@ -5120,7 +5120,7 @@
           <p:cNvPr id="19" name="">
             <a:extLst xmlns:a="http://schemas.openxmlformats.org/drawingml/2006/main">
               <a:ext uri="{FF2B5EF4-FFF2-40B4-BE49-F238E27FC236}">
-                <a16:creationId xmlns:a16="http://schemas.microsoft.com/office/drawing/2014/main" id="{487129EF-3D8C-4D10-A0B8-E9D4B39F4940}"/>
+                <a16:creationId xmlns:a16="http://schemas.microsoft.com/office/drawing/2014/main" id="{7342CACE-79DB-44EA-B7BA-B0A525CE6BCC}"/>
               </a:ext>
             </a:extLst>
           </p:cNvPr>
@@ -5178,7 +5178,7 @@
           <p:cNvPr id="20" name="">
             <a:extLst xmlns:a="http://schemas.openxmlformats.org/drawingml/2006/main">
               <a:ext uri="{FF2B5EF4-FFF2-40B4-BE49-F238E27FC236}">
-                <a16:creationId xmlns:a16="http://schemas.microsoft.com/office/drawing/2014/main" id="{8F30C02F-C458-4170-BF31-2D46412CE83C}"/>
+                <a16:creationId xmlns:a16="http://schemas.microsoft.com/office/drawing/2014/main" id="{C9FA82DC-3331-48D6-BC8D-48CE2959D2F3}"/>
               </a:ext>
             </a:extLst>
           </p:cNvPr>
@@ -5236,7 +5236,7 @@
           <p:cNvPr id="21" name="">
             <a:extLst xmlns:a="http://schemas.openxmlformats.org/drawingml/2006/main">
               <a:ext uri="{FF2B5EF4-FFF2-40B4-BE49-F238E27FC236}">
-                <a16:creationId xmlns:a16="http://schemas.microsoft.com/office/drawing/2014/main" id="{0FF54897-9BD6-4A40-B1BE-F1839526A3BA}"/>
+                <a16:creationId xmlns:a16="http://schemas.microsoft.com/office/drawing/2014/main" id="{3C7F1059-161C-4DBF-8611-40FC475E7963}"/>
               </a:ext>
             </a:extLst>
           </p:cNvPr>
@@ -5263,7 +5263,7 @@
           <a:bodyPr xmlns:a="http://schemas.openxmlformats.org/drawingml/2006/main"/>
           <a:lstStyle xmlns:a="http://schemas.openxmlformats.org/drawingml/2006/main">
             <a:defPPr>
-              <a:defRPr sz="1200" b="0">
+              <a:defRPr sz="1125" b="0">
                 <a:solidFill>
                   <a:srgbClr val="0D1B26"/>
                 </a:solidFill>
@@ -5272,19 +5272,19 @@
           </a:lstStyle>
           <a:p xmlns:a="http://schemas.openxmlformats.org/drawingml/2006/main">
             <a:pPr>
-              <a:defRPr sz="1200" b="0">
-                <a:solidFill>
-                  <a:srgbClr val="0D1B26"/>
-                </a:solidFill>
-              </a:defRPr>
-            </a:pPr>
-            <a:r>
-              <a:rPr sz="1200" b="0">
-                <a:solidFill>
-                  <a:srgbClr val="0D1B26"/>
-                </a:solidFill>
-              </a:rPr>
-              <a:t>DLP · audit 12 tháng · multi-AZ · backup RPO 1h · quota và eval gate</a:t>
+              <a:defRPr sz="1125" b="0">
+                <a:solidFill>
+                  <a:srgbClr val="0D1B26"/>
+                </a:solidFill>
+              </a:defRPr>
+            </a:pPr>
+            <a:r>
+              <a:rPr sz="1125" b="0">
+                <a:solidFill>
+                  <a:srgbClr val="0D1B26"/>
+                </a:solidFill>
+              </a:rPr>
+              <a:t>DLP · audit 12 tháng · multi-AZ · backup RPO 1h · golden set 100 mẫu</a:t>
             </a:r>
           </a:p>
         </p:txBody>
@@ -5292,7 +5292,7 @@
     </p:spTree>
     <p:extLst>
       <p:ext uri="{BB962C8B-B14F-4D97-AF65-F5344CB8AC3E}">
-        <p14:creationId xmlns:p14="http://schemas.microsoft.com/office/powerpoint/2010/main" val="1733736930"/>
+        <p14:creationId xmlns:p14="http://schemas.microsoft.com/office/powerpoint/2010/main" val="1430662196"/>
       </p:ext>
     </p:extLst>
   </p:cSld>

</xml_diff>

<commit_message>
refactor: separate model calls from requests
</commit_message>
<xml_diff>
--- a/G03_slide.pptx
+++ b/G03_slide.pptx
@@ -2,14 +2,14 @@
 <file path=ppt/presentation.xml><?xml version="1.0" encoding="utf-8"?>
 <p:presentation xmlns:p="http://schemas.openxmlformats.org/presentationml/2006/main">
   <p:sldMasterIdLst>
-    <p:sldMasterId xmlns:r="http://schemas.openxmlformats.org/officeDocument/2006/relationships" id="2147483648" r:id="R146dcbcbe65d4986"/>
+    <p:sldMasterId xmlns:r="http://schemas.openxmlformats.org/officeDocument/2006/relationships" id="2147483648" r:id="R1b7dfcc7499a48ea"/>
   </p:sldMasterIdLst>
   <p:notesMasterIdLst>
-    <p:notesMasterId xmlns:r="http://schemas.openxmlformats.org/officeDocument/2006/relationships" r:id="Rf31ed27a2fae4ae4"/>
+    <p:notesMasterId xmlns:r="http://schemas.openxmlformats.org/officeDocument/2006/relationships" r:id="Rd7c3b2caacbe4eca"/>
   </p:notesMasterIdLst>
   <p:sldIdLst>
-    <p:sldId xmlns:r="http://schemas.openxmlformats.org/officeDocument/2006/relationships" id="256" r:id="R77e8c457ac384b29"/>
-    <p:sldId xmlns:r="http://schemas.openxmlformats.org/officeDocument/2006/relationships" id="257" r:id="Rf85a221e7cb246c1"/>
+    <p:sldId xmlns:r="http://schemas.openxmlformats.org/officeDocument/2006/relationships" id="256" r:id="Rff89b8584e504031"/>
+    <p:sldId xmlns:r="http://schemas.openxmlformats.org/officeDocument/2006/relationships" id="257" r:id="R89b12d72c527478c"/>
   </p:sldIdLst>
   <p:sldSz cx="12192000" cy="6858000"/>
   <p:notesSz cx="6858000" cy="9144000"/>
@@ -552,7 +552,7 @@
           <p:cNvPr id="3" name="Title">
             <a:extLst xmlns:a="http://schemas.openxmlformats.org/drawingml/2006/main">
               <a:ext uri="{FF2B5EF4-FFF2-40B4-BE49-F238E27FC236}">
-                <a16:creationId xmlns:a16="http://schemas.microsoft.com/office/drawing/2014/main" id="{36CF4E87-FD27-44D5-BCC7-6DC170464891}"/>
+                <a16:creationId xmlns:a16="http://schemas.microsoft.com/office/drawing/2014/main" id="{FDAFB45F-FCEF-48A2-A89C-58729212FFE9}"/>
               </a:ext>
             </a:extLst>
           </p:cNvPr>
@@ -709,7 +709,7 @@
           <p:cNvPr id="2" name="Subtitle">
             <a:extLst xmlns:a="http://schemas.openxmlformats.org/drawingml/2006/main">
               <a:ext uri="{FF2B5EF4-FFF2-40B4-BE49-F238E27FC236}">
-                <a16:creationId xmlns:a16="http://schemas.microsoft.com/office/drawing/2014/main" id="{743AB708-CB94-4F4D-9094-E8D4D54FDD9D}"/>
+                <a16:creationId xmlns:a16="http://schemas.microsoft.com/office/drawing/2014/main" id="{726DE389-1F1C-4774-8CF3-0CA45283179B}"/>
               </a:ext>
             </a:extLst>
           </p:cNvPr>
@@ -883,7 +883,7 @@
           <p:cNvPr id="2" name="Section title">
             <a:extLst xmlns:a="http://schemas.openxmlformats.org/drawingml/2006/main">
               <a:ext uri="{FF2B5EF4-FFF2-40B4-BE49-F238E27FC236}">
-                <a16:creationId xmlns:a16="http://schemas.microsoft.com/office/drawing/2014/main" id="{23020810-0C64-4F89-9FAA-905B5982B4C2}"/>
+                <a16:creationId xmlns:a16="http://schemas.microsoft.com/office/drawing/2014/main" id="{CB10E169-7045-45CB-B15A-DF76A9E09E1C}"/>
               </a:ext>
             </a:extLst>
           </p:cNvPr>
@@ -1057,7 +1057,7 @@
           <p:cNvPr id="3" name="Title">
             <a:extLst xmlns:a="http://schemas.openxmlformats.org/drawingml/2006/main">
               <a:ext uri="{FF2B5EF4-FFF2-40B4-BE49-F238E27FC236}">
-                <a16:creationId xmlns:a16="http://schemas.microsoft.com/office/drawing/2014/main" id="{0F3E0C1B-E5CC-4595-9591-72470FDA0339}"/>
+                <a16:creationId xmlns:a16="http://schemas.microsoft.com/office/drawing/2014/main" id="{59B1CBA3-8DA3-499E-B727-7A3A459E7545}"/>
               </a:ext>
             </a:extLst>
           </p:cNvPr>
@@ -1214,7 +1214,7 @@
           <p:cNvPr id="2" name="Body">
             <a:extLst xmlns:a="http://schemas.openxmlformats.org/drawingml/2006/main">
               <a:ext uri="{FF2B5EF4-FFF2-40B4-BE49-F238E27FC236}">
-                <a16:creationId xmlns:a16="http://schemas.microsoft.com/office/drawing/2014/main" id="{AFA23D25-E0C1-409B-9039-55D962A80E4E}"/>
+                <a16:creationId xmlns:a16="http://schemas.microsoft.com/office/drawing/2014/main" id="{8BE799CE-9376-4507-B2E2-7EB0E57FFDDC}"/>
               </a:ext>
             </a:extLst>
           </p:cNvPr>
@@ -1388,7 +1388,7 @@
           <p:cNvPr id="4" name="Title">
             <a:extLst xmlns:a="http://schemas.openxmlformats.org/drawingml/2006/main">
               <a:ext uri="{FF2B5EF4-FFF2-40B4-BE49-F238E27FC236}">
-                <a16:creationId xmlns:a16="http://schemas.microsoft.com/office/drawing/2014/main" id="{24258F05-AADD-4CA8-B633-CF55E1B39504}"/>
+                <a16:creationId xmlns:a16="http://schemas.microsoft.com/office/drawing/2014/main" id="{8BB183EB-0C9A-4B9A-A5BD-770B25F72E08}"/>
               </a:ext>
             </a:extLst>
           </p:cNvPr>
@@ -1545,7 +1545,7 @@
           <p:cNvPr id="2" name="Left column">
             <a:extLst xmlns:a="http://schemas.openxmlformats.org/drawingml/2006/main">
               <a:ext uri="{FF2B5EF4-FFF2-40B4-BE49-F238E27FC236}">
-                <a16:creationId xmlns:a16="http://schemas.microsoft.com/office/drawing/2014/main" id="{F98B85E6-FA4F-49B8-A511-97E7A5190418}"/>
+                <a16:creationId xmlns:a16="http://schemas.microsoft.com/office/drawing/2014/main" id="{C1BA1992-813C-4B15-8305-C4CB682D84C5}"/>
               </a:ext>
             </a:extLst>
           </p:cNvPr>
@@ -1702,7 +1702,7 @@
           <p:cNvPr id="3" name="Right column">
             <a:extLst xmlns:a="http://schemas.openxmlformats.org/drawingml/2006/main">
               <a:ext uri="{FF2B5EF4-FFF2-40B4-BE49-F238E27FC236}">
-                <a16:creationId xmlns:a16="http://schemas.microsoft.com/office/drawing/2014/main" id="{37378C09-17FB-4DB0-9381-F1CD7174911A}"/>
+                <a16:creationId xmlns:a16="http://schemas.microsoft.com/office/drawing/2014/main" id="{B0D66F67-6B64-4DE6-8A6A-87B8E4F9F634}"/>
               </a:ext>
             </a:extLst>
           </p:cNvPr>
@@ -1876,7 +1876,7 @@
           <p:cNvPr id="3" name="Title">
             <a:extLst xmlns:a="http://schemas.openxmlformats.org/drawingml/2006/main">
               <a:ext uri="{FF2B5EF4-FFF2-40B4-BE49-F238E27FC236}">
-                <a16:creationId xmlns:a16="http://schemas.microsoft.com/office/drawing/2014/main" id="{33BD5826-27FA-4C7D-8DBD-011812D548B3}"/>
+                <a16:creationId xmlns:a16="http://schemas.microsoft.com/office/drawing/2014/main" id="{2C849459-8D97-43EC-ACF3-1B512D125350}"/>
               </a:ext>
             </a:extLst>
           </p:cNvPr>
@@ -2033,7 +2033,7 @@
           <p:cNvPr id="2" name="Left column">
             <a:extLst xmlns:a="http://schemas.openxmlformats.org/drawingml/2006/main">
               <a:ext uri="{FF2B5EF4-FFF2-40B4-BE49-F238E27FC236}">
-                <a16:creationId xmlns:a16="http://schemas.microsoft.com/office/drawing/2014/main" id="{9A0C3138-993B-4008-A8E5-D6E5669D689F}"/>
+                <a16:creationId xmlns:a16="http://schemas.microsoft.com/office/drawing/2014/main" id="{8639581F-4FA7-4D42-BAEC-D76CAD71A601}"/>
               </a:ext>
             </a:extLst>
           </p:cNvPr>
@@ -2228,12 +2228,12 @@
   </p:cSld>
   <p:clrMap bg1="lt1" tx1="dk1" bg2="lt2" tx2="dk2" accent1="accent1" accent2="accent2" accent3="accent3" accent4="accent4" accent5="accent5" accent6="accent6" hlink="hlink" folHlink="folHlink"/>
   <p:sldLayoutIdLst>
-    <p:sldLayoutId xmlns:r="http://schemas.openxmlformats.org/officeDocument/2006/relationships" id="2147483649" r:id="R83dd212d813548a8"/>
-    <p:sldLayoutId xmlns:r="http://schemas.openxmlformats.org/officeDocument/2006/relationships" id="2147483650" r:id="R7eb8ac48aeda4bef"/>
-    <p:sldLayoutId xmlns:r="http://schemas.openxmlformats.org/officeDocument/2006/relationships" id="2147483651" r:id="Ra17e80568a514106"/>
-    <p:sldLayoutId xmlns:r="http://schemas.openxmlformats.org/officeDocument/2006/relationships" id="2147483652" r:id="R5633715b3d624449"/>
-    <p:sldLayoutId xmlns:r="http://schemas.openxmlformats.org/officeDocument/2006/relationships" id="2147483653" r:id="Rf7ce13f67abb462e"/>
-    <p:sldLayoutId xmlns:r="http://schemas.openxmlformats.org/officeDocument/2006/relationships" id="2147483654" r:id="R60fe6dea5e554f8c"/>
+    <p:sldLayoutId xmlns:r="http://schemas.openxmlformats.org/officeDocument/2006/relationships" id="2147483649" r:id="R792e5c3eb7874f61"/>
+    <p:sldLayoutId xmlns:r="http://schemas.openxmlformats.org/officeDocument/2006/relationships" id="2147483650" r:id="Ra571631729744285"/>
+    <p:sldLayoutId xmlns:r="http://schemas.openxmlformats.org/officeDocument/2006/relationships" id="2147483651" r:id="R16a822e6a8444617"/>
+    <p:sldLayoutId xmlns:r="http://schemas.openxmlformats.org/officeDocument/2006/relationships" id="2147483652" r:id="Rfe1b3070bc784617"/>
+    <p:sldLayoutId xmlns:r="http://schemas.openxmlformats.org/officeDocument/2006/relationships" id="2147483653" r:id="R3afd3899cad041b8"/>
+    <p:sldLayoutId xmlns:r="http://schemas.openxmlformats.org/officeDocument/2006/relationships" id="2147483654" r:id="R51e55eeb1bcf4787"/>
   </p:sldLayoutIdLst>
   <p:txStyles>
     <p:titleStyle>
@@ -2784,7 +2784,7 @@
           <p:cNvPr id="14" name="">
             <a:extLst xmlns:a="http://schemas.openxmlformats.org/drawingml/2006/main">
               <a:ext uri="{FF2B5EF4-FFF2-40B4-BE49-F238E27FC236}">
-                <a16:creationId xmlns:a16="http://schemas.microsoft.com/office/drawing/2014/main" id="{D8146625-4FA7-4DF3-8652-9B4B8232F521}"/>
+                <a16:creationId xmlns:a16="http://schemas.microsoft.com/office/drawing/2014/main" id="{08A52AF9-B26A-44BE-8511-553C6282D2C0}"/>
               </a:ext>
             </a:extLst>
           </p:cNvPr>
@@ -2842,7 +2842,7 @@
           <p:cNvPr id="2" name="">
             <a:extLst xmlns:a="http://schemas.openxmlformats.org/drawingml/2006/main">
               <a:ext uri="{FF2B5EF4-FFF2-40B4-BE49-F238E27FC236}">
-                <a16:creationId xmlns:a16="http://schemas.microsoft.com/office/drawing/2014/main" id="{575A355F-D763-4A64-B316-051A260EE339}"/>
+                <a16:creationId xmlns:a16="http://schemas.microsoft.com/office/drawing/2014/main" id="{F5D990E1-0646-4493-96D8-828E565029A6}"/>
               </a:ext>
             </a:extLst>
           </p:cNvPr>
@@ -2900,7 +2900,7 @@
           <p:cNvPr id="3" name="">
             <a:extLst xmlns:a="http://schemas.openxmlformats.org/drawingml/2006/main">
               <a:ext uri="{FF2B5EF4-FFF2-40B4-BE49-F238E27FC236}">
-                <a16:creationId xmlns:a16="http://schemas.microsoft.com/office/drawing/2014/main" id="{C3AF6852-A669-401B-B623-84BBDE793A74}"/>
+                <a16:creationId xmlns:a16="http://schemas.microsoft.com/office/drawing/2014/main" id="{1BD449E8-8E86-4CD2-91E1-D4C019AB4A6A}"/>
               </a:ext>
             </a:extLst>
           </p:cNvPr>
@@ -2958,7 +2958,7 @@
           <p:cNvPr id="4" name="">
             <a:extLst xmlns:a="http://schemas.openxmlformats.org/drawingml/2006/main">
               <a:ext uri="{FF2B5EF4-FFF2-40B4-BE49-F238E27FC236}">
-                <a16:creationId xmlns:a16="http://schemas.microsoft.com/office/drawing/2014/main" id="{3B2A3AA1-93D0-43C8-AA0B-C3E486068C4A}"/>
+                <a16:creationId xmlns:a16="http://schemas.microsoft.com/office/drawing/2014/main" id="{A2D204A9-1014-467E-93B2-96D146BDA938}"/>
               </a:ext>
             </a:extLst>
           </p:cNvPr>
@@ -3039,7 +3039,7 @@
           <p:cNvPr id="5" name="">
             <a:extLst xmlns:a="http://schemas.openxmlformats.org/drawingml/2006/main">
               <a:ext uri="{FF2B5EF4-FFF2-40B4-BE49-F238E27FC236}">
-                <a16:creationId xmlns:a16="http://schemas.microsoft.com/office/drawing/2014/main" id="{E454DFEC-5BD0-4961-9601-7C80B27BBD27}"/>
+                <a16:creationId xmlns:a16="http://schemas.microsoft.com/office/drawing/2014/main" id="{57FB5C9B-F7BD-4EEC-A241-1F5C1CC4E1CA}"/>
               </a:ext>
             </a:extLst>
           </p:cNvPr>
@@ -3093,7 +3093,7 @@
                   <a:srgbClr val="0D1B26"/>
                 </a:solidFill>
               </a:rPr>
-              <a:t>6.688B input</a:t>
+              <a:t>9.636B input</a:t>
             </a:r>
           </a:p>
           <a:p xmlns:a="http://schemas.openxmlformats.org/drawingml/2006/main">
@@ -3110,7 +3110,7 @@
                   <a:srgbClr val="0D1B26"/>
                 </a:solidFill>
               </a:rPr>
-              <a:t>0.986B output token</a:t>
+              <a:t>1.452B output token</a:t>
             </a:r>
           </a:p>
         </p:txBody>
@@ -3120,7 +3120,7 @@
           <p:cNvPr id="6" name="">
             <a:extLst xmlns:a="http://schemas.openxmlformats.org/drawingml/2006/main">
               <a:ext uri="{FF2B5EF4-FFF2-40B4-BE49-F238E27FC236}">
-                <a16:creationId xmlns:a16="http://schemas.microsoft.com/office/drawing/2014/main" id="{86FD8513-386C-43EB-893A-E5D1384AC507}"/>
+                <a16:creationId xmlns:a16="http://schemas.microsoft.com/office/drawing/2014/main" id="{2DBC8247-E74A-443F-B09A-AA0E886099F5}"/>
               </a:ext>
             </a:extLst>
           </p:cNvPr>
@@ -3201,7 +3201,7 @@
           <p:cNvPr id="7" name="">
             <a:extLst xmlns:a="http://schemas.openxmlformats.org/drawingml/2006/main">
               <a:ext uri="{FF2B5EF4-FFF2-40B4-BE49-F238E27FC236}">
-                <a16:creationId xmlns:a16="http://schemas.microsoft.com/office/drawing/2014/main" id="{D372E7F1-1A7B-4C23-AC2B-81BA262ECA95}"/>
+                <a16:creationId xmlns:a16="http://schemas.microsoft.com/office/drawing/2014/main" id="{B543120B-50F2-4D25-94F1-5DC35875456A}"/>
               </a:ext>
             </a:extLst>
           </p:cNvPr>
@@ -3255,7 +3255,7 @@
                   <a:srgbClr val="0D1B26"/>
                 </a:solidFill>
               </a:rPr>
-              <a:t>3,333 task-h</a:t>
+              <a:t>6,667 billable</a:t>
             </a:r>
           </a:p>
           <a:p xmlns:a="http://schemas.openxmlformats.org/drawingml/2006/main">
@@ -3272,7 +3272,7 @@
                   <a:srgbClr val="0D1B26"/>
                 </a:solidFill>
               </a:rPr>
-              <a:t>sandbox/tháng</a:t>
+              <a:t>task-h/tháng</a:t>
             </a:r>
           </a:p>
         </p:txBody>
@@ -3282,7 +3282,7 @@
           <p:cNvPr id="8" name="">
             <a:extLst xmlns:a="http://schemas.openxmlformats.org/drawingml/2006/main">
               <a:ext uri="{FF2B5EF4-FFF2-40B4-BE49-F238E27FC236}">
-                <a16:creationId xmlns:a16="http://schemas.microsoft.com/office/drawing/2014/main" id="{AD438042-97E5-44F1-9E7F-F36FC90C52AC}"/>
+                <a16:creationId xmlns:a16="http://schemas.microsoft.com/office/drawing/2014/main" id="{E6196011-A2F4-404C-AE99-36ACDB0D13ED}"/>
               </a:ext>
             </a:extLst>
           </p:cNvPr>
@@ -3363,7 +3363,7 @@
           <p:cNvPr id="9" name="">
             <a:extLst xmlns:a="http://schemas.openxmlformats.org/drawingml/2006/main">
               <a:ext uri="{FF2B5EF4-FFF2-40B4-BE49-F238E27FC236}">
-                <a16:creationId xmlns:a16="http://schemas.microsoft.com/office/drawing/2014/main" id="{B73BEEF2-5E45-4D62-B750-C69F5C71099E}"/>
+                <a16:creationId xmlns:a16="http://schemas.microsoft.com/office/drawing/2014/main" id="{27C75DF6-C5FA-45E5-8672-9851D40DF217}"/>
               </a:ext>
             </a:extLst>
           </p:cNvPr>
@@ -3421,7 +3421,7 @@
           <p:cNvPr id="10" name="">
             <a:extLst xmlns:a="http://schemas.openxmlformats.org/drawingml/2006/main">
               <a:ext uri="{FF2B5EF4-FFF2-40B4-BE49-F238E27FC236}">
-                <a16:creationId xmlns:a16="http://schemas.microsoft.com/office/drawing/2014/main" id="{4600CFE5-B552-4DD5-AF3E-0617D11F4F26}"/>
+                <a16:creationId xmlns:a16="http://schemas.microsoft.com/office/drawing/2014/main" id="{11681458-FF01-4A2B-92DC-9E17EC158EEE}"/>
               </a:ext>
             </a:extLst>
           </p:cNvPr>
@@ -3433,7 +3433,7 @@
         <p:spPr>
           <a:xfrm xmlns:a="http://schemas.openxmlformats.org/drawingml/2006/main">
             <a:off x="609600" y="4171950"/>
-            <a:ext cx="5334000" cy="1428750"/>
+            <a:ext cx="5334000" cy="1714500"/>
           </a:xfrm>
           <a:prstGeom xmlns:a="http://schemas.openxmlformats.org/drawingml/2006/main" prst="rect">
             <a:avLst/>
@@ -3448,7 +3448,7 @@
           <a:bodyPr xmlns:a="http://schemas.openxmlformats.org/drawingml/2006/main"/>
           <a:lstStyle xmlns:a="http://schemas.openxmlformats.org/drawingml/2006/main">
             <a:defPPr>
-              <a:defRPr sz="1500" b="0">
+              <a:defRPr sz="1350" b="0">
                 <a:solidFill>
                   <a:srgbClr val="0D1B26"/>
                 </a:solidFill>
@@ -3457,14 +3457,14 @@
           </a:lstStyle>
           <a:p xmlns:a="http://schemas.openxmlformats.org/drawingml/2006/main">
             <a:pPr>
-              <a:defRPr sz="1500" b="0">
-                <a:solidFill>
-                  <a:srgbClr val="0D1B26"/>
-                </a:solidFill>
-              </a:defRPr>
-            </a:pPr>
-            <a:r>
-              <a:rPr sz="1500" b="0">
+              <a:defRPr sz="1350" b="0">
+                <a:solidFill>
+                  <a:srgbClr val="0D1B26"/>
+                </a:solidFill>
+              </a:defRPr>
+            </a:pPr>
+            <a:r>
+              <a:rPr sz="1350" b="0">
                 <a:solidFill>
                   <a:srgbClr val="0D1B26"/>
                 </a:solidFill>
@@ -3474,14 +3474,14 @@
           </a:p>
           <a:p xmlns:a="http://schemas.openxmlformats.org/drawingml/2006/main">
             <a:pPr>
-              <a:defRPr sz="1500" b="0">
-                <a:solidFill>
-                  <a:srgbClr val="0D1B26"/>
-                </a:solidFill>
-              </a:defRPr>
-            </a:pPr>
-            <a:r>
-              <a:rPr sz="1500" b="0">
+              <a:defRPr sz="1350" b="0">
+                <a:solidFill>
+                  <a:srgbClr val="0D1B26"/>
+                </a:solidFill>
+              </a:defRPr>
+            </a:pPr>
+            <a:r>
+              <a:rPr sz="1350" b="0">
                 <a:solidFill>
                   <a:srgbClr val="0D1B26"/>
                 </a:solidFill>
@@ -3491,31 +3491,48 @@
           </a:p>
           <a:p xmlns:a="http://schemas.openxmlformats.org/drawingml/2006/main">
             <a:pPr>
-              <a:defRPr sz="1500" b="0">
-                <a:solidFill>
-                  <a:srgbClr val="0D1B26"/>
-                </a:solidFill>
-              </a:defRPr>
-            </a:pPr>
-            <a:r>
-              <a:rPr sz="1500" b="0">
-                <a:solidFill>
-                  <a:srgbClr val="0D1B26"/>
-                </a:solidFill>
-              </a:rPr>
-              <a:t>400,000 × 30s ÷ 3,600 = 3,333 task-hours</a:t>
-            </a:r>
-          </a:p>
-          <a:p xmlns:a="http://schemas.openxmlformats.org/drawingml/2006/main">
-            <a:pPr>
-              <a:defRPr sz="1500" b="0">
-                <a:solidFill>
-                  <a:srgbClr val="0D1B26"/>
-                </a:solidFill>
-              </a:defRPr>
-            </a:pPr>
-            <a:r>
-              <a:rPr sz="1500" b="0">
+              <a:defRPr sz="1350" b="0">
+                <a:solidFill>
+                  <a:srgbClr val="0D1B26"/>
+                </a:solidFill>
+              </a:defRPr>
+            </a:pPr>
+            <a:r>
+              <a:rPr sz="1350" b="0">
+                <a:solidFill>
+                  <a:srgbClr val="0D1B26"/>
+                </a:solidFill>
+              </a:rPr>
+              <a:t>2.376M model calls; 9.636B input + 1.452B output token</a:t>
+            </a:r>
+          </a:p>
+          <a:p xmlns:a="http://schemas.openxmlformats.org/drawingml/2006/main">
+            <a:pPr>
+              <a:defRPr sz="1350" b="0">
+                <a:solidFill>
+                  <a:srgbClr val="0D1B26"/>
+                </a:solidFill>
+              </a:defRPr>
+            </a:pPr>
+            <a:r>
+              <a:rPr sz="1350" b="0">
+                <a:solidFill>
+                  <a:srgbClr val="0D1B26"/>
+                </a:solidFill>
+              </a:rPr>
+              <a:t>400,000 × minimum 60s ÷ 3,600 = 6,667 billable task-hours</a:t>
+            </a:r>
+          </a:p>
+          <a:p xmlns:a="http://schemas.openxmlformats.org/drawingml/2006/main">
+            <a:pPr>
+              <a:defRPr sz="1350" b="0">
+                <a:solidFill>
+                  <a:srgbClr val="0D1B26"/>
+                </a:solidFill>
+              </a:defRPr>
+            </a:pPr>
+            <a:r>
+              <a:rPr sz="1350" b="0">
                 <a:solidFill>
                   <a:srgbClr val="0D1B26"/>
                 </a:solidFill>
@@ -3530,7 +3547,7 @@
           <p:cNvPr id="11" name="">
             <a:extLst xmlns:a="http://schemas.openxmlformats.org/drawingml/2006/main">
               <a:ext uri="{FF2B5EF4-FFF2-40B4-BE49-F238E27FC236}">
-                <a16:creationId xmlns:a16="http://schemas.microsoft.com/office/drawing/2014/main" id="{793B9935-B9CF-4958-9D65-0A63FFE4EF2E}"/>
+                <a16:creationId xmlns:a16="http://schemas.microsoft.com/office/drawing/2014/main" id="{E99347F7-CCDC-455F-B460-4DAC7C569152}"/>
               </a:ext>
             </a:extLst>
           </p:cNvPr>
@@ -3588,7 +3605,7 @@
           <p:cNvPr id="12" name="">
             <a:extLst xmlns:a="http://schemas.openxmlformats.org/drawingml/2006/main">
               <a:ext uri="{FF2B5EF4-FFF2-40B4-BE49-F238E27FC236}">
-                <a16:creationId xmlns:a16="http://schemas.microsoft.com/office/drawing/2014/main" id="{EE653B82-2149-4B5E-AD4D-C926995568D2}"/>
+                <a16:creationId xmlns:a16="http://schemas.microsoft.com/office/drawing/2014/main" id="{D9AAA766-BC06-42EC-950B-A22E20A349D4}"/>
               </a:ext>
             </a:extLst>
           </p:cNvPr>
@@ -3600,7 +3617,7 @@
         <p:spPr>
           <a:xfrm xmlns:a="http://schemas.openxmlformats.org/drawingml/2006/main">
             <a:off x="6667500" y="4171950"/>
-            <a:ext cx="4857750" cy="1714500"/>
+            <a:ext cx="4857750" cy="1809750"/>
           </a:xfrm>
           <a:prstGeom xmlns:a="http://schemas.openxmlformats.org/drawingml/2006/main" prst="rect">
             <a:avLst/>
@@ -3615,7 +3632,7 @@
           <a:bodyPr xmlns:a="http://schemas.openxmlformats.org/drawingml/2006/main"/>
           <a:lstStyle xmlns:a="http://schemas.openxmlformats.org/drawingml/2006/main">
             <a:defPPr>
-              <a:defRPr sz="1350" b="0">
+              <a:defRPr sz="1275" b="0">
                 <a:solidFill>
                   <a:srgbClr val="0D1B26"/>
                 </a:solidFill>
@@ -3624,14 +3641,14 @@
           </a:lstStyle>
           <a:p xmlns:a="http://schemas.openxmlformats.org/drawingml/2006/main">
             <a:pPr>
-              <a:defRPr sz="1350" b="0">
-                <a:solidFill>
-                  <a:srgbClr val="0D1B26"/>
-                </a:solidFill>
-              </a:defRPr>
-            </a:pPr>
-            <a:r>
-              <a:rPr sz="1350" b="0">
+              <a:defRPr sz="1275" b="0">
+                <a:solidFill>
+                  <a:srgbClr val="0D1B26"/>
+                </a:solidFill>
+              </a:defRPr>
+            </a:pPr>
+            <a:r>
+              <a:rPr sz="1275" b="0">
                 <a:solidFill>
                   <a:srgbClr val="0D1B26"/>
                 </a:solidFill>
@@ -3641,53 +3658,53 @@
           </a:p>
           <a:p xmlns:a="http://schemas.openxmlformats.org/drawingml/2006/main">
             <a:pPr>
-              <a:defRPr sz="1350" b="0">
-                <a:solidFill>
-                  <a:srgbClr val="0D1B26"/>
-                </a:solidFill>
-              </a:defRPr>
-            </a:pPr>
-            <a:r>
-              <a:rPr sz="1350" b="0">
-                <a:solidFill>
-                  <a:srgbClr val="0D1B26"/>
-                </a:solidFill>
-              </a:rPr>
-              <a:t>• APAC Geo: Lite C1–3; Pro C4–5; agent steps C3=2, C4=3, C5=4</a:t>
-            </a:r>
-          </a:p>
-          <a:p xmlns:a="http://schemas.openxmlformats.org/drawingml/2006/main">
-            <a:pPr>
-              <a:defRPr sz="1350" b="0">
-                <a:solidFill>
-                  <a:srgbClr val="0D1B26"/>
-                </a:solidFill>
-              </a:defRPr>
-            </a:pPr>
-            <a:r>
-              <a:rPr sz="1350" b="0">
-                <a:solidFill>
-                  <a:srgbClr val="0D1B26"/>
-                </a:solidFill>
-              </a:rPr>
-              <a:t>• Titan Image G1 v2 không dùng: legacy/EOL; Nova sinh SVG/HTML render sandbox</a:t>
-            </a:r>
-          </a:p>
-          <a:p xmlns:a="http://schemas.openxmlformats.org/drawingml/2006/main">
-            <a:pPr>
-              <a:defRPr sz="1350" b="0">
-                <a:solidFill>
-                  <a:srgbClr val="0D1B26"/>
-                </a:solidFill>
-              </a:defRPr>
-            </a:pPr>
-            <a:r>
-              <a:rPr sz="1350" b="0">
-                <a:solidFill>
-                  <a:srgbClr val="0D1B26"/>
-                </a:solidFill>
-              </a:rPr>
-              <a:t>• Titan Embeddings V2 + S3 + pgvector trong Aurora</a:t>
+              <a:defRPr sz="1275" b="0">
+                <a:solidFill>
+                  <a:srgbClr val="0D1B26"/>
+                </a:solidFill>
+              </a:defRPr>
+            </a:pPr>
+            <a:r>
+              <a:rPr sz="1275" b="0">
+                <a:solidFill>
+                  <a:srgbClr val="0D1B26"/>
+                </a:solidFill>
+              </a:rPr>
+              <a:t>• Routing Lite C1–3 / Pro C4–5 là baseline để benchmark; không dùng agent-step để nhân token</a:t>
+            </a:r>
+          </a:p>
+          <a:p xmlns:a="http://schemas.openxmlformats.org/drawingml/2006/main">
+            <a:pPr>
+              <a:defRPr sz="1275" b="0">
+                <a:solidFill>
+                  <a:srgbClr val="0D1B26"/>
+                </a:solidFill>
+              </a:defRPr>
+            </a:pPr>
+            <a:r>
+              <a:rPr sz="1275" b="0">
+                <a:solidFill>
+                  <a:srgbClr val="0D1B26"/>
+                </a:solidFill>
+              </a:rPr>
+              <a:t>• Titan Image G1 v2 không dùng: legacy/EOL; ảnh SVG/HTML là giả định cần benchmark</a:t>
+            </a:r>
+          </a:p>
+          <a:p xmlns:a="http://schemas.openxmlformats.org/drawingml/2006/main">
+            <a:pPr>
+              <a:defRPr sz="1275" b="0">
+                <a:solidFill>
+                  <a:srgbClr val="0D1B26"/>
+                </a:solidFill>
+              </a:defRPr>
+            </a:pPr>
+            <a:r>
+              <a:rPr sz="1275" b="0">
+                <a:solidFill>
+                  <a:srgbClr val="0D1B26"/>
+                </a:solidFill>
+              </a:rPr>
+              <a:t>• Titan Embeddings V2 + S3 + pgvector trong Aurora; giá LLM/sandbox PENDING_VERIFICATION</a:t>
             </a:r>
           </a:p>
         </p:txBody>
@@ -3697,7 +3714,7 @@
           <p:cNvPr id="13" name="">
             <a:extLst xmlns:a="http://schemas.openxmlformats.org/drawingml/2006/main">
               <a:ext uri="{FF2B5EF4-FFF2-40B4-BE49-F238E27FC236}">
-                <a16:creationId xmlns:a16="http://schemas.microsoft.com/office/drawing/2014/main" id="{F4E31B59-3925-493C-9841-E8AC79A22C4A}"/>
+                <a16:creationId xmlns:a16="http://schemas.microsoft.com/office/drawing/2014/main" id="{DF35F3DC-D472-4983-85DD-F83F9B06A5A0}"/>
               </a:ext>
             </a:extLst>
           </p:cNvPr>
@@ -3724,7 +3741,7 @@
           <a:bodyPr xmlns:a="http://schemas.openxmlformats.org/drawingml/2006/main"/>
           <a:lstStyle xmlns:a="http://schemas.openxmlformats.org/drawingml/2006/main">
             <a:defPPr>
-              <a:defRPr sz="1650" b="1">
+              <a:defRPr sz="1575" b="1">
                 <a:solidFill>
                   <a:srgbClr val="B45309"/>
                 </a:solidFill>
@@ -3733,19 +3750,19 @@
           </a:lstStyle>
           <a:p xmlns:a="http://schemas.openxmlformats.org/drawingml/2006/main">
             <a:pPr>
-              <a:defRPr sz="1650" b="1">
+              <a:defRPr sz="1575" b="1">
                 <a:solidFill>
                   <a:srgbClr val="B45309"/>
                 </a:solidFill>
               </a:defRPr>
             </a:pPr>
             <a:r>
-              <a:rPr sz="1650" b="1">
+              <a:rPr sz="1575" b="1">
                 <a:solidFill>
                   <a:srgbClr val="B45309"/>
                 </a:solidFill>
               </a:rPr>
-              <a:t>TOTAL 15,001.24 USD/tháng · 7.50 USD/DAU/tháng</a:t>
+              <a:t>TOTAL working estimate 12,814.26 USD/tháng · 6.41 USD/DAU/tháng</a:t>
             </a:r>
           </a:p>
         </p:txBody>
@@ -3753,7 +3770,7 @@
     </p:spTree>
     <p:extLst>
       <p:ext uri="{BB962C8B-B14F-4D97-AF65-F5344CB8AC3E}">
-        <p14:creationId xmlns:p14="http://schemas.microsoft.com/office/powerpoint/2010/main" val="1862336159"/>
+        <p14:creationId xmlns:p14="http://schemas.microsoft.com/office/powerpoint/2010/main" val="1655983584"/>
       </p:ext>
     </p:extLst>
   </p:cSld>
@@ -3784,7 +3801,7 @@
           <p:cNvPr id="22" name="">
             <a:extLst xmlns:a="http://schemas.openxmlformats.org/drawingml/2006/main">
               <a:ext uri="{FF2B5EF4-FFF2-40B4-BE49-F238E27FC236}">
-                <a16:creationId xmlns:a16="http://schemas.microsoft.com/office/drawing/2014/main" id="{42D63A21-D401-44D1-ABD9-494814BF10AA}"/>
+                <a16:creationId xmlns:a16="http://schemas.microsoft.com/office/drawing/2014/main" id="{9D04B27A-F5D6-4ACF-86FC-43D491398562}"/>
               </a:ext>
             </a:extLst>
           </p:cNvPr>
@@ -3842,7 +3859,7 @@
           <p:cNvPr id="2" name="">
             <a:extLst xmlns:a="http://schemas.openxmlformats.org/drawingml/2006/main">
               <a:ext uri="{FF2B5EF4-FFF2-40B4-BE49-F238E27FC236}">
-                <a16:creationId xmlns:a16="http://schemas.microsoft.com/office/drawing/2014/main" id="{322F76EE-5817-4559-BF50-38D07775A923}"/>
+                <a16:creationId xmlns:a16="http://schemas.microsoft.com/office/drawing/2014/main" id="{A32F55DC-ED41-4524-9AA1-2A82D301B41C}"/>
               </a:ext>
             </a:extLst>
           </p:cNvPr>
@@ -3900,7 +3917,7 @@
           <p:cNvPr id="3" name="">
             <a:extLst xmlns:a="http://schemas.openxmlformats.org/drawingml/2006/main">
               <a:ext uri="{FF2B5EF4-FFF2-40B4-BE49-F238E27FC236}">
-                <a16:creationId xmlns:a16="http://schemas.microsoft.com/office/drawing/2014/main" id="{E3FC589D-D6A5-445D-970F-2D95058C5478}"/>
+                <a16:creationId xmlns:a16="http://schemas.microsoft.com/office/drawing/2014/main" id="{6CDB42F1-5CB0-4EAD-849B-0DA55531B771}"/>
               </a:ext>
             </a:extLst>
           </p:cNvPr>
@@ -3958,7 +3975,7 @@
           <p:cNvPr id="4" name="">
             <a:extLst xmlns:a="http://schemas.openxmlformats.org/drawingml/2006/main">
               <a:ext uri="{FF2B5EF4-FFF2-40B4-BE49-F238E27FC236}">
-                <a16:creationId xmlns:a16="http://schemas.microsoft.com/office/drawing/2014/main" id="{909E7E0C-71E2-4992-8B75-CDB6B8844A5D}"/>
+                <a16:creationId xmlns:a16="http://schemas.microsoft.com/office/drawing/2014/main" id="{E09E5A31-5DC4-4FCB-AF26-D95E3A08837E}"/>
               </a:ext>
             </a:extLst>
           </p:cNvPr>
@@ -4056,7 +4073,7 @@
           <p:cNvPr id="5" name="">
             <a:extLst xmlns:a="http://schemas.openxmlformats.org/drawingml/2006/main">
               <a:ext uri="{FF2B5EF4-FFF2-40B4-BE49-F238E27FC236}">
-                <a16:creationId xmlns:a16="http://schemas.microsoft.com/office/drawing/2014/main" id="{DE99FBD2-EBD5-481C-A628-9C0A5C564642}"/>
+                <a16:creationId xmlns:a16="http://schemas.microsoft.com/office/drawing/2014/main" id="{E96D445F-0195-408B-9082-43216701B8BD}"/>
               </a:ext>
             </a:extLst>
           </p:cNvPr>
@@ -4114,7 +4131,7 @@
           <p:cNvPr id="6" name="">
             <a:extLst xmlns:a="http://schemas.openxmlformats.org/drawingml/2006/main">
               <a:ext uri="{FF2B5EF4-FFF2-40B4-BE49-F238E27FC236}">
-                <a16:creationId xmlns:a16="http://schemas.microsoft.com/office/drawing/2014/main" id="{84001B4F-A802-4699-BCCB-CE965B466881}"/>
+                <a16:creationId xmlns:a16="http://schemas.microsoft.com/office/drawing/2014/main" id="{771F66B7-682E-4790-86CE-46BE58B1C5A8}"/>
               </a:ext>
             </a:extLst>
           </p:cNvPr>
@@ -4195,7 +4212,7 @@
           <p:cNvPr id="7" name="">
             <a:extLst xmlns:a="http://schemas.openxmlformats.org/drawingml/2006/main">
               <a:ext uri="{FF2B5EF4-FFF2-40B4-BE49-F238E27FC236}">
-                <a16:creationId xmlns:a16="http://schemas.microsoft.com/office/drawing/2014/main" id="{B5018289-DB65-480F-B1D1-1F77D3CBC9D2}"/>
+                <a16:creationId xmlns:a16="http://schemas.microsoft.com/office/drawing/2014/main" id="{75FD351E-5930-4A7A-BC2D-FA8C9174328A}"/>
               </a:ext>
             </a:extLst>
           </p:cNvPr>
@@ -4253,7 +4270,7 @@
           <p:cNvPr id="8" name="">
             <a:extLst xmlns:a="http://schemas.openxmlformats.org/drawingml/2006/main">
               <a:ext uri="{FF2B5EF4-FFF2-40B4-BE49-F238E27FC236}">
-                <a16:creationId xmlns:a16="http://schemas.microsoft.com/office/drawing/2014/main" id="{12D34371-0202-449A-8FC6-BE3C6750BA8C}"/>
+                <a16:creationId xmlns:a16="http://schemas.microsoft.com/office/drawing/2014/main" id="{FDB64561-CCDB-418F-B9E5-60B4D3CE45B0}"/>
               </a:ext>
             </a:extLst>
           </p:cNvPr>
@@ -4334,7 +4351,7 @@
           <p:cNvPr id="9" name="">
             <a:extLst xmlns:a="http://schemas.openxmlformats.org/drawingml/2006/main">
               <a:ext uri="{FF2B5EF4-FFF2-40B4-BE49-F238E27FC236}">
-                <a16:creationId xmlns:a16="http://schemas.microsoft.com/office/drawing/2014/main" id="{21F525F1-DA79-4F8C-AE73-8AAB0D92D40A}"/>
+                <a16:creationId xmlns:a16="http://schemas.microsoft.com/office/drawing/2014/main" id="{8DAF3381-F6B1-4ED0-AC21-80D23F129E4E}"/>
               </a:ext>
             </a:extLst>
           </p:cNvPr>
@@ -4392,7 +4409,7 @@
           <p:cNvPr id="10" name="">
             <a:extLst xmlns:a="http://schemas.openxmlformats.org/drawingml/2006/main">
               <a:ext uri="{FF2B5EF4-FFF2-40B4-BE49-F238E27FC236}">
-                <a16:creationId xmlns:a16="http://schemas.microsoft.com/office/drawing/2014/main" id="{A974E5E6-F477-478F-BDDF-7CD18BAB0B93}"/>
+                <a16:creationId xmlns:a16="http://schemas.microsoft.com/office/drawing/2014/main" id="{F5072802-9EBD-4DAB-919C-853A2F08CEC3}"/>
               </a:ext>
             </a:extLst>
           </p:cNvPr>
@@ -4473,7 +4490,7 @@
           <p:cNvPr id="11" name="">
             <a:extLst xmlns:a="http://schemas.openxmlformats.org/drawingml/2006/main">
               <a:ext uri="{FF2B5EF4-FFF2-40B4-BE49-F238E27FC236}">
-                <a16:creationId xmlns:a16="http://schemas.microsoft.com/office/drawing/2014/main" id="{6B839EE3-BC39-4758-A0B0-CD04C38B1F6B}"/>
+                <a16:creationId xmlns:a16="http://schemas.microsoft.com/office/drawing/2014/main" id="{C4B03AC6-57B1-445F-88BD-64DB2801E96A}"/>
               </a:ext>
             </a:extLst>
           </p:cNvPr>
@@ -4531,7 +4548,7 @@
           <p:cNvPr id="12" name="">
             <a:extLst xmlns:a="http://schemas.openxmlformats.org/drawingml/2006/main">
               <a:ext uri="{FF2B5EF4-FFF2-40B4-BE49-F238E27FC236}">
-                <a16:creationId xmlns:a16="http://schemas.microsoft.com/office/drawing/2014/main" id="{CA23A181-F109-4364-BC45-611E26B8F71D}"/>
+                <a16:creationId xmlns:a16="http://schemas.microsoft.com/office/drawing/2014/main" id="{A5B7AF16-5F15-4F03-AE19-774C57A7FC4A}"/>
               </a:ext>
             </a:extLst>
           </p:cNvPr>
@@ -4612,7 +4629,7 @@
           <p:cNvPr id="13" name="">
             <a:extLst xmlns:a="http://schemas.openxmlformats.org/drawingml/2006/main">
               <a:ext uri="{FF2B5EF4-FFF2-40B4-BE49-F238E27FC236}">
-                <a16:creationId xmlns:a16="http://schemas.microsoft.com/office/drawing/2014/main" id="{02B0528D-7BDB-4687-A794-EA0ADDFEC550}"/>
+                <a16:creationId xmlns:a16="http://schemas.microsoft.com/office/drawing/2014/main" id="{37AC17E2-F023-4DF9-A280-7C4CDC6FC0EA}"/>
               </a:ext>
             </a:extLst>
           </p:cNvPr>
@@ -4710,7 +4727,7 @@
           <p:cNvPr id="14" name="">
             <a:extLst xmlns:a="http://schemas.openxmlformats.org/drawingml/2006/main">
               <a:ext uri="{FF2B5EF4-FFF2-40B4-BE49-F238E27FC236}">
-                <a16:creationId xmlns:a16="http://schemas.microsoft.com/office/drawing/2014/main" id="{20FBB908-B19A-4B37-AD34-F15804618271}"/>
+                <a16:creationId xmlns:a16="http://schemas.microsoft.com/office/drawing/2014/main" id="{7281E8CB-680E-4B80-BEDA-16ABB89A454E}"/>
               </a:ext>
             </a:extLst>
           </p:cNvPr>
@@ -4808,7 +4825,7 @@
           <p:cNvPr id="15" name="">
             <a:extLst xmlns:a="http://schemas.openxmlformats.org/drawingml/2006/main">
               <a:ext uri="{FF2B5EF4-FFF2-40B4-BE49-F238E27FC236}">
-                <a16:creationId xmlns:a16="http://schemas.microsoft.com/office/drawing/2014/main" id="{BB3AF825-8D93-4003-B2A3-6275B8B64746}"/>
+                <a16:creationId xmlns:a16="http://schemas.microsoft.com/office/drawing/2014/main" id="{7235BA75-8D8D-4481-B07D-6D09A61FEDEC}"/>
               </a:ext>
             </a:extLst>
           </p:cNvPr>
@@ -4906,7 +4923,7 @@
           <p:cNvPr id="16" name="">
             <a:extLst xmlns:a="http://schemas.openxmlformats.org/drawingml/2006/main">
               <a:ext uri="{FF2B5EF4-FFF2-40B4-BE49-F238E27FC236}">
-                <a16:creationId xmlns:a16="http://schemas.microsoft.com/office/drawing/2014/main" id="{4F7B9538-2719-44CF-9C9A-DA5D407DC015}"/>
+                <a16:creationId xmlns:a16="http://schemas.microsoft.com/office/drawing/2014/main" id="{CE7755A7-AF1F-4AFD-AA98-A076F7564FD5}"/>
               </a:ext>
             </a:extLst>
           </p:cNvPr>
@@ -5004,7 +5021,7 @@
           <p:cNvPr id="17" name="">
             <a:extLst xmlns:a="http://schemas.openxmlformats.org/drawingml/2006/main">
               <a:ext uri="{FF2B5EF4-FFF2-40B4-BE49-F238E27FC236}">
-                <a16:creationId xmlns:a16="http://schemas.microsoft.com/office/drawing/2014/main" id="{FC9C4A7C-9D4B-45D7-92E8-1DB24904C4CF}"/>
+                <a16:creationId xmlns:a16="http://schemas.microsoft.com/office/drawing/2014/main" id="{0B1A09E7-6571-4CCB-A45A-4E91FB7B0AEF}"/>
               </a:ext>
             </a:extLst>
           </p:cNvPr>
@@ -5062,7 +5079,7 @@
           <p:cNvPr id="18" name="">
             <a:extLst xmlns:a="http://schemas.openxmlformats.org/drawingml/2006/main">
               <a:ext uri="{FF2B5EF4-FFF2-40B4-BE49-F238E27FC236}">
-                <a16:creationId xmlns:a16="http://schemas.microsoft.com/office/drawing/2014/main" id="{1778ECA3-0EA5-499E-B947-D325F0A87D7A}"/>
+                <a16:creationId xmlns:a16="http://schemas.microsoft.com/office/drawing/2014/main" id="{594001EE-AB90-4D5C-86AB-6BE9086E7DB6}"/>
               </a:ext>
             </a:extLst>
           </p:cNvPr>
@@ -5120,7 +5137,7 @@
           <p:cNvPr id="19" name="">
             <a:extLst xmlns:a="http://schemas.openxmlformats.org/drawingml/2006/main">
               <a:ext uri="{FF2B5EF4-FFF2-40B4-BE49-F238E27FC236}">
-                <a16:creationId xmlns:a16="http://schemas.microsoft.com/office/drawing/2014/main" id="{7342CACE-79DB-44EA-B7BA-B0A525CE6BCC}"/>
+                <a16:creationId xmlns:a16="http://schemas.microsoft.com/office/drawing/2014/main" id="{C1C0BD50-56CE-49C4-B549-49DCB9D8BB67}"/>
               </a:ext>
             </a:extLst>
           </p:cNvPr>
@@ -5178,7 +5195,7 @@
           <p:cNvPr id="20" name="">
             <a:extLst xmlns:a="http://schemas.openxmlformats.org/drawingml/2006/main">
               <a:ext uri="{FF2B5EF4-FFF2-40B4-BE49-F238E27FC236}">
-                <a16:creationId xmlns:a16="http://schemas.microsoft.com/office/drawing/2014/main" id="{C9FA82DC-3331-48D6-BC8D-48CE2959D2F3}"/>
+                <a16:creationId xmlns:a16="http://schemas.microsoft.com/office/drawing/2014/main" id="{0002BA38-2A22-4477-9A4C-58C5A3438F45}"/>
               </a:ext>
             </a:extLst>
           </p:cNvPr>
@@ -5236,7 +5253,7 @@
           <p:cNvPr id="21" name="">
             <a:extLst xmlns:a="http://schemas.openxmlformats.org/drawingml/2006/main">
               <a:ext uri="{FF2B5EF4-FFF2-40B4-BE49-F238E27FC236}">
-                <a16:creationId xmlns:a16="http://schemas.microsoft.com/office/drawing/2014/main" id="{3C7F1059-161C-4DBF-8611-40FC475E7963}"/>
+                <a16:creationId xmlns:a16="http://schemas.microsoft.com/office/drawing/2014/main" id="{27BC505C-C981-43FE-A8F2-3E869B8DE88C}"/>
               </a:ext>
             </a:extLst>
           </p:cNvPr>
@@ -5292,7 +5309,7 @@
     </p:spTree>
     <p:extLst>
       <p:ext uri="{BB962C8B-B14F-4D97-AF65-F5344CB8AC3E}">
-        <p14:creationId xmlns:p14="http://schemas.microsoft.com/office/powerpoint/2010/main" val="1430662196"/>
+        <p14:creationId xmlns:p14="http://schemas.microsoft.com/office/powerpoint/2010/main" val="528581707"/>
       </p:ext>
     </p:extLst>
   </p:cSld>

</xml_diff>

<commit_message>
refactor: exclude ops labor from total cost calculation and update pricing artifacts
</commit_message>
<xml_diff>
--- a/G03_slide.pptx
+++ b/G03_slide.pptx
@@ -2,24 +2,24 @@
 <file path=ppt/presentation.xml><?xml version="1.0" encoding="utf-8"?>
 <p:presentation xmlns:p="http://schemas.openxmlformats.org/presentationml/2006/main">
   <p:sldMasterIdLst>
-    <p:sldMasterId xmlns:r="http://schemas.openxmlformats.org/officeDocument/2006/relationships" id="2147483648" r:id="R785c73cb59984e7a"/>
+    <p:sldMasterId xmlns:r="http://schemas.openxmlformats.org/officeDocument/2006/relationships" id="2147483648" r:id="R4353bdbe7af44806"/>
   </p:sldMasterIdLst>
   <p:notesMasterIdLst>
-    <p:notesMasterId xmlns:r="http://schemas.openxmlformats.org/officeDocument/2006/relationships" r:id="R7a80d82c1c1a468a"/>
+    <p:notesMasterId xmlns:r="http://schemas.openxmlformats.org/officeDocument/2006/relationships" r:id="Re86abfb373e8404d"/>
   </p:notesMasterIdLst>
   <p:sldIdLst>
-    <p:sldId xmlns:r="http://schemas.openxmlformats.org/officeDocument/2006/relationships" id="256" r:id="Ra14e00df859342b2"/>
-    <p:sldId xmlns:r="http://schemas.openxmlformats.org/officeDocument/2006/relationships" id="257" r:id="R2c67041f10ab4c2a"/>
-    <p:sldId xmlns:r="http://schemas.openxmlformats.org/officeDocument/2006/relationships" id="258" r:id="R554c0dcf1de347c6"/>
-    <p:sldId xmlns:r="http://schemas.openxmlformats.org/officeDocument/2006/relationships" id="259" r:id="Ref67d33fc6c14a35"/>
-    <p:sldId xmlns:r="http://schemas.openxmlformats.org/officeDocument/2006/relationships" id="260" r:id="Rb4d99999de8b4ac7"/>
-    <p:sldId xmlns:r="http://schemas.openxmlformats.org/officeDocument/2006/relationships" id="261" r:id="R2cacc74301934d19"/>
-    <p:sldId xmlns:r="http://schemas.openxmlformats.org/officeDocument/2006/relationships" id="262" r:id="R43efe94a45c044ec"/>
-    <p:sldId xmlns:r="http://schemas.openxmlformats.org/officeDocument/2006/relationships" id="263" r:id="R8d71be0b3b2f4c2e"/>
-    <p:sldId xmlns:r="http://schemas.openxmlformats.org/officeDocument/2006/relationships" id="264" r:id="Rfd0d7deedb8e446d"/>
-    <p:sldId xmlns:r="http://schemas.openxmlformats.org/officeDocument/2006/relationships" id="265" r:id="R8d19c292fc1d44e2"/>
-    <p:sldId xmlns:r="http://schemas.openxmlformats.org/officeDocument/2006/relationships" id="266" r:id="Rdd54597152084b13"/>
-    <p:sldId xmlns:r="http://schemas.openxmlformats.org/officeDocument/2006/relationships" id="267" r:id="R56f5035ebf1b409c"/>
+    <p:sldId xmlns:r="http://schemas.openxmlformats.org/officeDocument/2006/relationships" id="256" r:id="R94c67e8bb3414af4"/>
+    <p:sldId xmlns:r="http://schemas.openxmlformats.org/officeDocument/2006/relationships" id="257" r:id="Re9aad9f8fc264411"/>
+    <p:sldId xmlns:r="http://schemas.openxmlformats.org/officeDocument/2006/relationships" id="258" r:id="R7d11d5114f284511"/>
+    <p:sldId xmlns:r="http://schemas.openxmlformats.org/officeDocument/2006/relationships" id="259" r:id="Re9d349a51279409a"/>
+    <p:sldId xmlns:r="http://schemas.openxmlformats.org/officeDocument/2006/relationships" id="260" r:id="Rf31cfe07e1894616"/>
+    <p:sldId xmlns:r="http://schemas.openxmlformats.org/officeDocument/2006/relationships" id="261" r:id="R42423f451eb84703"/>
+    <p:sldId xmlns:r="http://schemas.openxmlformats.org/officeDocument/2006/relationships" id="262" r:id="R90fc9f8c841a4ae1"/>
+    <p:sldId xmlns:r="http://schemas.openxmlformats.org/officeDocument/2006/relationships" id="263" r:id="Re8a06a00bca24d9f"/>
+    <p:sldId xmlns:r="http://schemas.openxmlformats.org/officeDocument/2006/relationships" id="264" r:id="Rca2d928ec5a04701"/>
+    <p:sldId xmlns:r="http://schemas.openxmlformats.org/officeDocument/2006/relationships" id="265" r:id="R9c016e4c84f2437f"/>
+    <p:sldId xmlns:r="http://schemas.openxmlformats.org/officeDocument/2006/relationships" id="266" r:id="Raa73bca213f14654"/>
+    <p:sldId xmlns:r="http://schemas.openxmlformats.org/officeDocument/2006/relationships" id="267" r:id="R58bd6c5bdcd3442f"/>
   </p:sldIdLst>
   <p:sldSz cx="12192000" cy="6858000"/>
   <p:notesSz cx="6858000" cy="9144000"/>
@@ -1222,7 +1222,7 @@
           <p:cNvPr id="3" name="Title">
             <a:extLst xmlns:a="http://schemas.openxmlformats.org/drawingml/2006/main">
               <a:ext uri="{FF2B5EF4-FFF2-40B4-BE49-F238E27FC236}">
-                <a16:creationId xmlns:a16="http://schemas.microsoft.com/office/drawing/2014/main" id="{71798356-4C8F-4A7F-9162-41EE13EADCE8}"/>
+                <a16:creationId xmlns:a16="http://schemas.microsoft.com/office/drawing/2014/main" id="{78427962-28D8-4428-8C7D-A3BF5F7DB31E}"/>
               </a:ext>
             </a:extLst>
           </p:cNvPr>
@@ -1379,7 +1379,7 @@
           <p:cNvPr id="2" name="Subtitle">
             <a:extLst xmlns:a="http://schemas.openxmlformats.org/drawingml/2006/main">
               <a:ext uri="{FF2B5EF4-FFF2-40B4-BE49-F238E27FC236}">
-                <a16:creationId xmlns:a16="http://schemas.microsoft.com/office/drawing/2014/main" id="{81A1584E-7BDF-4CF1-B4D9-C5C407DE5B3F}"/>
+                <a16:creationId xmlns:a16="http://schemas.microsoft.com/office/drawing/2014/main" id="{BD55375E-989D-4CBD-B5A6-34F7FF5D0F38}"/>
               </a:ext>
             </a:extLst>
           </p:cNvPr>
@@ -1553,7 +1553,7 @@
           <p:cNvPr id="2" name="Section title">
             <a:extLst xmlns:a="http://schemas.openxmlformats.org/drawingml/2006/main">
               <a:ext uri="{FF2B5EF4-FFF2-40B4-BE49-F238E27FC236}">
-                <a16:creationId xmlns:a16="http://schemas.microsoft.com/office/drawing/2014/main" id="{C6C5E8BF-A2B7-4EB0-B443-30EF91DC368D}"/>
+                <a16:creationId xmlns:a16="http://schemas.microsoft.com/office/drawing/2014/main" id="{D9A155E6-18D6-4A4E-A9C3-5A58CED0EF48}"/>
               </a:ext>
             </a:extLst>
           </p:cNvPr>
@@ -1727,7 +1727,7 @@
           <p:cNvPr id="3" name="Title">
             <a:extLst xmlns:a="http://schemas.openxmlformats.org/drawingml/2006/main">
               <a:ext uri="{FF2B5EF4-FFF2-40B4-BE49-F238E27FC236}">
-                <a16:creationId xmlns:a16="http://schemas.microsoft.com/office/drawing/2014/main" id="{B6872D49-3F23-48F9-8756-09443683F512}"/>
+                <a16:creationId xmlns:a16="http://schemas.microsoft.com/office/drawing/2014/main" id="{B1FB222B-AD23-423F-8146-D1E4A15E1633}"/>
               </a:ext>
             </a:extLst>
           </p:cNvPr>
@@ -1884,7 +1884,7 @@
           <p:cNvPr id="2" name="Body">
             <a:extLst xmlns:a="http://schemas.openxmlformats.org/drawingml/2006/main">
               <a:ext uri="{FF2B5EF4-FFF2-40B4-BE49-F238E27FC236}">
-                <a16:creationId xmlns:a16="http://schemas.microsoft.com/office/drawing/2014/main" id="{1E9657B0-A6D9-4C0A-A11F-43260431FFBC}"/>
+                <a16:creationId xmlns:a16="http://schemas.microsoft.com/office/drawing/2014/main" id="{4732947C-EB8B-49F8-A132-013D964F4B99}"/>
               </a:ext>
             </a:extLst>
           </p:cNvPr>
@@ -2058,7 +2058,7 @@
           <p:cNvPr id="4" name="Title">
             <a:extLst xmlns:a="http://schemas.openxmlformats.org/drawingml/2006/main">
               <a:ext uri="{FF2B5EF4-FFF2-40B4-BE49-F238E27FC236}">
-                <a16:creationId xmlns:a16="http://schemas.microsoft.com/office/drawing/2014/main" id="{DFCD80D2-1994-4483-BE97-0EFE4C8C61EB}"/>
+                <a16:creationId xmlns:a16="http://schemas.microsoft.com/office/drawing/2014/main" id="{26D2B7D9-6478-4A39-8BE5-DA693A362577}"/>
               </a:ext>
             </a:extLst>
           </p:cNvPr>
@@ -2215,7 +2215,7 @@
           <p:cNvPr id="2" name="Left column">
             <a:extLst xmlns:a="http://schemas.openxmlformats.org/drawingml/2006/main">
               <a:ext uri="{FF2B5EF4-FFF2-40B4-BE49-F238E27FC236}">
-                <a16:creationId xmlns:a16="http://schemas.microsoft.com/office/drawing/2014/main" id="{E9D08823-7D55-4111-BA3B-978F5653DCAF}"/>
+                <a16:creationId xmlns:a16="http://schemas.microsoft.com/office/drawing/2014/main" id="{BCC588B6-3407-411B-A618-B9EE6B504AE7}"/>
               </a:ext>
             </a:extLst>
           </p:cNvPr>
@@ -2372,7 +2372,7 @@
           <p:cNvPr id="3" name="Right column">
             <a:extLst xmlns:a="http://schemas.openxmlformats.org/drawingml/2006/main">
               <a:ext uri="{FF2B5EF4-FFF2-40B4-BE49-F238E27FC236}">
-                <a16:creationId xmlns:a16="http://schemas.microsoft.com/office/drawing/2014/main" id="{D5BB36B4-6FB5-4343-821F-EFC2A63BB9F0}"/>
+                <a16:creationId xmlns:a16="http://schemas.microsoft.com/office/drawing/2014/main" id="{A344F63B-1501-4503-9556-F238CBCDCDF7}"/>
               </a:ext>
             </a:extLst>
           </p:cNvPr>
@@ -2546,7 +2546,7 @@
           <p:cNvPr id="3" name="Title">
             <a:extLst xmlns:a="http://schemas.openxmlformats.org/drawingml/2006/main">
               <a:ext uri="{FF2B5EF4-FFF2-40B4-BE49-F238E27FC236}">
-                <a16:creationId xmlns:a16="http://schemas.microsoft.com/office/drawing/2014/main" id="{8B1805A8-1F95-4414-9DF1-8372DE057E7B}"/>
+                <a16:creationId xmlns:a16="http://schemas.microsoft.com/office/drawing/2014/main" id="{8A1D7A32-3C20-4F95-B0AD-B4082905DC71}"/>
               </a:ext>
             </a:extLst>
           </p:cNvPr>
@@ -2703,7 +2703,7 @@
           <p:cNvPr id="2" name="Left column">
             <a:extLst xmlns:a="http://schemas.openxmlformats.org/drawingml/2006/main">
               <a:ext uri="{FF2B5EF4-FFF2-40B4-BE49-F238E27FC236}">
-                <a16:creationId xmlns:a16="http://schemas.microsoft.com/office/drawing/2014/main" id="{D770DBC4-7871-4655-8290-335C6B4087F3}"/>
+                <a16:creationId xmlns:a16="http://schemas.microsoft.com/office/drawing/2014/main" id="{B657992C-864B-48A9-9D2E-C81CD28B01D7}"/>
               </a:ext>
             </a:extLst>
           </p:cNvPr>
@@ -2898,12 +2898,12 @@
   </p:cSld>
   <p:clrMap bg1="lt1" tx1="dk1" bg2="lt2" tx2="dk2" accent1="accent1" accent2="accent2" accent3="accent3" accent4="accent4" accent5="accent5" accent6="accent6" hlink="hlink" folHlink="folHlink"/>
   <p:sldLayoutIdLst>
-    <p:sldLayoutId xmlns:r="http://schemas.openxmlformats.org/officeDocument/2006/relationships" id="2147483649" r:id="Rd1d79f5ce8de4725"/>
-    <p:sldLayoutId xmlns:r="http://schemas.openxmlformats.org/officeDocument/2006/relationships" id="2147483650" r:id="Rb9847689a5f149cc"/>
-    <p:sldLayoutId xmlns:r="http://schemas.openxmlformats.org/officeDocument/2006/relationships" id="2147483651" r:id="Rffdcbb8f3c3b4858"/>
-    <p:sldLayoutId xmlns:r="http://schemas.openxmlformats.org/officeDocument/2006/relationships" id="2147483652" r:id="R5aa75e4a9d3e4471"/>
-    <p:sldLayoutId xmlns:r="http://schemas.openxmlformats.org/officeDocument/2006/relationships" id="2147483653" r:id="R3a31a8fdb3f6494b"/>
-    <p:sldLayoutId xmlns:r="http://schemas.openxmlformats.org/officeDocument/2006/relationships" id="2147483654" r:id="R97c7b887247d414e"/>
+    <p:sldLayoutId xmlns:r="http://schemas.openxmlformats.org/officeDocument/2006/relationships" id="2147483649" r:id="Ra250966ce62f47f2"/>
+    <p:sldLayoutId xmlns:r="http://schemas.openxmlformats.org/officeDocument/2006/relationships" id="2147483650" r:id="Rabad2de800774fc2"/>
+    <p:sldLayoutId xmlns:r="http://schemas.openxmlformats.org/officeDocument/2006/relationships" id="2147483651" r:id="R52952fd7885c4f8e"/>
+    <p:sldLayoutId xmlns:r="http://schemas.openxmlformats.org/officeDocument/2006/relationships" id="2147483652" r:id="R3352fa250ed84dd6"/>
+    <p:sldLayoutId xmlns:r="http://schemas.openxmlformats.org/officeDocument/2006/relationships" id="2147483653" r:id="Ra177524aecd54509"/>
+    <p:sldLayoutId xmlns:r="http://schemas.openxmlformats.org/officeDocument/2006/relationships" id="2147483654" r:id="R5581f05348a240d0"/>
   </p:sldLayoutIdLst>
   <p:txStyles>
     <p:titleStyle>
@@ -3454,7 +3454,7 @@
           <p:cNvPr id="15" name="">
             <a:extLst xmlns:a="http://schemas.openxmlformats.org/drawingml/2006/main">
               <a:ext uri="{FF2B5EF4-FFF2-40B4-BE49-F238E27FC236}">
-                <a16:creationId xmlns:a16="http://schemas.microsoft.com/office/drawing/2014/main" id="{57F02005-B6C8-41F6-B592-BD3CE90DC8D1}"/>
+                <a16:creationId xmlns:a16="http://schemas.microsoft.com/office/drawing/2014/main" id="{76F1DF5A-597B-49FA-ADA0-69CDDFBEA2E9}"/>
               </a:ext>
             </a:extLst>
           </p:cNvPr>
@@ -3512,7 +3512,7 @@
           <p:cNvPr id="2" name="">
             <a:extLst xmlns:a="http://schemas.openxmlformats.org/drawingml/2006/main">
               <a:ext uri="{FF2B5EF4-FFF2-40B4-BE49-F238E27FC236}">
-                <a16:creationId xmlns:a16="http://schemas.microsoft.com/office/drawing/2014/main" id="{BA2E749C-CA0E-49E6-A0AE-8CFFC5725581}"/>
+                <a16:creationId xmlns:a16="http://schemas.microsoft.com/office/drawing/2014/main" id="{7C2291A5-7794-40A9-A4EC-727F157BFDA9}"/>
               </a:ext>
             </a:extLst>
           </p:cNvPr>
@@ -3570,7 +3570,7 @@
           <p:cNvPr id="3" name="">
             <a:extLst xmlns:a="http://schemas.openxmlformats.org/drawingml/2006/main">
               <a:ext uri="{FF2B5EF4-FFF2-40B4-BE49-F238E27FC236}">
-                <a16:creationId xmlns:a16="http://schemas.microsoft.com/office/drawing/2014/main" id="{E9913DE8-9485-426A-A519-6E8F1C53ED03}"/>
+                <a16:creationId xmlns:a16="http://schemas.microsoft.com/office/drawing/2014/main" id="{B01BE3C5-83A0-4252-A9E1-2624B65CFE8A}"/>
               </a:ext>
             </a:extLst>
           </p:cNvPr>
@@ -3628,7 +3628,7 @@
           <p:cNvPr id="4" name="">
             <a:extLst xmlns:a="http://schemas.openxmlformats.org/drawingml/2006/main">
               <a:ext uri="{FF2B5EF4-FFF2-40B4-BE49-F238E27FC236}">
-                <a16:creationId xmlns:a16="http://schemas.microsoft.com/office/drawing/2014/main" id="{AF5E682E-CBA7-42DE-88AE-F9ACB7650C2F}"/>
+                <a16:creationId xmlns:a16="http://schemas.microsoft.com/office/drawing/2014/main" id="{5BF073FB-88DF-4672-9770-5BC1F8BE10C9}"/>
               </a:ext>
             </a:extLst>
           </p:cNvPr>
@@ -3686,7 +3686,7 @@
           <p:cNvPr id="5" name="">
             <a:extLst xmlns:a="http://schemas.openxmlformats.org/drawingml/2006/main">
               <a:ext uri="{FF2B5EF4-FFF2-40B4-BE49-F238E27FC236}">
-                <a16:creationId xmlns:a16="http://schemas.microsoft.com/office/drawing/2014/main" id="{851D80C7-4F31-468A-AA06-E6DE9CAE274C}"/>
+                <a16:creationId xmlns:a16="http://schemas.microsoft.com/office/drawing/2014/main" id="{F89F0A21-D17C-43E4-85D3-B0DADFCD93C0}"/>
               </a:ext>
             </a:extLst>
           </p:cNvPr>
@@ -3767,7 +3767,7 @@
           <p:cNvPr id="6" name="">
             <a:extLst xmlns:a="http://schemas.openxmlformats.org/drawingml/2006/main">
               <a:ext uri="{FF2B5EF4-FFF2-40B4-BE49-F238E27FC236}">
-                <a16:creationId xmlns:a16="http://schemas.microsoft.com/office/drawing/2014/main" id="{36D7D179-DE1C-4745-8272-8AA5E1F59FFB}"/>
+                <a16:creationId xmlns:a16="http://schemas.microsoft.com/office/drawing/2014/main" id="{CCB6E4D9-B68A-487F-9DB2-6DE1F56E55CB}"/>
               </a:ext>
             </a:extLst>
           </p:cNvPr>
@@ -3848,7 +3848,7 @@
           <p:cNvPr id="7" name="">
             <a:extLst xmlns:a="http://schemas.openxmlformats.org/drawingml/2006/main">
               <a:ext uri="{FF2B5EF4-FFF2-40B4-BE49-F238E27FC236}">
-                <a16:creationId xmlns:a16="http://schemas.microsoft.com/office/drawing/2014/main" id="{7FA246E6-797D-4071-AD23-12B68D3BC65E}"/>
+                <a16:creationId xmlns:a16="http://schemas.microsoft.com/office/drawing/2014/main" id="{B82FE3E8-5F9B-4B79-84E5-F919F51B0D7E}"/>
               </a:ext>
             </a:extLst>
           </p:cNvPr>
@@ -3929,7 +3929,7 @@
           <p:cNvPr id="8" name="">
             <a:extLst xmlns:a="http://schemas.openxmlformats.org/drawingml/2006/main">
               <a:ext uri="{FF2B5EF4-FFF2-40B4-BE49-F238E27FC236}">
-                <a16:creationId xmlns:a16="http://schemas.microsoft.com/office/drawing/2014/main" id="{18D95CBA-C34D-4614-8310-C647D71C655B}"/>
+                <a16:creationId xmlns:a16="http://schemas.microsoft.com/office/drawing/2014/main" id="{26E226C8-0515-4DB3-A684-D1728E0D0D9D}"/>
               </a:ext>
             </a:extLst>
           </p:cNvPr>
@@ -4010,7 +4010,7 @@
           <p:cNvPr id="9" name="">
             <a:extLst xmlns:a="http://schemas.openxmlformats.org/drawingml/2006/main">
               <a:ext uri="{FF2B5EF4-FFF2-40B4-BE49-F238E27FC236}">
-                <a16:creationId xmlns:a16="http://schemas.microsoft.com/office/drawing/2014/main" id="{7FA0D75A-8354-40E5-8180-062332F2E2A9}"/>
+                <a16:creationId xmlns:a16="http://schemas.microsoft.com/office/drawing/2014/main" id="{0AF77A44-82BF-4D27-A8AB-30115C998BF0}"/>
               </a:ext>
             </a:extLst>
           </p:cNvPr>
@@ -4091,7 +4091,7 @@
           <p:cNvPr id="10" name="">
             <a:extLst xmlns:a="http://schemas.openxmlformats.org/drawingml/2006/main">
               <a:ext uri="{FF2B5EF4-FFF2-40B4-BE49-F238E27FC236}">
-                <a16:creationId xmlns:a16="http://schemas.microsoft.com/office/drawing/2014/main" id="{29E300ED-343E-4412-99B2-5E9AFAD36DB8}"/>
+                <a16:creationId xmlns:a16="http://schemas.microsoft.com/office/drawing/2014/main" id="{B688ECD0-359B-4BF3-8F2A-83A0B6691B3F}"/>
               </a:ext>
             </a:extLst>
           </p:cNvPr>
@@ -4155,7 +4155,7 @@
           <p:cNvPr id="11" name="">
             <a:extLst xmlns:a="http://schemas.openxmlformats.org/drawingml/2006/main">
               <a:ext uri="{FF2B5EF4-FFF2-40B4-BE49-F238E27FC236}">
-                <a16:creationId xmlns:a16="http://schemas.microsoft.com/office/drawing/2014/main" id="{65292992-A382-42B0-B6FE-483D33871E17}"/>
+                <a16:creationId xmlns:a16="http://schemas.microsoft.com/office/drawing/2014/main" id="{5604B26D-2B5C-487E-9A90-71E90C81D4E6}"/>
               </a:ext>
             </a:extLst>
           </p:cNvPr>
@@ -4291,7 +4291,7 @@
           <p:cNvPr id="12" name="">
             <a:extLst xmlns:a="http://schemas.openxmlformats.org/drawingml/2006/main">
               <a:ext uri="{FF2B5EF4-FFF2-40B4-BE49-F238E27FC236}">
-                <a16:creationId xmlns:a16="http://schemas.microsoft.com/office/drawing/2014/main" id="{A6A53D04-3F7F-4E43-9F97-8ED1EEE475D1}"/>
+                <a16:creationId xmlns:a16="http://schemas.microsoft.com/office/drawing/2014/main" id="{4786AD90-5C4C-4D54-9252-FA2EFF215EA0}"/>
               </a:ext>
             </a:extLst>
           </p:cNvPr>
@@ -4355,7 +4355,7 @@
           <p:cNvPr id="13" name="">
             <a:extLst xmlns:a="http://schemas.openxmlformats.org/drawingml/2006/main">
               <a:ext uri="{FF2B5EF4-FFF2-40B4-BE49-F238E27FC236}">
-                <a16:creationId xmlns:a16="http://schemas.microsoft.com/office/drawing/2014/main" id="{57B735C9-ABFC-4E8A-B609-8798748123F5}"/>
+                <a16:creationId xmlns:a16="http://schemas.microsoft.com/office/drawing/2014/main" id="{172F5A8B-088F-4F50-B381-4991F7C40A74}"/>
               </a:ext>
             </a:extLst>
           </p:cNvPr>
@@ -4474,7 +4474,7 @@
           <p:cNvPr id="14" name="">
             <a:extLst xmlns:a="http://schemas.openxmlformats.org/drawingml/2006/main">
               <a:ext uri="{FF2B5EF4-FFF2-40B4-BE49-F238E27FC236}">
-                <a16:creationId xmlns:a16="http://schemas.microsoft.com/office/drawing/2014/main" id="{D53E83C2-1210-4053-A650-A4DC9E51B304}"/>
+                <a16:creationId xmlns:a16="http://schemas.microsoft.com/office/drawing/2014/main" id="{DAB115BA-D300-4AD0-A694-DAE8D29A2A44}"/>
               </a:ext>
             </a:extLst>
           </p:cNvPr>
@@ -4530,7 +4530,7 @@
     </p:spTree>
     <p:extLst>
       <p:ext uri="{BB962C8B-B14F-4D97-AF65-F5344CB8AC3E}">
-        <p14:creationId xmlns:p14="http://schemas.microsoft.com/office/powerpoint/2010/main" val="2025540152"/>
+        <p14:creationId xmlns:p14="http://schemas.microsoft.com/office/powerpoint/2010/main" val="244813215"/>
       </p:ext>
     </p:extLst>
   </p:cSld>
@@ -4561,7 +4561,7 @@
           <p:cNvPr id="10" name="">
             <a:extLst xmlns:a="http://schemas.openxmlformats.org/drawingml/2006/main">
               <a:ext uri="{FF2B5EF4-FFF2-40B4-BE49-F238E27FC236}">
-                <a16:creationId xmlns:a16="http://schemas.microsoft.com/office/drawing/2014/main" id="{7A36C6D8-E986-4394-B597-B122D205910C}"/>
+                <a16:creationId xmlns:a16="http://schemas.microsoft.com/office/drawing/2014/main" id="{C2325449-CCF9-4416-9785-44F91498C0F0}"/>
               </a:ext>
             </a:extLst>
           </p:cNvPr>
@@ -4619,7 +4619,7 @@
           <p:cNvPr id="2" name="">
             <a:extLst xmlns:a="http://schemas.openxmlformats.org/drawingml/2006/main">
               <a:ext uri="{FF2B5EF4-FFF2-40B4-BE49-F238E27FC236}">
-                <a16:creationId xmlns:a16="http://schemas.microsoft.com/office/drawing/2014/main" id="{5A6DAE6A-B38F-4626-A733-A83FE0365507}"/>
+                <a16:creationId xmlns:a16="http://schemas.microsoft.com/office/drawing/2014/main" id="{C9F91C7C-0BC1-44C0-A166-A79A8471761D}"/>
               </a:ext>
             </a:extLst>
           </p:cNvPr>
@@ -4677,7 +4677,7 @@
           <p:cNvPr id="3" name="">
             <a:extLst xmlns:a="http://schemas.openxmlformats.org/drawingml/2006/main">
               <a:ext uri="{FF2B5EF4-FFF2-40B4-BE49-F238E27FC236}">
-                <a16:creationId xmlns:a16="http://schemas.microsoft.com/office/drawing/2014/main" id="{877E1437-DC2D-4654-9BC6-3C1EC3322989}"/>
+                <a16:creationId xmlns:a16="http://schemas.microsoft.com/office/drawing/2014/main" id="{38111048-78D0-427A-B58B-FEB6D09A7838}"/>
               </a:ext>
             </a:extLst>
           </p:cNvPr>
@@ -4735,7 +4735,7 @@
           <p:cNvPr id="4" name="">
             <a:extLst xmlns:a="http://schemas.openxmlformats.org/drawingml/2006/main">
               <a:ext uri="{FF2B5EF4-FFF2-40B4-BE49-F238E27FC236}">
-                <a16:creationId xmlns:a16="http://schemas.microsoft.com/office/drawing/2014/main" id="{3C83FFDF-0DFC-4C42-99BA-3B3ABDD1516F}"/>
+                <a16:creationId xmlns:a16="http://schemas.microsoft.com/office/drawing/2014/main" id="{A1899508-A6B0-4362-AB66-CEB0787B3848}"/>
               </a:ext>
             </a:extLst>
           </p:cNvPr>
@@ -4793,7 +4793,7 @@
           <p:cNvPr id="5" name="">
             <a:extLst xmlns:a="http://schemas.openxmlformats.org/drawingml/2006/main">
               <a:ext uri="{FF2B5EF4-FFF2-40B4-BE49-F238E27FC236}">
-                <a16:creationId xmlns:a16="http://schemas.microsoft.com/office/drawing/2014/main" id="{9672B0B8-528C-4DA8-8F38-F1771D04F89E}"/>
+                <a16:creationId xmlns:a16="http://schemas.microsoft.com/office/drawing/2014/main" id="{4A3CAFE8-046E-4EBE-9E23-C76BAEFE8F5F}"/>
               </a:ext>
             </a:extLst>
           </p:cNvPr>
@@ -4857,7 +4857,7 @@
           <p:cNvPr id="6" name="">
             <a:extLst xmlns:a="http://schemas.openxmlformats.org/drawingml/2006/main">
               <a:ext uri="{FF2B5EF4-FFF2-40B4-BE49-F238E27FC236}">
-                <a16:creationId xmlns:a16="http://schemas.microsoft.com/office/drawing/2014/main" id="{0EF2BACF-5E6A-480A-A439-8599183D6A54}"/>
+                <a16:creationId xmlns:a16="http://schemas.microsoft.com/office/drawing/2014/main" id="{4536F0C9-D52E-4AAA-8F87-75BF3C91416B}"/>
               </a:ext>
             </a:extLst>
           </p:cNvPr>
@@ -4983,7 +4983,7 @@
           <p:cNvPr id="7" name="">
             <a:extLst xmlns:a="http://schemas.openxmlformats.org/drawingml/2006/main">
               <a:ext uri="{FF2B5EF4-FFF2-40B4-BE49-F238E27FC236}">
-                <a16:creationId xmlns:a16="http://schemas.microsoft.com/office/drawing/2014/main" id="{15440B09-330D-45E0-B9EE-6B78952BF148}"/>
+                <a16:creationId xmlns:a16="http://schemas.microsoft.com/office/drawing/2014/main" id="{DF1A0DF4-0B58-440F-9372-B8C71E5E868D}"/>
               </a:ext>
             </a:extLst>
           </p:cNvPr>
@@ -5047,7 +5047,7 @@
           <p:cNvPr id="8" name="">
             <a:extLst xmlns:a="http://schemas.openxmlformats.org/drawingml/2006/main">
               <a:ext uri="{FF2B5EF4-FFF2-40B4-BE49-F238E27FC236}">
-                <a16:creationId xmlns:a16="http://schemas.microsoft.com/office/drawing/2014/main" id="{4FF17234-4A2F-481C-A195-3FCC7C44E312}"/>
+                <a16:creationId xmlns:a16="http://schemas.microsoft.com/office/drawing/2014/main" id="{8AF9DE77-A026-47DC-9350-03835B790DF7}"/>
               </a:ext>
             </a:extLst>
           </p:cNvPr>
@@ -5193,7 +5193,7 @@
           <p:cNvPr id="9" name="">
             <a:extLst xmlns:a="http://schemas.openxmlformats.org/drawingml/2006/main">
               <a:ext uri="{FF2B5EF4-FFF2-40B4-BE49-F238E27FC236}">
-                <a16:creationId xmlns:a16="http://schemas.microsoft.com/office/drawing/2014/main" id="{41FC7EA2-0BE1-4DFD-A912-385E9F7C1E0C}"/>
+                <a16:creationId xmlns:a16="http://schemas.microsoft.com/office/drawing/2014/main" id="{946AA991-E013-430D-B686-9B8B6AD63933}"/>
               </a:ext>
             </a:extLst>
           </p:cNvPr>
@@ -5249,7 +5249,7 @@
     </p:spTree>
     <p:extLst>
       <p:ext uri="{BB962C8B-B14F-4D97-AF65-F5344CB8AC3E}">
-        <p14:creationId xmlns:p14="http://schemas.microsoft.com/office/powerpoint/2010/main" val="1618012221"/>
+        <p14:creationId xmlns:p14="http://schemas.microsoft.com/office/powerpoint/2010/main" val="1477964489"/>
       </p:ext>
     </p:extLst>
   </p:cSld>
@@ -5280,7 +5280,7 @@
           <p:cNvPr id="10" name="">
             <a:extLst xmlns:a="http://schemas.openxmlformats.org/drawingml/2006/main">
               <a:ext uri="{FF2B5EF4-FFF2-40B4-BE49-F238E27FC236}">
-                <a16:creationId xmlns:a16="http://schemas.microsoft.com/office/drawing/2014/main" id="{91A62884-9EDF-4CFF-8713-35D2B2519BDC}"/>
+                <a16:creationId xmlns:a16="http://schemas.microsoft.com/office/drawing/2014/main" id="{6D51471F-6000-4027-9F4F-0D8DFD26DA01}"/>
               </a:ext>
             </a:extLst>
           </p:cNvPr>
@@ -5338,7 +5338,7 @@
           <p:cNvPr id="2" name="">
             <a:extLst xmlns:a="http://schemas.openxmlformats.org/drawingml/2006/main">
               <a:ext uri="{FF2B5EF4-FFF2-40B4-BE49-F238E27FC236}">
-                <a16:creationId xmlns:a16="http://schemas.microsoft.com/office/drawing/2014/main" id="{04BFC37A-10AB-4151-B732-68A7D5071E32}"/>
+                <a16:creationId xmlns:a16="http://schemas.microsoft.com/office/drawing/2014/main" id="{5DED00FC-7C02-4174-ADB6-B032EE093D9B}"/>
               </a:ext>
             </a:extLst>
           </p:cNvPr>
@@ -5396,7 +5396,7 @@
           <p:cNvPr id="3" name="">
             <a:extLst xmlns:a="http://schemas.openxmlformats.org/drawingml/2006/main">
               <a:ext uri="{FF2B5EF4-FFF2-40B4-BE49-F238E27FC236}">
-                <a16:creationId xmlns:a16="http://schemas.microsoft.com/office/drawing/2014/main" id="{F989979C-F220-45E1-8234-CA98CE27DBA5}"/>
+                <a16:creationId xmlns:a16="http://schemas.microsoft.com/office/drawing/2014/main" id="{0CA66AB8-9930-46F1-9D4C-0C249D668DE3}"/>
               </a:ext>
             </a:extLst>
           </p:cNvPr>
@@ -5454,7 +5454,7 @@
           <p:cNvPr id="4" name="">
             <a:extLst xmlns:a="http://schemas.openxmlformats.org/drawingml/2006/main">
               <a:ext uri="{FF2B5EF4-FFF2-40B4-BE49-F238E27FC236}">
-                <a16:creationId xmlns:a16="http://schemas.microsoft.com/office/drawing/2014/main" id="{2FE0D1D8-299A-45DF-B820-A15DEB9A9B04}"/>
+                <a16:creationId xmlns:a16="http://schemas.microsoft.com/office/drawing/2014/main" id="{47A935BB-108C-4F57-8214-F842FA13A8D3}"/>
               </a:ext>
             </a:extLst>
           </p:cNvPr>
@@ -5512,7 +5512,7 @@
           <p:cNvPr id="5" name="">
             <a:extLst xmlns:a="http://schemas.openxmlformats.org/drawingml/2006/main">
               <a:ext uri="{FF2B5EF4-FFF2-40B4-BE49-F238E27FC236}">
-                <a16:creationId xmlns:a16="http://schemas.microsoft.com/office/drawing/2014/main" id="{3F45D6FF-830C-4D74-8E36-74CD75FC6807}"/>
+                <a16:creationId xmlns:a16="http://schemas.microsoft.com/office/drawing/2014/main" id="{302867C3-5F88-4FA0-A382-7E33C54517A6}"/>
               </a:ext>
             </a:extLst>
           </p:cNvPr>
@@ -5560,7 +5560,7 @@
                   <a:srgbClr val="0D1B26"/>
                 </a:solidFill>
               </a:rPr>
-              <a:t>Ops labor                         $6,000.00</a:t>
+              <a:t>LLM serving                       $5,452.37</a:t>
             </a:r>
           </a:p>
           <a:p xmlns:a="http://schemas.openxmlformats.org/drawingml/2006/main">
@@ -5577,7 +5577,7 @@
                   <a:srgbClr val="0D1B26"/>
                 </a:solidFill>
               </a:rPr>
-              <a:t>LLM serving                       $5,452.37</a:t>
+              <a:t>Tú: security/sandbox/ops          $2,321.63</a:t>
             </a:r>
           </a:p>
           <a:p xmlns:a="http://schemas.openxmlformats.org/drawingml/2006/main">
@@ -5594,7 +5594,7 @@
                   <a:srgbClr val="0D1B26"/>
                 </a:solidFill>
               </a:rPr>
-              <a:t>Tú: security/sandbox/ops          $2,321.63</a:t>
+              <a:t>Thành: data/cloud/DR              $1,436.46</a:t>
             </a:r>
           </a:p>
           <a:p xmlns:a="http://schemas.openxmlformats.org/drawingml/2006/main">
@@ -5611,7 +5611,7 @@
                   <a:srgbClr val="0D1B26"/>
                 </a:solidFill>
               </a:rPr>
-              <a:t>Thành: data/cloud/DR              $1,436.46</a:t>
+              <a:t>Contingency 10%                   $924.94</a:t>
             </a:r>
           </a:p>
           <a:p xmlns:a="http://schemas.openxmlformats.org/drawingml/2006/main">
@@ -5628,7 +5628,7 @@
                   <a:srgbClr val="0D1B26"/>
                 </a:solidFill>
               </a:rPr>
-              <a:t>Contingency 10%                   $1,524.94</a:t>
+              <a:t>Embedding + gateway + licenses    $38.96</a:t>
             </a:r>
           </a:p>
           <a:p xmlns:a="http://schemas.openxmlformats.org/drawingml/2006/main">
@@ -5645,7 +5645,7 @@
                   <a:srgbClr val="0D1B26"/>
                 </a:solidFill>
               </a:rPr>
-              <a:t>Embedding + gateway + licenses    $38.96</a:t>
+              <a:t>Ops labor                         excluded</a:t>
             </a:r>
           </a:p>
           <a:p xmlns:a="http://schemas.openxmlformats.org/drawingml/2006/main">
@@ -5679,7 +5679,7 @@
                   <a:srgbClr val="0D1B26"/>
                 </a:solidFill>
               </a:rPr>
-              <a:t>TOTAL                             $16,774.36</a:t>
+              <a:t>TOTAL                             $10,174.36</a:t>
             </a:r>
           </a:p>
           <a:p xmlns:a="http://schemas.openxmlformats.org/drawingml/2006/main">
@@ -5701,7 +5701,7 @@
                   <a:srgbClr val="0D1B26"/>
                 </a:solidFill>
               </a:rPr>
-              <a:t>$8.39 / DAU / month</a:t>
+              <a:t>$5.09 / DAU / month</a:t>
             </a:r>
           </a:p>
         </p:txBody>
@@ -5711,7 +5711,7 @@
           <p:cNvPr id="6" name="">
             <a:extLst xmlns:a="http://schemas.openxmlformats.org/drawingml/2006/main">
               <a:ext uri="{FF2B5EF4-FFF2-40B4-BE49-F238E27FC236}">
-                <a16:creationId xmlns:a16="http://schemas.microsoft.com/office/drawing/2014/main" id="{D8885452-B96A-4229-8B43-A39B78C0F4C7}"/>
+                <a16:creationId xmlns:a16="http://schemas.microsoft.com/office/drawing/2014/main" id="{4D3F1049-8BD6-48E3-B3EA-C514075481B7}"/>
               </a:ext>
             </a:extLst>
           </p:cNvPr>
@@ -5782,7 +5782,7 @@
                   <a:srgbClr val="0D1B26"/>
                 </a:solidFill>
               </a:rPr>
-              <a:t>$15,249.42</a:t>
+              <a:t>$9,249.42</a:t>
             </a:r>
           </a:p>
         </p:txBody>
@@ -5792,7 +5792,7 @@
           <p:cNvPr id="7" name="">
             <a:extLst xmlns:a="http://schemas.openxmlformats.org/drawingml/2006/main">
               <a:ext uri="{FF2B5EF4-FFF2-40B4-BE49-F238E27FC236}">
-                <a16:creationId xmlns:a16="http://schemas.microsoft.com/office/drawing/2014/main" id="{755BC680-75D3-40DD-8E79-BFE8B48BE181}"/>
+                <a16:creationId xmlns:a16="http://schemas.microsoft.com/office/drawing/2014/main" id="{BA093B20-6516-4A85-96F1-94D3FD126CD7}"/>
               </a:ext>
             </a:extLst>
           </p:cNvPr>
@@ -5863,7 +5863,7 @@
                   <a:srgbClr val="0D1B26"/>
                 </a:solidFill>
               </a:rPr>
-              <a:t>$1,524.94</a:t>
+              <a:t>$924.94</a:t>
             </a:r>
           </a:p>
         </p:txBody>
@@ -5873,7 +5873,7 @@
           <p:cNvPr id="8" name="">
             <a:extLst xmlns:a="http://schemas.openxmlformats.org/drawingml/2006/main">
               <a:ext uri="{FF2B5EF4-FFF2-40B4-BE49-F238E27FC236}">
-                <a16:creationId xmlns:a16="http://schemas.microsoft.com/office/drawing/2014/main" id="{256EAA24-7455-485D-BCC8-3E9D89C8C4B1}"/>
+                <a16:creationId xmlns:a16="http://schemas.microsoft.com/office/drawing/2014/main" id="{E157645A-3B0A-4FB4-A2FB-7655343C9A2E}"/>
               </a:ext>
             </a:extLst>
           </p:cNvPr>
@@ -5931,7 +5931,7 @@
           <p:cNvPr id="9" name="">
             <a:extLst xmlns:a="http://schemas.openxmlformats.org/drawingml/2006/main">
               <a:ext uri="{FF2B5EF4-FFF2-40B4-BE49-F238E27FC236}">
-                <a16:creationId xmlns:a16="http://schemas.microsoft.com/office/drawing/2014/main" id="{7DBBE72C-AECE-4317-837B-6B5E44DEEFB8}"/>
+                <a16:creationId xmlns:a16="http://schemas.microsoft.com/office/drawing/2014/main" id="{0E61CBF9-8D0A-4DD5-A4DE-F9C04EB201F7}"/>
               </a:ext>
             </a:extLst>
           </p:cNvPr>
@@ -5987,7 +5987,7 @@
     </p:spTree>
     <p:extLst>
       <p:ext uri="{BB962C8B-B14F-4D97-AF65-F5344CB8AC3E}">
-        <p14:creationId xmlns:p14="http://schemas.microsoft.com/office/powerpoint/2010/main" val="148531080"/>
+        <p14:creationId xmlns:p14="http://schemas.microsoft.com/office/powerpoint/2010/main" val="1094539140"/>
       </p:ext>
     </p:extLst>
   </p:cSld>
@@ -6018,7 +6018,7 @@
           <p:cNvPr id="11" name="">
             <a:extLst xmlns:a="http://schemas.openxmlformats.org/drawingml/2006/main">
               <a:ext uri="{FF2B5EF4-FFF2-40B4-BE49-F238E27FC236}">
-                <a16:creationId xmlns:a16="http://schemas.microsoft.com/office/drawing/2014/main" id="{AE91C28F-E719-4CDF-8D70-AD6421D46FBA}"/>
+                <a16:creationId xmlns:a16="http://schemas.microsoft.com/office/drawing/2014/main" id="{2F3A83A0-A7FD-4CEB-B53C-F9EA47E1EAC7}"/>
               </a:ext>
             </a:extLst>
           </p:cNvPr>
@@ -6076,7 +6076,7 @@
           <p:cNvPr id="2" name="">
             <a:extLst xmlns:a="http://schemas.openxmlformats.org/drawingml/2006/main">
               <a:ext uri="{FF2B5EF4-FFF2-40B4-BE49-F238E27FC236}">
-                <a16:creationId xmlns:a16="http://schemas.microsoft.com/office/drawing/2014/main" id="{782C76A6-B1C1-4FA6-8517-85EDAAA0B590}"/>
+                <a16:creationId xmlns:a16="http://schemas.microsoft.com/office/drawing/2014/main" id="{BFB4BE62-FCB9-45EF-82CF-2C6B5BE5711C}"/>
               </a:ext>
             </a:extLst>
           </p:cNvPr>
@@ -6134,7 +6134,7 @@
           <p:cNvPr id="3" name="">
             <a:extLst xmlns:a="http://schemas.openxmlformats.org/drawingml/2006/main">
               <a:ext uri="{FF2B5EF4-FFF2-40B4-BE49-F238E27FC236}">
-                <a16:creationId xmlns:a16="http://schemas.microsoft.com/office/drawing/2014/main" id="{CF438EB3-F064-4BC2-9C4D-A475604D51CD}"/>
+                <a16:creationId xmlns:a16="http://schemas.microsoft.com/office/drawing/2014/main" id="{C4DBE380-D50E-4BD7-B3BE-6BC216753253}"/>
               </a:ext>
             </a:extLst>
           </p:cNvPr>
@@ -6192,7 +6192,7 @@
           <p:cNvPr id="4" name="">
             <a:extLst xmlns:a="http://schemas.openxmlformats.org/drawingml/2006/main">
               <a:ext uri="{FF2B5EF4-FFF2-40B4-BE49-F238E27FC236}">
-                <a16:creationId xmlns:a16="http://schemas.microsoft.com/office/drawing/2014/main" id="{B04F17F3-D781-4EDD-A9C8-0B70A31431F5}"/>
+                <a16:creationId xmlns:a16="http://schemas.microsoft.com/office/drawing/2014/main" id="{9293E3A9-E7C3-46CB-9567-C0AC430C8F23}"/>
               </a:ext>
             </a:extLst>
           </p:cNvPr>
@@ -6250,7 +6250,7 @@
           <p:cNvPr id="5" name="">
             <a:extLst xmlns:a="http://schemas.openxmlformats.org/drawingml/2006/main">
               <a:ext uri="{FF2B5EF4-FFF2-40B4-BE49-F238E27FC236}">
-                <a16:creationId xmlns:a16="http://schemas.microsoft.com/office/drawing/2014/main" id="{A5F24C62-CD4A-4243-A370-FF0D16ECD952}"/>
+                <a16:creationId xmlns:a16="http://schemas.microsoft.com/office/drawing/2014/main" id="{16D9177E-9536-4BA8-B0E6-AB45A2DB72F3}"/>
               </a:ext>
             </a:extLst>
           </p:cNvPr>
@@ -6314,7 +6314,7 @@
           <p:cNvPr id="6" name="">
             <a:extLst xmlns:a="http://schemas.openxmlformats.org/drawingml/2006/main">
               <a:ext uri="{FF2B5EF4-FFF2-40B4-BE49-F238E27FC236}">
-                <a16:creationId xmlns:a16="http://schemas.microsoft.com/office/drawing/2014/main" id="{63F0A9FF-B585-4DDA-A77E-2FD7119E48C1}"/>
+                <a16:creationId xmlns:a16="http://schemas.microsoft.com/office/drawing/2014/main" id="{D2E5AC5E-214E-48E9-9DE6-500C8E11503D}"/>
               </a:ext>
             </a:extLst>
           </p:cNvPr>
@@ -6450,7 +6450,7 @@
           <p:cNvPr id="7" name="">
             <a:extLst xmlns:a="http://schemas.openxmlformats.org/drawingml/2006/main">
               <a:ext uri="{FF2B5EF4-FFF2-40B4-BE49-F238E27FC236}">
-                <a16:creationId xmlns:a16="http://schemas.microsoft.com/office/drawing/2014/main" id="{C4DA972C-4941-491D-87FB-3577E3A4D44D}"/>
+                <a16:creationId xmlns:a16="http://schemas.microsoft.com/office/drawing/2014/main" id="{1DA37DE2-70AB-4A0A-A500-C0467F55ACE6}"/>
               </a:ext>
             </a:extLst>
           </p:cNvPr>
@@ -6514,7 +6514,7 @@
           <p:cNvPr id="8" name="">
             <a:extLst xmlns:a="http://schemas.openxmlformats.org/drawingml/2006/main">
               <a:ext uri="{FF2B5EF4-FFF2-40B4-BE49-F238E27FC236}">
-                <a16:creationId xmlns:a16="http://schemas.microsoft.com/office/drawing/2014/main" id="{1541F4CF-3215-4D01-AC02-BBB3B297B747}"/>
+                <a16:creationId xmlns:a16="http://schemas.microsoft.com/office/drawing/2014/main" id="{FADF6E37-BD57-4A67-91C3-2734E4A9A645}"/>
               </a:ext>
             </a:extLst>
           </p:cNvPr>
@@ -6616,7 +6616,7 @@
           <p:cNvPr id="9" name="">
             <a:extLst xmlns:a="http://schemas.openxmlformats.org/drawingml/2006/main">
               <a:ext uri="{FF2B5EF4-FFF2-40B4-BE49-F238E27FC236}">
-                <a16:creationId xmlns:a16="http://schemas.microsoft.com/office/drawing/2014/main" id="{00A8BACC-4474-4722-963C-5BD2CF3F7CEB}"/>
+                <a16:creationId xmlns:a16="http://schemas.microsoft.com/office/drawing/2014/main" id="{70FDA829-2618-41DF-BEFE-1725F12B5FDB}"/>
               </a:ext>
             </a:extLst>
           </p:cNvPr>
@@ -6674,7 +6674,7 @@
           <p:cNvPr id="10" name="">
             <a:extLst xmlns:a="http://schemas.openxmlformats.org/drawingml/2006/main">
               <a:ext uri="{FF2B5EF4-FFF2-40B4-BE49-F238E27FC236}">
-                <a16:creationId xmlns:a16="http://schemas.microsoft.com/office/drawing/2014/main" id="{F2EBF313-1F1F-4EA3-9479-46990F88ED1D}"/>
+                <a16:creationId xmlns:a16="http://schemas.microsoft.com/office/drawing/2014/main" id="{04483F5A-438B-43E1-AA3B-6DB8D157DD6D}"/>
               </a:ext>
             </a:extLst>
           </p:cNvPr>
@@ -6730,7 +6730,7 @@
     </p:spTree>
     <p:extLst>
       <p:ext uri="{BB962C8B-B14F-4D97-AF65-F5344CB8AC3E}">
-        <p14:creationId xmlns:p14="http://schemas.microsoft.com/office/powerpoint/2010/main" val="193358534"/>
+        <p14:creationId xmlns:p14="http://schemas.microsoft.com/office/powerpoint/2010/main" val="1001868612"/>
       </p:ext>
     </p:extLst>
   </p:cSld>
@@ -6761,7 +6761,7 @@
           <p:cNvPr id="20" name="">
             <a:extLst xmlns:a="http://schemas.openxmlformats.org/drawingml/2006/main">
               <a:ext uri="{FF2B5EF4-FFF2-40B4-BE49-F238E27FC236}">
-                <a16:creationId xmlns:a16="http://schemas.microsoft.com/office/drawing/2014/main" id="{169634AE-9A7C-443E-AFA1-280F98DE64B8}"/>
+                <a16:creationId xmlns:a16="http://schemas.microsoft.com/office/drawing/2014/main" id="{964C02BD-FBF5-4CDD-AA42-8A58BBF8D1F6}"/>
               </a:ext>
             </a:extLst>
           </p:cNvPr>
@@ -6819,7 +6819,7 @@
           <p:cNvPr id="2" name="">
             <a:extLst xmlns:a="http://schemas.openxmlformats.org/drawingml/2006/main">
               <a:ext uri="{FF2B5EF4-FFF2-40B4-BE49-F238E27FC236}">
-                <a16:creationId xmlns:a16="http://schemas.microsoft.com/office/drawing/2014/main" id="{DAA83A7F-5D96-4FCC-A048-0D89BA542572}"/>
+                <a16:creationId xmlns:a16="http://schemas.microsoft.com/office/drawing/2014/main" id="{341F9D2C-1D8C-4C5A-A852-D589A2B8A84B}"/>
               </a:ext>
             </a:extLst>
           </p:cNvPr>
@@ -6877,7 +6877,7 @@
           <p:cNvPr id="3" name="">
             <a:extLst xmlns:a="http://schemas.openxmlformats.org/drawingml/2006/main">
               <a:ext uri="{FF2B5EF4-FFF2-40B4-BE49-F238E27FC236}">
-                <a16:creationId xmlns:a16="http://schemas.microsoft.com/office/drawing/2014/main" id="{7EEB7DD1-4F4D-4E14-A7A9-0A21278CB837}"/>
+                <a16:creationId xmlns:a16="http://schemas.microsoft.com/office/drawing/2014/main" id="{113B5B63-853B-4904-BE46-21266282CD3D}"/>
               </a:ext>
             </a:extLst>
           </p:cNvPr>
@@ -6935,7 +6935,7 @@
           <p:cNvPr id="4" name="">
             <a:extLst xmlns:a="http://schemas.openxmlformats.org/drawingml/2006/main">
               <a:ext uri="{FF2B5EF4-FFF2-40B4-BE49-F238E27FC236}">
-                <a16:creationId xmlns:a16="http://schemas.microsoft.com/office/drawing/2014/main" id="{F464A3F0-9703-4B14-8A01-F88E646F8755}"/>
+                <a16:creationId xmlns:a16="http://schemas.microsoft.com/office/drawing/2014/main" id="{512C276E-7E01-4D8E-ADE4-6AC6DD60C04B}"/>
               </a:ext>
             </a:extLst>
           </p:cNvPr>
@@ -6993,7 +6993,7 @@
           <p:cNvPr id="5" name="">
             <a:extLst xmlns:a="http://schemas.openxmlformats.org/drawingml/2006/main">
               <a:ext uri="{FF2B5EF4-FFF2-40B4-BE49-F238E27FC236}">
-                <a16:creationId xmlns:a16="http://schemas.microsoft.com/office/drawing/2014/main" id="{1F085A9D-36B5-4211-A2E9-AE3BC86E7A96}"/>
+                <a16:creationId xmlns:a16="http://schemas.microsoft.com/office/drawing/2014/main" id="{6EE766BD-D709-464E-A826-2F746111B184}"/>
               </a:ext>
             </a:extLst>
           </p:cNvPr>
@@ -7091,7 +7091,7 @@
           <p:cNvPr id="6" name="">
             <a:extLst xmlns:a="http://schemas.openxmlformats.org/drawingml/2006/main">
               <a:ext uri="{FF2B5EF4-FFF2-40B4-BE49-F238E27FC236}">
-                <a16:creationId xmlns:a16="http://schemas.microsoft.com/office/drawing/2014/main" id="{8C0988DC-823C-4327-B6E9-F2ADDD989C42}"/>
+                <a16:creationId xmlns:a16="http://schemas.microsoft.com/office/drawing/2014/main" id="{76D928CC-FC3A-4605-A149-2ACE7C90D59C}"/>
               </a:ext>
             </a:extLst>
           </p:cNvPr>
@@ -7149,7 +7149,7 @@
           <p:cNvPr id="7" name="">
             <a:extLst xmlns:a="http://schemas.openxmlformats.org/drawingml/2006/main">
               <a:ext uri="{FF2B5EF4-FFF2-40B4-BE49-F238E27FC236}">
-                <a16:creationId xmlns:a16="http://schemas.microsoft.com/office/drawing/2014/main" id="{9BC010E7-855C-441F-B165-EFC852A08D23}"/>
+                <a16:creationId xmlns:a16="http://schemas.microsoft.com/office/drawing/2014/main" id="{AA600929-785B-40A2-AF50-EECAD457F555}"/>
               </a:ext>
             </a:extLst>
           </p:cNvPr>
@@ -7230,7 +7230,7 @@
           <p:cNvPr id="8" name="">
             <a:extLst xmlns:a="http://schemas.openxmlformats.org/drawingml/2006/main">
               <a:ext uri="{FF2B5EF4-FFF2-40B4-BE49-F238E27FC236}">
-                <a16:creationId xmlns:a16="http://schemas.microsoft.com/office/drawing/2014/main" id="{2413F2EC-A0D9-4407-AAC0-E9291DEB2150}"/>
+                <a16:creationId xmlns:a16="http://schemas.microsoft.com/office/drawing/2014/main" id="{DA0DA92B-C6B6-4B17-BFB2-622D5B41825D}"/>
               </a:ext>
             </a:extLst>
           </p:cNvPr>
@@ -7288,7 +7288,7 @@
           <p:cNvPr id="9" name="">
             <a:extLst xmlns:a="http://schemas.openxmlformats.org/drawingml/2006/main">
               <a:ext uri="{FF2B5EF4-FFF2-40B4-BE49-F238E27FC236}">
-                <a16:creationId xmlns:a16="http://schemas.microsoft.com/office/drawing/2014/main" id="{5835EF79-AE78-4B58-88BA-5F46D7BB9E72}"/>
+                <a16:creationId xmlns:a16="http://schemas.microsoft.com/office/drawing/2014/main" id="{9AFE6EA4-C690-4399-B07A-EC80A4372E7B}"/>
               </a:ext>
             </a:extLst>
           </p:cNvPr>
@@ -7369,7 +7369,7 @@
           <p:cNvPr id="10" name="">
             <a:extLst xmlns:a="http://schemas.openxmlformats.org/drawingml/2006/main">
               <a:ext uri="{FF2B5EF4-FFF2-40B4-BE49-F238E27FC236}">
-                <a16:creationId xmlns:a16="http://schemas.microsoft.com/office/drawing/2014/main" id="{A7C4F3CE-1663-4BFF-B908-9F7BBF0EE01E}"/>
+                <a16:creationId xmlns:a16="http://schemas.microsoft.com/office/drawing/2014/main" id="{69475E52-5AF3-4A20-9261-7B491A5A6F23}"/>
               </a:ext>
             </a:extLst>
           </p:cNvPr>
@@ -7427,7 +7427,7 @@
           <p:cNvPr id="11" name="">
             <a:extLst xmlns:a="http://schemas.openxmlformats.org/drawingml/2006/main">
               <a:ext uri="{FF2B5EF4-FFF2-40B4-BE49-F238E27FC236}">
-                <a16:creationId xmlns:a16="http://schemas.microsoft.com/office/drawing/2014/main" id="{7D28159E-96E6-43D3-B2C0-FA09D18D3952}"/>
+                <a16:creationId xmlns:a16="http://schemas.microsoft.com/office/drawing/2014/main" id="{8EBCD27A-AC71-4B63-ACBE-F24F2157681F}"/>
               </a:ext>
             </a:extLst>
           </p:cNvPr>
@@ -7508,7 +7508,7 @@
           <p:cNvPr id="12" name="">
             <a:extLst xmlns:a="http://schemas.openxmlformats.org/drawingml/2006/main">
               <a:ext uri="{FF2B5EF4-FFF2-40B4-BE49-F238E27FC236}">
-                <a16:creationId xmlns:a16="http://schemas.microsoft.com/office/drawing/2014/main" id="{7E0BC3A6-C822-45CD-B3D2-B74BDD767F33}"/>
+                <a16:creationId xmlns:a16="http://schemas.microsoft.com/office/drawing/2014/main" id="{876B7679-EABF-413B-9652-33B848B00D16}"/>
               </a:ext>
             </a:extLst>
           </p:cNvPr>
@@ -7566,7 +7566,7 @@
           <p:cNvPr id="13" name="">
             <a:extLst xmlns:a="http://schemas.openxmlformats.org/drawingml/2006/main">
               <a:ext uri="{FF2B5EF4-FFF2-40B4-BE49-F238E27FC236}">
-                <a16:creationId xmlns:a16="http://schemas.microsoft.com/office/drawing/2014/main" id="{66F67FE7-57EC-49C9-8D9A-832A338B1416}"/>
+                <a16:creationId xmlns:a16="http://schemas.microsoft.com/office/drawing/2014/main" id="{43E83AD8-E362-4ABC-8DAF-25872F2CA631}"/>
               </a:ext>
             </a:extLst>
           </p:cNvPr>
@@ -7647,7 +7647,7 @@
           <p:cNvPr id="14" name="">
             <a:extLst xmlns:a="http://schemas.openxmlformats.org/drawingml/2006/main">
               <a:ext uri="{FF2B5EF4-FFF2-40B4-BE49-F238E27FC236}">
-                <a16:creationId xmlns:a16="http://schemas.microsoft.com/office/drawing/2014/main" id="{7598511B-46AF-45EE-9EAD-19939AFCD8E8}"/>
+                <a16:creationId xmlns:a16="http://schemas.microsoft.com/office/drawing/2014/main" id="{FD1F6FB6-4AB0-4820-9DB6-6FA7AD33E6A2}"/>
               </a:ext>
             </a:extLst>
           </p:cNvPr>
@@ -7728,7 +7728,7 @@
           <p:cNvPr id="15" name="">
             <a:extLst xmlns:a="http://schemas.openxmlformats.org/drawingml/2006/main">
               <a:ext uri="{FF2B5EF4-FFF2-40B4-BE49-F238E27FC236}">
-                <a16:creationId xmlns:a16="http://schemas.microsoft.com/office/drawing/2014/main" id="{344B97DA-29A3-4543-8B39-B9A04CF37309}"/>
+                <a16:creationId xmlns:a16="http://schemas.microsoft.com/office/drawing/2014/main" id="{AC2A547A-2631-4503-876F-E7A9CAFDD1E7}"/>
               </a:ext>
             </a:extLst>
           </p:cNvPr>
@@ -7809,7 +7809,7 @@
           <p:cNvPr id="16" name="">
             <a:extLst xmlns:a="http://schemas.openxmlformats.org/drawingml/2006/main">
               <a:ext uri="{FF2B5EF4-FFF2-40B4-BE49-F238E27FC236}">
-                <a16:creationId xmlns:a16="http://schemas.microsoft.com/office/drawing/2014/main" id="{5B7D0E25-8479-41A2-A932-373E6AD44088}"/>
+                <a16:creationId xmlns:a16="http://schemas.microsoft.com/office/drawing/2014/main" id="{85BBA23D-DA7B-4A7B-A517-15F1F1ABFA2C}"/>
               </a:ext>
             </a:extLst>
           </p:cNvPr>
@@ -7890,7 +7890,7 @@
           <p:cNvPr id="17" name="">
             <a:extLst xmlns:a="http://schemas.openxmlformats.org/drawingml/2006/main">
               <a:ext uri="{FF2B5EF4-FFF2-40B4-BE49-F238E27FC236}">
-                <a16:creationId xmlns:a16="http://schemas.microsoft.com/office/drawing/2014/main" id="{D89D6884-C425-407B-B841-B7E1DC7F286D}"/>
+                <a16:creationId xmlns:a16="http://schemas.microsoft.com/office/drawing/2014/main" id="{A0475226-00C9-414A-8C74-8E1D4A5D715F}"/>
               </a:ext>
             </a:extLst>
           </p:cNvPr>
@@ -7971,7 +7971,7 @@
           <p:cNvPr id="18" name="">
             <a:extLst xmlns:a="http://schemas.openxmlformats.org/drawingml/2006/main">
               <a:ext uri="{FF2B5EF4-FFF2-40B4-BE49-F238E27FC236}">
-                <a16:creationId xmlns:a16="http://schemas.microsoft.com/office/drawing/2014/main" id="{E322A972-A1B3-4E8B-B660-00B31D3A176E}"/>
+                <a16:creationId xmlns:a16="http://schemas.microsoft.com/office/drawing/2014/main" id="{0A643E76-5C82-451B-A9BB-BE2A8A384610}"/>
               </a:ext>
             </a:extLst>
           </p:cNvPr>
@@ -8029,7 +8029,7 @@
           <p:cNvPr id="19" name="">
             <a:extLst xmlns:a="http://schemas.openxmlformats.org/drawingml/2006/main">
               <a:ext uri="{FF2B5EF4-FFF2-40B4-BE49-F238E27FC236}">
-                <a16:creationId xmlns:a16="http://schemas.microsoft.com/office/drawing/2014/main" id="{D417E199-6A73-455E-BAEB-FCC06218374E}"/>
+                <a16:creationId xmlns:a16="http://schemas.microsoft.com/office/drawing/2014/main" id="{26FAF3DD-EA39-402F-B8FE-74380F1532F8}"/>
               </a:ext>
             </a:extLst>
           </p:cNvPr>
@@ -8085,7 +8085,7 @@
     </p:spTree>
     <p:extLst>
       <p:ext uri="{BB962C8B-B14F-4D97-AF65-F5344CB8AC3E}">
-        <p14:creationId xmlns:p14="http://schemas.microsoft.com/office/powerpoint/2010/main" val="1886574383"/>
+        <p14:creationId xmlns:p14="http://schemas.microsoft.com/office/powerpoint/2010/main" val="494031531"/>
       </p:ext>
     </p:extLst>
   </p:cSld>
@@ -8116,7 +8116,7 @@
           <p:cNvPr id="21" name="">
             <a:extLst xmlns:a="http://schemas.openxmlformats.org/drawingml/2006/main">
               <a:ext uri="{FF2B5EF4-FFF2-40B4-BE49-F238E27FC236}">
-                <a16:creationId xmlns:a16="http://schemas.microsoft.com/office/drawing/2014/main" id="{562CF7E3-980A-4A4C-84A2-E2640D1502A5}"/>
+                <a16:creationId xmlns:a16="http://schemas.microsoft.com/office/drawing/2014/main" id="{D0343925-BBA5-40A2-9614-108C51E72D0E}"/>
               </a:ext>
             </a:extLst>
           </p:cNvPr>
@@ -8174,7 +8174,7 @@
           <p:cNvPr id="2" name="">
             <a:extLst xmlns:a="http://schemas.openxmlformats.org/drawingml/2006/main">
               <a:ext uri="{FF2B5EF4-FFF2-40B4-BE49-F238E27FC236}">
-                <a16:creationId xmlns:a16="http://schemas.microsoft.com/office/drawing/2014/main" id="{1A951798-B3F6-4612-B210-5B0021FDFB69}"/>
+                <a16:creationId xmlns:a16="http://schemas.microsoft.com/office/drawing/2014/main" id="{58437639-F917-4251-BC1F-BE47847BAE94}"/>
               </a:ext>
             </a:extLst>
           </p:cNvPr>
@@ -8232,7 +8232,7 @@
           <p:cNvPr id="3" name="">
             <a:extLst xmlns:a="http://schemas.openxmlformats.org/drawingml/2006/main">
               <a:ext uri="{FF2B5EF4-FFF2-40B4-BE49-F238E27FC236}">
-                <a16:creationId xmlns:a16="http://schemas.microsoft.com/office/drawing/2014/main" id="{D36D2928-3395-4B45-8510-427AB858B43C}"/>
+                <a16:creationId xmlns:a16="http://schemas.microsoft.com/office/drawing/2014/main" id="{CB6530D0-C29C-4E41-B18A-E79FEE78B06F}"/>
               </a:ext>
             </a:extLst>
           </p:cNvPr>
@@ -8290,7 +8290,7 @@
           <p:cNvPr id="4" name="">
             <a:extLst xmlns:a="http://schemas.openxmlformats.org/drawingml/2006/main">
               <a:ext uri="{FF2B5EF4-FFF2-40B4-BE49-F238E27FC236}">
-                <a16:creationId xmlns:a16="http://schemas.microsoft.com/office/drawing/2014/main" id="{DFE978F1-8390-4B10-8B20-5316B453519A}"/>
+                <a16:creationId xmlns:a16="http://schemas.microsoft.com/office/drawing/2014/main" id="{CC877989-9346-410F-AAC8-DA0A6F7706F2}"/>
               </a:ext>
             </a:extLst>
           </p:cNvPr>
@@ -8348,7 +8348,7 @@
           <p:cNvPr id="5" name="">
             <a:extLst xmlns:a="http://schemas.openxmlformats.org/drawingml/2006/main">
               <a:ext uri="{FF2B5EF4-FFF2-40B4-BE49-F238E27FC236}">
-                <a16:creationId xmlns:a16="http://schemas.microsoft.com/office/drawing/2014/main" id="{BF9B164F-A127-4292-B156-16FC0B58DAFC}"/>
+                <a16:creationId xmlns:a16="http://schemas.microsoft.com/office/drawing/2014/main" id="{A756A06D-8CED-4B12-BE73-5CF8E57D81D7}"/>
               </a:ext>
             </a:extLst>
           </p:cNvPr>
@@ -8429,7 +8429,7 @@
           <p:cNvPr id="6" name="">
             <a:extLst xmlns:a="http://schemas.openxmlformats.org/drawingml/2006/main">
               <a:ext uri="{FF2B5EF4-FFF2-40B4-BE49-F238E27FC236}">
-                <a16:creationId xmlns:a16="http://schemas.microsoft.com/office/drawing/2014/main" id="{0FC51044-93CD-40BD-A70E-04D971A3051E}"/>
+                <a16:creationId xmlns:a16="http://schemas.microsoft.com/office/drawing/2014/main" id="{4C1D83D7-DBF5-4445-88A1-2F428D2BD8F7}"/>
               </a:ext>
             </a:extLst>
           </p:cNvPr>
@@ -8487,7 +8487,7 @@
           <p:cNvPr id="7" name="">
             <a:extLst xmlns:a="http://schemas.openxmlformats.org/drawingml/2006/main">
               <a:ext uri="{FF2B5EF4-FFF2-40B4-BE49-F238E27FC236}">
-                <a16:creationId xmlns:a16="http://schemas.microsoft.com/office/drawing/2014/main" id="{3F25E93A-E623-4196-8CE3-64C2994A9C6F}"/>
+                <a16:creationId xmlns:a16="http://schemas.microsoft.com/office/drawing/2014/main" id="{E38F4A9E-225B-41AD-98DB-58F9D0661F17}"/>
               </a:ext>
             </a:extLst>
           </p:cNvPr>
@@ -8568,7 +8568,7 @@
           <p:cNvPr id="8" name="">
             <a:extLst xmlns:a="http://schemas.openxmlformats.org/drawingml/2006/main">
               <a:ext uri="{FF2B5EF4-FFF2-40B4-BE49-F238E27FC236}">
-                <a16:creationId xmlns:a16="http://schemas.microsoft.com/office/drawing/2014/main" id="{A0727B0D-FAA9-40E9-ACA9-1ECC92C80E23}"/>
+                <a16:creationId xmlns:a16="http://schemas.microsoft.com/office/drawing/2014/main" id="{1FE9ACB3-7497-4917-8E72-395281082439}"/>
               </a:ext>
             </a:extLst>
           </p:cNvPr>
@@ -8626,7 +8626,7 @@
           <p:cNvPr id="9" name="">
             <a:extLst xmlns:a="http://schemas.openxmlformats.org/drawingml/2006/main">
               <a:ext uri="{FF2B5EF4-FFF2-40B4-BE49-F238E27FC236}">
-                <a16:creationId xmlns:a16="http://schemas.microsoft.com/office/drawing/2014/main" id="{69682AC6-935E-4C77-AC81-BDC0D610BE00}"/>
+                <a16:creationId xmlns:a16="http://schemas.microsoft.com/office/drawing/2014/main" id="{AC9D90C1-A4BB-4B8E-A74D-B5266E1862C5}"/>
               </a:ext>
             </a:extLst>
           </p:cNvPr>
@@ -8707,7 +8707,7 @@
           <p:cNvPr id="10" name="">
             <a:extLst xmlns:a="http://schemas.openxmlformats.org/drawingml/2006/main">
               <a:ext uri="{FF2B5EF4-FFF2-40B4-BE49-F238E27FC236}">
-                <a16:creationId xmlns:a16="http://schemas.microsoft.com/office/drawing/2014/main" id="{823FF92B-ACA2-4F4D-8E91-DFBC6F11C201}"/>
+                <a16:creationId xmlns:a16="http://schemas.microsoft.com/office/drawing/2014/main" id="{38D13708-DA6F-4061-8F4C-F69C5E4B0AA2}"/>
               </a:ext>
             </a:extLst>
           </p:cNvPr>
@@ -8765,7 +8765,7 @@
           <p:cNvPr id="11" name="">
             <a:extLst xmlns:a="http://schemas.openxmlformats.org/drawingml/2006/main">
               <a:ext uri="{FF2B5EF4-FFF2-40B4-BE49-F238E27FC236}">
-                <a16:creationId xmlns:a16="http://schemas.microsoft.com/office/drawing/2014/main" id="{7A80D87E-EEF1-4AD2-9AF8-1AE9B32982AE}"/>
+                <a16:creationId xmlns:a16="http://schemas.microsoft.com/office/drawing/2014/main" id="{681FBE7A-812D-48A3-9A39-C328BBFE70C8}"/>
               </a:ext>
             </a:extLst>
           </p:cNvPr>
@@ -8846,7 +8846,7 @@
           <p:cNvPr id="12" name="">
             <a:extLst xmlns:a="http://schemas.openxmlformats.org/drawingml/2006/main">
               <a:ext uri="{FF2B5EF4-FFF2-40B4-BE49-F238E27FC236}">
-                <a16:creationId xmlns:a16="http://schemas.microsoft.com/office/drawing/2014/main" id="{CCD7CD84-E0A4-4E35-936A-C94A6DC4B7E8}"/>
+                <a16:creationId xmlns:a16="http://schemas.microsoft.com/office/drawing/2014/main" id="{6F8DD7F1-D466-4682-B221-68169719381E}"/>
               </a:ext>
             </a:extLst>
           </p:cNvPr>
@@ -8904,7 +8904,7 @@
           <p:cNvPr id="13" name="">
             <a:extLst xmlns:a="http://schemas.openxmlformats.org/drawingml/2006/main">
               <a:ext uri="{FF2B5EF4-FFF2-40B4-BE49-F238E27FC236}">
-                <a16:creationId xmlns:a16="http://schemas.microsoft.com/office/drawing/2014/main" id="{F2A83124-0959-4332-8000-39648DFF224F}"/>
+                <a16:creationId xmlns:a16="http://schemas.microsoft.com/office/drawing/2014/main" id="{75A64A01-511D-4B7C-8D13-B4B2B693F438}"/>
               </a:ext>
             </a:extLst>
           </p:cNvPr>
@@ -8985,7 +8985,7 @@
           <p:cNvPr id="14" name="">
             <a:extLst xmlns:a="http://schemas.openxmlformats.org/drawingml/2006/main">
               <a:ext uri="{FF2B5EF4-FFF2-40B4-BE49-F238E27FC236}">
-                <a16:creationId xmlns:a16="http://schemas.microsoft.com/office/drawing/2014/main" id="{04D1D53E-E427-4CD2-AD2C-5135B9BAD507}"/>
+                <a16:creationId xmlns:a16="http://schemas.microsoft.com/office/drawing/2014/main" id="{F48A9E02-4D70-4996-BAB7-445BB8893A21}"/>
               </a:ext>
             </a:extLst>
           </p:cNvPr>
@@ -9043,7 +9043,7 @@
           <p:cNvPr id="15" name="">
             <a:extLst xmlns:a="http://schemas.openxmlformats.org/drawingml/2006/main">
               <a:ext uri="{FF2B5EF4-FFF2-40B4-BE49-F238E27FC236}">
-                <a16:creationId xmlns:a16="http://schemas.microsoft.com/office/drawing/2014/main" id="{A73C95A2-55B6-411E-A833-9D48D333E1A4}"/>
+                <a16:creationId xmlns:a16="http://schemas.microsoft.com/office/drawing/2014/main" id="{6843606C-A272-4CC1-9ADB-D5637834B4F2}"/>
               </a:ext>
             </a:extLst>
           </p:cNvPr>
@@ -9124,7 +9124,7 @@
           <p:cNvPr id="16" name="">
             <a:extLst xmlns:a="http://schemas.openxmlformats.org/drawingml/2006/main">
               <a:ext uri="{FF2B5EF4-FFF2-40B4-BE49-F238E27FC236}">
-                <a16:creationId xmlns:a16="http://schemas.microsoft.com/office/drawing/2014/main" id="{C62C0AD6-EE7A-47DF-AE2A-B88DDA618E42}"/>
+                <a16:creationId xmlns:a16="http://schemas.microsoft.com/office/drawing/2014/main" id="{EC36643A-5623-40EF-8A55-339A536BB139}"/>
               </a:ext>
             </a:extLst>
           </p:cNvPr>
@@ -9188,7 +9188,7 @@
           <p:cNvPr id="17" name="">
             <a:extLst xmlns:a="http://schemas.openxmlformats.org/drawingml/2006/main">
               <a:ext uri="{FF2B5EF4-FFF2-40B4-BE49-F238E27FC236}">
-                <a16:creationId xmlns:a16="http://schemas.microsoft.com/office/drawing/2014/main" id="{9E0DB7DC-74A0-476B-86A9-004541070418}"/>
+                <a16:creationId xmlns:a16="http://schemas.microsoft.com/office/drawing/2014/main" id="{9EFB89E7-7D7E-45A2-9050-464AC4167590}"/>
               </a:ext>
             </a:extLst>
           </p:cNvPr>
@@ -9290,7 +9290,7 @@
           <p:cNvPr id="18" name="">
             <a:extLst xmlns:a="http://schemas.openxmlformats.org/drawingml/2006/main">
               <a:ext uri="{FF2B5EF4-FFF2-40B4-BE49-F238E27FC236}">
-                <a16:creationId xmlns:a16="http://schemas.microsoft.com/office/drawing/2014/main" id="{6BBE3596-5510-422D-9014-066AFC4C3AC9}"/>
+                <a16:creationId xmlns:a16="http://schemas.microsoft.com/office/drawing/2014/main" id="{77EDEB1B-D2D8-484E-9354-7DB3308B85EA}"/>
               </a:ext>
             </a:extLst>
           </p:cNvPr>
@@ -9354,7 +9354,7 @@
           <p:cNvPr id="19" name="">
             <a:extLst xmlns:a="http://schemas.openxmlformats.org/drawingml/2006/main">
               <a:ext uri="{FF2B5EF4-FFF2-40B4-BE49-F238E27FC236}">
-                <a16:creationId xmlns:a16="http://schemas.microsoft.com/office/drawing/2014/main" id="{01015F18-BE33-44C4-8554-3D31153A8A3E}"/>
+                <a16:creationId xmlns:a16="http://schemas.microsoft.com/office/drawing/2014/main" id="{6486DBB6-7DCE-4650-80E7-3D23B81DC826}"/>
               </a:ext>
             </a:extLst>
           </p:cNvPr>
@@ -9456,7 +9456,7 @@
           <p:cNvPr id="20" name="">
             <a:extLst xmlns:a="http://schemas.openxmlformats.org/drawingml/2006/main">
               <a:ext uri="{FF2B5EF4-FFF2-40B4-BE49-F238E27FC236}">
-                <a16:creationId xmlns:a16="http://schemas.microsoft.com/office/drawing/2014/main" id="{51DF9D8F-3B86-474E-BD77-58521D42ADB5}"/>
+                <a16:creationId xmlns:a16="http://schemas.microsoft.com/office/drawing/2014/main" id="{F7D0E6CB-0207-466C-8A25-26B2EF42FC4C}"/>
               </a:ext>
             </a:extLst>
           </p:cNvPr>
@@ -9512,7 +9512,7 @@
     </p:spTree>
     <p:extLst>
       <p:ext uri="{BB962C8B-B14F-4D97-AF65-F5344CB8AC3E}">
-        <p14:creationId xmlns:p14="http://schemas.microsoft.com/office/powerpoint/2010/main" val="1624904911"/>
+        <p14:creationId xmlns:p14="http://schemas.microsoft.com/office/powerpoint/2010/main" val="712300658"/>
       </p:ext>
     </p:extLst>
   </p:cSld>
@@ -9543,7 +9543,7 @@
           <p:cNvPr id="15" name="">
             <a:extLst xmlns:a="http://schemas.openxmlformats.org/drawingml/2006/main">
               <a:ext uri="{FF2B5EF4-FFF2-40B4-BE49-F238E27FC236}">
-                <a16:creationId xmlns:a16="http://schemas.microsoft.com/office/drawing/2014/main" id="{3C68BE95-9117-4519-8B5B-262CCA94F403}"/>
+                <a16:creationId xmlns:a16="http://schemas.microsoft.com/office/drawing/2014/main" id="{6319D098-097B-4ABB-ACBE-C9557182353A}"/>
               </a:ext>
             </a:extLst>
           </p:cNvPr>
@@ -9601,7 +9601,7 @@
           <p:cNvPr id="2" name="">
             <a:extLst xmlns:a="http://schemas.openxmlformats.org/drawingml/2006/main">
               <a:ext uri="{FF2B5EF4-FFF2-40B4-BE49-F238E27FC236}">
-                <a16:creationId xmlns:a16="http://schemas.microsoft.com/office/drawing/2014/main" id="{A3DC5AB2-DEC9-4ECC-A15D-3B68167CD35E}"/>
+                <a16:creationId xmlns:a16="http://schemas.microsoft.com/office/drawing/2014/main" id="{4C718422-00E8-4020-9372-9971656AB658}"/>
               </a:ext>
             </a:extLst>
           </p:cNvPr>
@@ -9659,7 +9659,7 @@
           <p:cNvPr id="3" name="">
             <a:extLst xmlns:a="http://schemas.openxmlformats.org/drawingml/2006/main">
               <a:ext uri="{FF2B5EF4-FFF2-40B4-BE49-F238E27FC236}">
-                <a16:creationId xmlns:a16="http://schemas.microsoft.com/office/drawing/2014/main" id="{FA5895A6-2046-47CB-92CE-27C10BBCCAC7}"/>
+                <a16:creationId xmlns:a16="http://schemas.microsoft.com/office/drawing/2014/main" id="{C245FA92-F5C8-4DF9-8D12-1545D5DCE1F0}"/>
               </a:ext>
             </a:extLst>
           </p:cNvPr>
@@ -9717,7 +9717,7 @@
           <p:cNvPr id="4" name="">
             <a:extLst xmlns:a="http://schemas.openxmlformats.org/drawingml/2006/main">
               <a:ext uri="{FF2B5EF4-FFF2-40B4-BE49-F238E27FC236}">
-                <a16:creationId xmlns:a16="http://schemas.microsoft.com/office/drawing/2014/main" id="{6AA45629-6F69-4E09-8721-C464B71434C6}"/>
+                <a16:creationId xmlns:a16="http://schemas.microsoft.com/office/drawing/2014/main" id="{F6F7B292-1925-4932-B9CB-5BB176442F3F}"/>
               </a:ext>
             </a:extLst>
           </p:cNvPr>
@@ -9775,7 +9775,7 @@
           <p:cNvPr id="5" name="">
             <a:extLst xmlns:a="http://schemas.openxmlformats.org/drawingml/2006/main">
               <a:ext uri="{FF2B5EF4-FFF2-40B4-BE49-F238E27FC236}">
-                <a16:creationId xmlns:a16="http://schemas.microsoft.com/office/drawing/2014/main" id="{1429EA08-F623-4C7B-B91D-DB2D457B37AF}"/>
+                <a16:creationId xmlns:a16="http://schemas.microsoft.com/office/drawing/2014/main" id="{6C0282CD-DD38-4403-A488-75F2B2680F5C}"/>
               </a:ext>
             </a:extLst>
           </p:cNvPr>
@@ -9873,7 +9873,7 @@
           <p:cNvPr id="6" name="">
             <a:extLst xmlns:a="http://schemas.openxmlformats.org/drawingml/2006/main">
               <a:ext uri="{FF2B5EF4-FFF2-40B4-BE49-F238E27FC236}">
-                <a16:creationId xmlns:a16="http://schemas.microsoft.com/office/drawing/2014/main" id="{87C5CAE6-6591-4AED-B198-F9A3190E37D6}"/>
+                <a16:creationId xmlns:a16="http://schemas.microsoft.com/office/drawing/2014/main" id="{E39C1DE0-1607-40F7-A330-FBFAF046EC79}"/>
               </a:ext>
             </a:extLst>
           </p:cNvPr>
@@ -9971,7 +9971,7 @@
           <p:cNvPr id="7" name="">
             <a:extLst xmlns:a="http://schemas.openxmlformats.org/drawingml/2006/main">
               <a:ext uri="{FF2B5EF4-FFF2-40B4-BE49-F238E27FC236}">
-                <a16:creationId xmlns:a16="http://schemas.microsoft.com/office/drawing/2014/main" id="{AF9199A5-E5C5-4D4E-9E22-7B67213F6311}"/>
+                <a16:creationId xmlns:a16="http://schemas.microsoft.com/office/drawing/2014/main" id="{46D1E084-6D4C-48FD-9E3F-3C715C0CB914}"/>
               </a:ext>
             </a:extLst>
           </p:cNvPr>
@@ -10069,7 +10069,7 @@
           <p:cNvPr id="8" name="">
             <a:extLst xmlns:a="http://schemas.openxmlformats.org/drawingml/2006/main">
               <a:ext uri="{FF2B5EF4-FFF2-40B4-BE49-F238E27FC236}">
-                <a16:creationId xmlns:a16="http://schemas.microsoft.com/office/drawing/2014/main" id="{3B83509A-8878-4D74-9C6B-2EDFC53EDE16}"/>
+                <a16:creationId xmlns:a16="http://schemas.microsoft.com/office/drawing/2014/main" id="{D87806BB-0573-4B18-9114-4AE0D81F040E}"/>
               </a:ext>
             </a:extLst>
           </p:cNvPr>
@@ -10167,7 +10167,7 @@
           <p:cNvPr id="9" name="">
             <a:extLst xmlns:a="http://schemas.openxmlformats.org/drawingml/2006/main">
               <a:ext uri="{FF2B5EF4-FFF2-40B4-BE49-F238E27FC236}">
-                <a16:creationId xmlns:a16="http://schemas.microsoft.com/office/drawing/2014/main" id="{F659C7C4-8AFC-413E-872D-330594603BBD}"/>
+                <a16:creationId xmlns:a16="http://schemas.microsoft.com/office/drawing/2014/main" id="{D2E2AEC4-EC4F-41AE-B928-4D1C2497B473}"/>
               </a:ext>
             </a:extLst>
           </p:cNvPr>
@@ -10225,7 +10225,7 @@
           <p:cNvPr id="10" name="">
             <a:extLst xmlns:a="http://schemas.openxmlformats.org/drawingml/2006/main">
               <a:ext uri="{FF2B5EF4-FFF2-40B4-BE49-F238E27FC236}">
-                <a16:creationId xmlns:a16="http://schemas.microsoft.com/office/drawing/2014/main" id="{1526BAB2-9E6C-476A-98E7-A367DE5E710C}"/>
+                <a16:creationId xmlns:a16="http://schemas.microsoft.com/office/drawing/2014/main" id="{B2D74D77-CCC2-4D13-807B-B1132AC8CB9B}"/>
               </a:ext>
             </a:extLst>
           </p:cNvPr>
@@ -10289,7 +10289,7 @@
           <p:cNvPr id="11" name="">
             <a:extLst xmlns:a="http://schemas.openxmlformats.org/drawingml/2006/main">
               <a:ext uri="{FF2B5EF4-FFF2-40B4-BE49-F238E27FC236}">
-                <a16:creationId xmlns:a16="http://schemas.microsoft.com/office/drawing/2014/main" id="{16596642-EF13-4AC4-908A-6F246CA39EC4}"/>
+                <a16:creationId xmlns:a16="http://schemas.microsoft.com/office/drawing/2014/main" id="{AB2C563B-DEEC-496D-8DAE-6104C91BDD41}"/>
               </a:ext>
             </a:extLst>
           </p:cNvPr>
@@ -10403,7 +10403,7 @@
           <p:cNvPr id="12" name="">
             <a:extLst xmlns:a="http://schemas.openxmlformats.org/drawingml/2006/main">
               <a:ext uri="{FF2B5EF4-FFF2-40B4-BE49-F238E27FC236}">
-                <a16:creationId xmlns:a16="http://schemas.microsoft.com/office/drawing/2014/main" id="{89423C5E-5A4A-4E9F-A9C2-4B1A658023E3}"/>
+                <a16:creationId xmlns:a16="http://schemas.microsoft.com/office/drawing/2014/main" id="{1C8BC57A-FC6C-4BB4-8080-AF61FE3E5213}"/>
               </a:ext>
             </a:extLst>
           </p:cNvPr>
@@ -10467,7 +10467,7 @@
           <p:cNvPr id="13" name="">
             <a:extLst xmlns:a="http://schemas.openxmlformats.org/drawingml/2006/main">
               <a:ext uri="{FF2B5EF4-FFF2-40B4-BE49-F238E27FC236}">
-                <a16:creationId xmlns:a16="http://schemas.microsoft.com/office/drawing/2014/main" id="{93C89234-0BFE-4919-A5DD-F62A96F50FAC}"/>
+                <a16:creationId xmlns:a16="http://schemas.microsoft.com/office/drawing/2014/main" id="{E8FE7A80-8776-46C1-9B5D-789E5B7FEEE1}"/>
               </a:ext>
             </a:extLst>
           </p:cNvPr>
@@ -10569,7 +10569,7 @@
           <p:cNvPr id="14" name="">
             <a:extLst xmlns:a="http://schemas.openxmlformats.org/drawingml/2006/main">
               <a:ext uri="{FF2B5EF4-FFF2-40B4-BE49-F238E27FC236}">
-                <a16:creationId xmlns:a16="http://schemas.microsoft.com/office/drawing/2014/main" id="{98A0C556-B8F2-4A1C-B0AD-21D8BFA9875A}"/>
+                <a16:creationId xmlns:a16="http://schemas.microsoft.com/office/drawing/2014/main" id="{98322DA1-12FD-4652-BA4D-B26C936DD386}"/>
               </a:ext>
             </a:extLst>
           </p:cNvPr>
@@ -10625,7 +10625,7 @@
     </p:spTree>
     <p:extLst>
       <p:ext uri="{BB962C8B-B14F-4D97-AF65-F5344CB8AC3E}">
-        <p14:creationId xmlns:p14="http://schemas.microsoft.com/office/powerpoint/2010/main" val="2064842454"/>
+        <p14:creationId xmlns:p14="http://schemas.microsoft.com/office/powerpoint/2010/main" val="471383382"/>
       </p:ext>
     </p:extLst>
   </p:cSld>
@@ -10656,7 +10656,7 @@
           <p:cNvPr id="10" name="">
             <a:extLst xmlns:a="http://schemas.openxmlformats.org/drawingml/2006/main">
               <a:ext uri="{FF2B5EF4-FFF2-40B4-BE49-F238E27FC236}">
-                <a16:creationId xmlns:a16="http://schemas.microsoft.com/office/drawing/2014/main" id="{B8CE8499-A4EC-407B-AE79-A2F6DCE1F4CB}"/>
+                <a16:creationId xmlns:a16="http://schemas.microsoft.com/office/drawing/2014/main" id="{181E7CFD-2AA6-42FB-BA7A-FE1658F066E3}"/>
               </a:ext>
             </a:extLst>
           </p:cNvPr>
@@ -10714,7 +10714,7 @@
           <p:cNvPr id="2" name="">
             <a:extLst xmlns:a="http://schemas.openxmlformats.org/drawingml/2006/main">
               <a:ext uri="{FF2B5EF4-FFF2-40B4-BE49-F238E27FC236}">
-                <a16:creationId xmlns:a16="http://schemas.microsoft.com/office/drawing/2014/main" id="{300CFF78-75E3-4ABA-AC0B-FE1DC3FDD404}"/>
+                <a16:creationId xmlns:a16="http://schemas.microsoft.com/office/drawing/2014/main" id="{EF45324A-0E63-485C-8D33-05DD57DD386A}"/>
               </a:ext>
             </a:extLst>
           </p:cNvPr>
@@ -10772,7 +10772,7 @@
           <p:cNvPr id="3" name="">
             <a:extLst xmlns:a="http://schemas.openxmlformats.org/drawingml/2006/main">
               <a:ext uri="{FF2B5EF4-FFF2-40B4-BE49-F238E27FC236}">
-                <a16:creationId xmlns:a16="http://schemas.microsoft.com/office/drawing/2014/main" id="{F9350F65-CDA1-47E2-A8D3-64182616403D}"/>
+                <a16:creationId xmlns:a16="http://schemas.microsoft.com/office/drawing/2014/main" id="{8962F738-0BF9-4546-BE92-3E531AFFFCB3}"/>
               </a:ext>
             </a:extLst>
           </p:cNvPr>
@@ -10830,7 +10830,7 @@
           <p:cNvPr id="4" name="">
             <a:extLst xmlns:a="http://schemas.openxmlformats.org/drawingml/2006/main">
               <a:ext uri="{FF2B5EF4-FFF2-40B4-BE49-F238E27FC236}">
-                <a16:creationId xmlns:a16="http://schemas.microsoft.com/office/drawing/2014/main" id="{07A09D9F-D0FC-4F96-9C56-1C4C4A45BFC1}"/>
+                <a16:creationId xmlns:a16="http://schemas.microsoft.com/office/drawing/2014/main" id="{0594D1CF-3CB3-45D8-971E-3C11E6B0734C}"/>
               </a:ext>
             </a:extLst>
           </p:cNvPr>
@@ -10888,7 +10888,7 @@
           <p:cNvPr id="5" name="">
             <a:extLst xmlns:a="http://schemas.openxmlformats.org/drawingml/2006/main">
               <a:ext uri="{FF2B5EF4-FFF2-40B4-BE49-F238E27FC236}">
-                <a16:creationId xmlns:a16="http://schemas.microsoft.com/office/drawing/2014/main" id="{85B87D25-ADB8-48A5-8B59-D5C38F0D7A0F}"/>
+                <a16:creationId xmlns:a16="http://schemas.microsoft.com/office/drawing/2014/main" id="{7F102401-3312-42A0-A836-A417DCCF5BFD}"/>
               </a:ext>
             </a:extLst>
           </p:cNvPr>
@@ -10952,7 +10952,7 @@
           <p:cNvPr id="6" name="">
             <a:extLst xmlns:a="http://schemas.openxmlformats.org/drawingml/2006/main">
               <a:ext uri="{FF2B5EF4-FFF2-40B4-BE49-F238E27FC236}">
-                <a16:creationId xmlns:a16="http://schemas.microsoft.com/office/drawing/2014/main" id="{C2088F34-0B65-4605-8D8F-3D50F6D1F9CF}"/>
+                <a16:creationId xmlns:a16="http://schemas.microsoft.com/office/drawing/2014/main" id="{A74A6874-13BB-47A1-9B58-F991A12FD142}"/>
               </a:ext>
             </a:extLst>
           </p:cNvPr>
@@ -11078,7 +11078,7 @@
           <p:cNvPr id="7" name="">
             <a:extLst xmlns:a="http://schemas.openxmlformats.org/drawingml/2006/main">
               <a:ext uri="{FF2B5EF4-FFF2-40B4-BE49-F238E27FC236}">
-                <a16:creationId xmlns:a16="http://schemas.microsoft.com/office/drawing/2014/main" id="{367C5474-0517-4F2E-A680-6D79D3B0FD44}"/>
+                <a16:creationId xmlns:a16="http://schemas.microsoft.com/office/drawing/2014/main" id="{EB393250-2E82-4EBA-A8BD-21AD4FE8F046}"/>
               </a:ext>
             </a:extLst>
           </p:cNvPr>
@@ -11142,7 +11142,7 @@
           <p:cNvPr id="8" name="">
             <a:extLst xmlns:a="http://schemas.openxmlformats.org/drawingml/2006/main">
               <a:ext uri="{FF2B5EF4-FFF2-40B4-BE49-F238E27FC236}">
-                <a16:creationId xmlns:a16="http://schemas.microsoft.com/office/drawing/2014/main" id="{54668F53-AF81-4507-A644-F2B5F57CE49B}"/>
+                <a16:creationId xmlns:a16="http://schemas.microsoft.com/office/drawing/2014/main" id="{0C68002D-1A01-44FC-ADE8-486FE3C4C95D}"/>
               </a:ext>
             </a:extLst>
           </p:cNvPr>
@@ -11273,7 +11273,7 @@
           <p:cNvPr id="9" name="">
             <a:extLst xmlns:a="http://schemas.openxmlformats.org/drawingml/2006/main">
               <a:ext uri="{FF2B5EF4-FFF2-40B4-BE49-F238E27FC236}">
-                <a16:creationId xmlns:a16="http://schemas.microsoft.com/office/drawing/2014/main" id="{F9103EA0-D0CD-4453-91B3-1A77D96B43EB}"/>
+                <a16:creationId xmlns:a16="http://schemas.microsoft.com/office/drawing/2014/main" id="{0747AE4D-9F9D-444D-AB01-E55BB03495BD}"/>
               </a:ext>
             </a:extLst>
           </p:cNvPr>
@@ -11329,7 +11329,7 @@
     </p:spTree>
     <p:extLst>
       <p:ext uri="{BB962C8B-B14F-4D97-AF65-F5344CB8AC3E}">
-        <p14:creationId xmlns:p14="http://schemas.microsoft.com/office/powerpoint/2010/main" val="1501814659"/>
+        <p14:creationId xmlns:p14="http://schemas.microsoft.com/office/powerpoint/2010/main" val="924659202"/>
       </p:ext>
     </p:extLst>
   </p:cSld>
@@ -11360,7 +11360,7 @@
           <p:cNvPr id="10" name="">
             <a:extLst xmlns:a="http://schemas.openxmlformats.org/drawingml/2006/main">
               <a:ext uri="{FF2B5EF4-FFF2-40B4-BE49-F238E27FC236}">
-                <a16:creationId xmlns:a16="http://schemas.microsoft.com/office/drawing/2014/main" id="{ABA970BA-139F-4C8D-867D-2142BCF0F130}"/>
+                <a16:creationId xmlns:a16="http://schemas.microsoft.com/office/drawing/2014/main" id="{57FA6CBC-7820-471D-B496-056DF6FA6B81}"/>
               </a:ext>
             </a:extLst>
           </p:cNvPr>
@@ -11418,7 +11418,7 @@
           <p:cNvPr id="2" name="">
             <a:extLst xmlns:a="http://schemas.openxmlformats.org/drawingml/2006/main">
               <a:ext uri="{FF2B5EF4-FFF2-40B4-BE49-F238E27FC236}">
-                <a16:creationId xmlns:a16="http://schemas.microsoft.com/office/drawing/2014/main" id="{FCE9E2E5-59D0-42B7-91FC-E6642EEC576B}"/>
+                <a16:creationId xmlns:a16="http://schemas.microsoft.com/office/drawing/2014/main" id="{1E8C5EFC-799C-4455-AA14-6BE588DCDBA2}"/>
               </a:ext>
             </a:extLst>
           </p:cNvPr>
@@ -11476,7 +11476,7 @@
           <p:cNvPr id="3" name="">
             <a:extLst xmlns:a="http://schemas.openxmlformats.org/drawingml/2006/main">
               <a:ext uri="{FF2B5EF4-FFF2-40B4-BE49-F238E27FC236}">
-                <a16:creationId xmlns:a16="http://schemas.microsoft.com/office/drawing/2014/main" id="{9380D378-CFEB-464D-A512-F955BA1F1FD5}"/>
+                <a16:creationId xmlns:a16="http://schemas.microsoft.com/office/drawing/2014/main" id="{2B6FB1D9-2C2A-4390-BDF1-D7B4EC82229A}"/>
               </a:ext>
             </a:extLst>
           </p:cNvPr>
@@ -11534,7 +11534,7 @@
           <p:cNvPr id="4" name="">
             <a:extLst xmlns:a="http://schemas.openxmlformats.org/drawingml/2006/main">
               <a:ext uri="{FF2B5EF4-FFF2-40B4-BE49-F238E27FC236}">
-                <a16:creationId xmlns:a16="http://schemas.microsoft.com/office/drawing/2014/main" id="{0F982677-EEB3-44EE-ACF2-C2AB4D710D96}"/>
+                <a16:creationId xmlns:a16="http://schemas.microsoft.com/office/drawing/2014/main" id="{83C15E84-B571-4EF6-9A11-0F5F6FD99E57}"/>
               </a:ext>
             </a:extLst>
           </p:cNvPr>
@@ -11592,7 +11592,7 @@
           <p:cNvPr id="5" name="">
             <a:extLst xmlns:a="http://schemas.openxmlformats.org/drawingml/2006/main">
               <a:ext uri="{FF2B5EF4-FFF2-40B4-BE49-F238E27FC236}">
-                <a16:creationId xmlns:a16="http://schemas.microsoft.com/office/drawing/2014/main" id="{C8B21986-1678-419E-A195-3B0858A3A972}"/>
+                <a16:creationId xmlns:a16="http://schemas.microsoft.com/office/drawing/2014/main" id="{4ACAD8D6-D482-4466-ADDE-248475136FB3}"/>
               </a:ext>
             </a:extLst>
           </p:cNvPr>
@@ -11656,7 +11656,7 @@
           <p:cNvPr id="6" name="">
             <a:extLst xmlns:a="http://schemas.openxmlformats.org/drawingml/2006/main">
               <a:ext uri="{FF2B5EF4-FFF2-40B4-BE49-F238E27FC236}">
-                <a16:creationId xmlns:a16="http://schemas.microsoft.com/office/drawing/2014/main" id="{9F58D729-F125-402D-A6A8-3AAD279E34A7}"/>
+                <a16:creationId xmlns:a16="http://schemas.microsoft.com/office/drawing/2014/main" id="{B080FBA4-303E-483F-8CF9-670F49CD24CB}"/>
               </a:ext>
             </a:extLst>
           </p:cNvPr>
@@ -11775,7 +11775,7 @@
           <p:cNvPr id="7" name="">
             <a:extLst xmlns:a="http://schemas.openxmlformats.org/drawingml/2006/main">
               <a:ext uri="{FF2B5EF4-FFF2-40B4-BE49-F238E27FC236}">
-                <a16:creationId xmlns:a16="http://schemas.microsoft.com/office/drawing/2014/main" id="{110AFC9F-62AE-41D7-9A81-DF30B795A34D}"/>
+                <a16:creationId xmlns:a16="http://schemas.microsoft.com/office/drawing/2014/main" id="{DDBE6B15-0225-47AD-A815-C79D22AE0566}"/>
               </a:ext>
             </a:extLst>
           </p:cNvPr>
@@ -11839,7 +11839,7 @@
           <p:cNvPr id="8" name="">
             <a:extLst xmlns:a="http://schemas.openxmlformats.org/drawingml/2006/main">
               <a:ext uri="{FF2B5EF4-FFF2-40B4-BE49-F238E27FC236}">
-                <a16:creationId xmlns:a16="http://schemas.microsoft.com/office/drawing/2014/main" id="{12FEE5E5-D700-43B4-B0B5-A57128885DF1}"/>
+                <a16:creationId xmlns:a16="http://schemas.microsoft.com/office/drawing/2014/main" id="{42B9BB31-DB0B-4D91-A1B0-DEE088DEBBBE}"/>
               </a:ext>
             </a:extLst>
           </p:cNvPr>
@@ -11963,7 +11963,7 @@
           <p:cNvPr id="9" name="">
             <a:extLst xmlns:a="http://schemas.openxmlformats.org/drawingml/2006/main">
               <a:ext uri="{FF2B5EF4-FFF2-40B4-BE49-F238E27FC236}">
-                <a16:creationId xmlns:a16="http://schemas.microsoft.com/office/drawing/2014/main" id="{297F7116-4622-4A84-B64E-1EDDD7E2B2FC}"/>
+                <a16:creationId xmlns:a16="http://schemas.microsoft.com/office/drawing/2014/main" id="{8C664CC6-FA47-4FBD-8165-B99AC964FA05}"/>
               </a:ext>
             </a:extLst>
           </p:cNvPr>
@@ -12019,7 +12019,7 @@
     </p:spTree>
     <p:extLst>
       <p:ext uri="{BB962C8B-B14F-4D97-AF65-F5344CB8AC3E}">
-        <p14:creationId xmlns:p14="http://schemas.microsoft.com/office/powerpoint/2010/main" val="2121655736"/>
+        <p14:creationId xmlns:p14="http://schemas.microsoft.com/office/powerpoint/2010/main" val="1451264506"/>
       </p:ext>
     </p:extLst>
   </p:cSld>
@@ -12050,7 +12050,7 @@
           <p:cNvPr id="12" name="">
             <a:extLst xmlns:a="http://schemas.openxmlformats.org/drawingml/2006/main">
               <a:ext uri="{FF2B5EF4-FFF2-40B4-BE49-F238E27FC236}">
-                <a16:creationId xmlns:a16="http://schemas.microsoft.com/office/drawing/2014/main" id="{DB6C6E06-35DC-4C2C-B11B-9F05CD56886C}"/>
+                <a16:creationId xmlns:a16="http://schemas.microsoft.com/office/drawing/2014/main" id="{044974AA-F428-48B3-872F-316822B2D4AA}"/>
               </a:ext>
             </a:extLst>
           </p:cNvPr>
@@ -12108,7 +12108,7 @@
           <p:cNvPr id="2" name="">
             <a:extLst xmlns:a="http://schemas.openxmlformats.org/drawingml/2006/main">
               <a:ext uri="{FF2B5EF4-FFF2-40B4-BE49-F238E27FC236}">
-                <a16:creationId xmlns:a16="http://schemas.microsoft.com/office/drawing/2014/main" id="{4DE373D6-B562-4C32-ACB5-1697DA5BDF72}"/>
+                <a16:creationId xmlns:a16="http://schemas.microsoft.com/office/drawing/2014/main" id="{86784D78-0CBF-4B31-82C3-76860A8D0556}"/>
               </a:ext>
             </a:extLst>
           </p:cNvPr>
@@ -12166,7 +12166,7 @@
           <p:cNvPr id="3" name="">
             <a:extLst xmlns:a="http://schemas.openxmlformats.org/drawingml/2006/main">
               <a:ext uri="{FF2B5EF4-FFF2-40B4-BE49-F238E27FC236}">
-                <a16:creationId xmlns:a16="http://schemas.microsoft.com/office/drawing/2014/main" id="{B03BE742-74FD-46B1-A82C-64D7521F1327}"/>
+                <a16:creationId xmlns:a16="http://schemas.microsoft.com/office/drawing/2014/main" id="{31482E5B-5B9B-41F5-9C76-A3B0E9F44C05}"/>
               </a:ext>
             </a:extLst>
           </p:cNvPr>
@@ -12224,7 +12224,7 @@
           <p:cNvPr id="4" name="">
             <a:extLst xmlns:a="http://schemas.openxmlformats.org/drawingml/2006/main">
               <a:ext uri="{FF2B5EF4-FFF2-40B4-BE49-F238E27FC236}">
-                <a16:creationId xmlns:a16="http://schemas.microsoft.com/office/drawing/2014/main" id="{E938A4D2-EADB-42A0-BA29-83A1FFDCCDB2}"/>
+                <a16:creationId xmlns:a16="http://schemas.microsoft.com/office/drawing/2014/main" id="{97FDF721-ECCD-4D49-A834-C836B71D05CD}"/>
               </a:ext>
             </a:extLst>
           </p:cNvPr>
@@ -12282,7 +12282,7 @@
           <p:cNvPr id="5" name="">
             <a:extLst xmlns:a="http://schemas.openxmlformats.org/drawingml/2006/main">
               <a:ext uri="{FF2B5EF4-FFF2-40B4-BE49-F238E27FC236}">
-                <a16:creationId xmlns:a16="http://schemas.microsoft.com/office/drawing/2014/main" id="{F558135B-2207-46AE-9B2B-55C95B50B22C}"/>
+                <a16:creationId xmlns:a16="http://schemas.microsoft.com/office/drawing/2014/main" id="{AA8592C3-D549-47D3-8014-26C2AC48E378}"/>
               </a:ext>
             </a:extLst>
           </p:cNvPr>
@@ -12380,7 +12380,7 @@
           <p:cNvPr id="6" name="">
             <a:extLst xmlns:a="http://schemas.openxmlformats.org/drawingml/2006/main">
               <a:ext uri="{FF2B5EF4-FFF2-40B4-BE49-F238E27FC236}">
-                <a16:creationId xmlns:a16="http://schemas.microsoft.com/office/drawing/2014/main" id="{DB47A8B9-FBEC-4AB7-8137-7CF3EDC5376B}"/>
+                <a16:creationId xmlns:a16="http://schemas.microsoft.com/office/drawing/2014/main" id="{F35D2937-5A5D-4CCB-9550-ED3C363403ED}"/>
               </a:ext>
             </a:extLst>
           </p:cNvPr>
@@ -12478,7 +12478,7 @@
           <p:cNvPr id="7" name="">
             <a:extLst xmlns:a="http://schemas.openxmlformats.org/drawingml/2006/main">
               <a:ext uri="{FF2B5EF4-FFF2-40B4-BE49-F238E27FC236}">
-                <a16:creationId xmlns:a16="http://schemas.microsoft.com/office/drawing/2014/main" id="{2FBD6B3C-3E55-463D-B978-151FB67B78A8}"/>
+                <a16:creationId xmlns:a16="http://schemas.microsoft.com/office/drawing/2014/main" id="{DC239257-4581-4263-9172-0A8EA21D216C}"/>
               </a:ext>
             </a:extLst>
           </p:cNvPr>
@@ -12576,7 +12576,7 @@
           <p:cNvPr id="8" name="">
             <a:extLst xmlns:a="http://schemas.openxmlformats.org/drawingml/2006/main">
               <a:ext uri="{FF2B5EF4-FFF2-40B4-BE49-F238E27FC236}">
-                <a16:creationId xmlns:a16="http://schemas.microsoft.com/office/drawing/2014/main" id="{527E7CEB-3052-4C17-B323-7BE5DAC8BE53}"/>
+                <a16:creationId xmlns:a16="http://schemas.microsoft.com/office/drawing/2014/main" id="{68F3CB5F-A1E3-4EF7-8E0D-41017296FB30}"/>
               </a:ext>
             </a:extLst>
           </p:cNvPr>
@@ -12674,7 +12674,7 @@
           <p:cNvPr id="9" name="">
             <a:extLst xmlns:a="http://schemas.openxmlformats.org/drawingml/2006/main">
               <a:ext uri="{FF2B5EF4-FFF2-40B4-BE49-F238E27FC236}">
-                <a16:creationId xmlns:a16="http://schemas.microsoft.com/office/drawing/2014/main" id="{E265C886-A7DA-4F3E-A9DC-472BEF32EBC2}"/>
+                <a16:creationId xmlns:a16="http://schemas.microsoft.com/office/drawing/2014/main" id="{AE2C75C4-0973-4A92-A0A7-258312FE3C50}"/>
               </a:ext>
             </a:extLst>
           </p:cNvPr>
@@ -12732,7 +12732,7 @@
           <p:cNvPr id="10" name="">
             <a:extLst xmlns:a="http://schemas.openxmlformats.org/drawingml/2006/main">
               <a:ext uri="{FF2B5EF4-FFF2-40B4-BE49-F238E27FC236}">
-                <a16:creationId xmlns:a16="http://schemas.microsoft.com/office/drawing/2014/main" id="{324497A3-A194-4F26-8AE3-FC1785B56484}"/>
+                <a16:creationId xmlns:a16="http://schemas.microsoft.com/office/drawing/2014/main" id="{992DDEAA-6291-4430-9F8F-009D24C621B3}"/>
               </a:ext>
             </a:extLst>
           </p:cNvPr>
@@ -12790,7 +12790,7 @@
           <p:cNvPr id="11" name="">
             <a:extLst xmlns:a="http://schemas.openxmlformats.org/drawingml/2006/main">
               <a:ext uri="{FF2B5EF4-FFF2-40B4-BE49-F238E27FC236}">
-                <a16:creationId xmlns:a16="http://schemas.microsoft.com/office/drawing/2014/main" id="{537AD99E-AAD7-4011-9AE1-148AA21DFD8E}"/>
+                <a16:creationId xmlns:a16="http://schemas.microsoft.com/office/drawing/2014/main" id="{98D97107-81DB-491E-9D5A-A600965D3C05}"/>
               </a:ext>
             </a:extLst>
           </p:cNvPr>
@@ -12846,7 +12846,7 @@
     </p:spTree>
     <p:extLst>
       <p:ext uri="{BB962C8B-B14F-4D97-AF65-F5344CB8AC3E}">
-        <p14:creationId xmlns:p14="http://schemas.microsoft.com/office/powerpoint/2010/main" val="1285082838"/>
+        <p14:creationId xmlns:p14="http://schemas.microsoft.com/office/powerpoint/2010/main" val="604475786"/>
       </p:ext>
     </p:extLst>
   </p:cSld>
@@ -12877,7 +12877,7 @@
           <p:cNvPr id="11" name="">
             <a:extLst xmlns:a="http://schemas.openxmlformats.org/drawingml/2006/main">
               <a:ext uri="{FF2B5EF4-FFF2-40B4-BE49-F238E27FC236}">
-                <a16:creationId xmlns:a16="http://schemas.microsoft.com/office/drawing/2014/main" id="{28FE934A-E9DC-46F9-AC7D-35E07DC6E6DF}"/>
+                <a16:creationId xmlns:a16="http://schemas.microsoft.com/office/drawing/2014/main" id="{2342F17C-C74C-4A05-86CC-E85EB222A219}"/>
               </a:ext>
             </a:extLst>
           </p:cNvPr>
@@ -12935,7 +12935,7 @@
           <p:cNvPr id="2" name="">
             <a:extLst xmlns:a="http://schemas.openxmlformats.org/drawingml/2006/main">
               <a:ext uri="{FF2B5EF4-FFF2-40B4-BE49-F238E27FC236}">
-                <a16:creationId xmlns:a16="http://schemas.microsoft.com/office/drawing/2014/main" id="{33B38DA3-7618-4F64-89A0-3A91507C0EE0}"/>
+                <a16:creationId xmlns:a16="http://schemas.microsoft.com/office/drawing/2014/main" id="{8C11D018-3182-4282-8C46-F12571EA6D4C}"/>
               </a:ext>
             </a:extLst>
           </p:cNvPr>
@@ -12993,7 +12993,7 @@
           <p:cNvPr id="3" name="">
             <a:extLst xmlns:a="http://schemas.openxmlformats.org/drawingml/2006/main">
               <a:ext uri="{FF2B5EF4-FFF2-40B4-BE49-F238E27FC236}">
-                <a16:creationId xmlns:a16="http://schemas.microsoft.com/office/drawing/2014/main" id="{81AD8DB1-1F61-4AD1-BC90-3B2A3E0605A7}"/>
+                <a16:creationId xmlns:a16="http://schemas.microsoft.com/office/drawing/2014/main" id="{595998E6-2FE9-4F43-AF62-1EB7A596F3BA}"/>
               </a:ext>
             </a:extLst>
           </p:cNvPr>
@@ -13051,7 +13051,7 @@
           <p:cNvPr id="4" name="">
             <a:extLst xmlns:a="http://schemas.openxmlformats.org/drawingml/2006/main">
               <a:ext uri="{FF2B5EF4-FFF2-40B4-BE49-F238E27FC236}">
-                <a16:creationId xmlns:a16="http://schemas.microsoft.com/office/drawing/2014/main" id="{9B7F93B3-9790-44BD-AFA3-5D52AEF6E5F9}"/>
+                <a16:creationId xmlns:a16="http://schemas.microsoft.com/office/drawing/2014/main" id="{EF1798E5-E495-4817-9CAE-BB3C7C5F2314}"/>
               </a:ext>
             </a:extLst>
           </p:cNvPr>
@@ -13109,7 +13109,7 @@
           <p:cNvPr id="5" name="">
             <a:extLst xmlns:a="http://schemas.openxmlformats.org/drawingml/2006/main">
               <a:ext uri="{FF2B5EF4-FFF2-40B4-BE49-F238E27FC236}">
-                <a16:creationId xmlns:a16="http://schemas.microsoft.com/office/drawing/2014/main" id="{DB671050-B463-4033-8323-4DDDDD95732D}"/>
+                <a16:creationId xmlns:a16="http://schemas.microsoft.com/office/drawing/2014/main" id="{B7A1C034-550C-4D93-9CEB-F4F1097E6059}"/>
               </a:ext>
             </a:extLst>
           </p:cNvPr>
@@ -13173,7 +13173,7 @@
           <p:cNvPr id="6" name="">
             <a:extLst xmlns:a="http://schemas.openxmlformats.org/drawingml/2006/main">
               <a:ext uri="{FF2B5EF4-FFF2-40B4-BE49-F238E27FC236}">
-                <a16:creationId xmlns:a16="http://schemas.microsoft.com/office/drawing/2014/main" id="{1429427F-6D68-4C52-8B24-E4D931997B62}"/>
+                <a16:creationId xmlns:a16="http://schemas.microsoft.com/office/drawing/2014/main" id="{0846595A-C806-4A01-B870-D4382BF56ABE}"/>
               </a:ext>
             </a:extLst>
           </p:cNvPr>
@@ -13275,7 +13275,7 @@
           <p:cNvPr id="7" name="">
             <a:extLst xmlns:a="http://schemas.openxmlformats.org/drawingml/2006/main">
               <a:ext uri="{FF2B5EF4-FFF2-40B4-BE49-F238E27FC236}">
-                <a16:creationId xmlns:a16="http://schemas.microsoft.com/office/drawing/2014/main" id="{84E07A01-0ECA-4194-804C-138FE2FA68C3}"/>
+                <a16:creationId xmlns:a16="http://schemas.microsoft.com/office/drawing/2014/main" id="{7F99F3F9-5919-4A9A-ACE0-C3B433E308AD}"/>
               </a:ext>
             </a:extLst>
           </p:cNvPr>
@@ -13339,7 +13339,7 @@
           <p:cNvPr id="8" name="">
             <a:extLst xmlns:a="http://schemas.openxmlformats.org/drawingml/2006/main">
               <a:ext uri="{FF2B5EF4-FFF2-40B4-BE49-F238E27FC236}">
-                <a16:creationId xmlns:a16="http://schemas.microsoft.com/office/drawing/2014/main" id="{981E1BEE-1946-47FF-8BEC-4C412DCA2FE7}"/>
+                <a16:creationId xmlns:a16="http://schemas.microsoft.com/office/drawing/2014/main" id="{8F88A6FB-9880-4A41-ADAD-F8A05241DAA0}"/>
               </a:ext>
             </a:extLst>
           </p:cNvPr>
@@ -13458,7 +13458,7 @@
           <p:cNvPr id="9" name="">
             <a:extLst xmlns:a="http://schemas.openxmlformats.org/drawingml/2006/main">
               <a:ext uri="{FF2B5EF4-FFF2-40B4-BE49-F238E27FC236}">
-                <a16:creationId xmlns:a16="http://schemas.microsoft.com/office/drawing/2014/main" id="{C66D9D2E-8883-4F90-9CFA-AF0D55EAF5CA}"/>
+                <a16:creationId xmlns:a16="http://schemas.microsoft.com/office/drawing/2014/main" id="{E43C772B-6FA7-458D-9F2A-12E8C06BD77A}"/>
               </a:ext>
             </a:extLst>
           </p:cNvPr>
@@ -13516,7 +13516,7 @@
           <p:cNvPr id="10" name="">
             <a:extLst xmlns:a="http://schemas.openxmlformats.org/drawingml/2006/main">
               <a:ext uri="{FF2B5EF4-FFF2-40B4-BE49-F238E27FC236}">
-                <a16:creationId xmlns:a16="http://schemas.microsoft.com/office/drawing/2014/main" id="{242801AF-9BAA-4029-B599-D46FF99ED189}"/>
+                <a16:creationId xmlns:a16="http://schemas.microsoft.com/office/drawing/2014/main" id="{A5814A60-9015-4D9C-A655-8F6E0236FD41}"/>
               </a:ext>
             </a:extLst>
           </p:cNvPr>
@@ -13572,7 +13572,7 @@
     </p:spTree>
     <p:extLst>
       <p:ext uri="{BB962C8B-B14F-4D97-AF65-F5344CB8AC3E}">
-        <p14:creationId xmlns:p14="http://schemas.microsoft.com/office/powerpoint/2010/main" val="1381194688"/>
+        <p14:creationId xmlns:p14="http://schemas.microsoft.com/office/powerpoint/2010/main" val="1715303464"/>
       </p:ext>
     </p:extLst>
   </p:cSld>
@@ -13603,7 +13603,7 @@
           <p:cNvPr id="13" name="">
             <a:extLst xmlns:a="http://schemas.openxmlformats.org/drawingml/2006/main">
               <a:ext uri="{FF2B5EF4-FFF2-40B4-BE49-F238E27FC236}">
-                <a16:creationId xmlns:a16="http://schemas.microsoft.com/office/drawing/2014/main" id="{1FED8945-2F8C-42B9-ABEA-AA808541DB8D}"/>
+                <a16:creationId xmlns:a16="http://schemas.microsoft.com/office/drawing/2014/main" id="{E5E2D545-22C5-4A59-AA28-E1FC9350EE19}"/>
               </a:ext>
             </a:extLst>
           </p:cNvPr>
@@ -13661,7 +13661,7 @@
           <p:cNvPr id="2" name="">
             <a:extLst xmlns:a="http://schemas.openxmlformats.org/drawingml/2006/main">
               <a:ext uri="{FF2B5EF4-FFF2-40B4-BE49-F238E27FC236}">
-                <a16:creationId xmlns:a16="http://schemas.microsoft.com/office/drawing/2014/main" id="{33AD0085-0463-424E-8D7D-CB43A336AB92}"/>
+                <a16:creationId xmlns:a16="http://schemas.microsoft.com/office/drawing/2014/main" id="{E1D3B29C-5DCF-43DA-8FB2-301C6999E191}"/>
               </a:ext>
             </a:extLst>
           </p:cNvPr>
@@ -13719,7 +13719,7 @@
           <p:cNvPr id="3" name="">
             <a:extLst xmlns:a="http://schemas.openxmlformats.org/drawingml/2006/main">
               <a:ext uri="{FF2B5EF4-FFF2-40B4-BE49-F238E27FC236}">
-                <a16:creationId xmlns:a16="http://schemas.microsoft.com/office/drawing/2014/main" id="{200C8871-927F-407E-B99F-D265C402EA43}"/>
+                <a16:creationId xmlns:a16="http://schemas.microsoft.com/office/drawing/2014/main" id="{D610F4A4-59B4-4E12-804B-165142C3966B}"/>
               </a:ext>
             </a:extLst>
           </p:cNvPr>
@@ -13777,7 +13777,7 @@
           <p:cNvPr id="4" name="">
             <a:extLst xmlns:a="http://schemas.openxmlformats.org/drawingml/2006/main">
               <a:ext uri="{FF2B5EF4-FFF2-40B4-BE49-F238E27FC236}">
-                <a16:creationId xmlns:a16="http://schemas.microsoft.com/office/drawing/2014/main" id="{D7603B02-580B-4FA1-B3EF-0E021DB126AB}"/>
+                <a16:creationId xmlns:a16="http://schemas.microsoft.com/office/drawing/2014/main" id="{95BF9D6F-B7EC-4C7C-BC04-610636E6E590}"/>
               </a:ext>
             </a:extLst>
           </p:cNvPr>
@@ -13835,7 +13835,7 @@
           <p:cNvPr id="5" name="">
             <a:extLst xmlns:a="http://schemas.openxmlformats.org/drawingml/2006/main">
               <a:ext uri="{FF2B5EF4-FFF2-40B4-BE49-F238E27FC236}">
-                <a16:creationId xmlns:a16="http://schemas.microsoft.com/office/drawing/2014/main" id="{9C016A68-D7C6-4F27-90B3-9FA2836C3FEA}"/>
+                <a16:creationId xmlns:a16="http://schemas.microsoft.com/office/drawing/2014/main" id="{A9E94AC0-3D57-421E-92FF-9765B1478E7F}"/>
               </a:ext>
             </a:extLst>
           </p:cNvPr>
@@ -13916,7 +13916,7 @@
           <p:cNvPr id="6" name="">
             <a:extLst xmlns:a="http://schemas.openxmlformats.org/drawingml/2006/main">
               <a:ext uri="{FF2B5EF4-FFF2-40B4-BE49-F238E27FC236}">
-                <a16:creationId xmlns:a16="http://schemas.microsoft.com/office/drawing/2014/main" id="{225FEE93-05A5-4B28-AA29-B76F79A75685}"/>
+                <a16:creationId xmlns:a16="http://schemas.microsoft.com/office/drawing/2014/main" id="{B504F3DF-AA70-494E-B0F3-6B86D17B79FA}"/>
               </a:ext>
             </a:extLst>
           </p:cNvPr>
@@ -13997,7 +13997,7 @@
           <p:cNvPr id="7" name="">
             <a:extLst xmlns:a="http://schemas.openxmlformats.org/drawingml/2006/main">
               <a:ext uri="{FF2B5EF4-FFF2-40B4-BE49-F238E27FC236}">
-                <a16:creationId xmlns:a16="http://schemas.microsoft.com/office/drawing/2014/main" id="{5A96191E-E13D-40C2-9B10-40096AA2FD89}"/>
+                <a16:creationId xmlns:a16="http://schemas.microsoft.com/office/drawing/2014/main" id="{544B4120-A491-4522-9C35-2D9C0955EF32}"/>
               </a:ext>
             </a:extLst>
           </p:cNvPr>
@@ -14078,7 +14078,7 @@
           <p:cNvPr id="8" name="">
             <a:extLst xmlns:a="http://schemas.openxmlformats.org/drawingml/2006/main">
               <a:ext uri="{FF2B5EF4-FFF2-40B4-BE49-F238E27FC236}">
-                <a16:creationId xmlns:a16="http://schemas.microsoft.com/office/drawing/2014/main" id="{9D297342-1B22-49AD-BA6D-8DC59D9CA9DC}"/>
+                <a16:creationId xmlns:a16="http://schemas.microsoft.com/office/drawing/2014/main" id="{DA3FC91E-641D-4DDB-82B7-77A84BE349F3}"/>
               </a:ext>
             </a:extLst>
           </p:cNvPr>
@@ -14159,7 +14159,7 @@
           <p:cNvPr id="9" name="">
             <a:extLst xmlns:a="http://schemas.openxmlformats.org/drawingml/2006/main">
               <a:ext uri="{FF2B5EF4-FFF2-40B4-BE49-F238E27FC236}">
-                <a16:creationId xmlns:a16="http://schemas.microsoft.com/office/drawing/2014/main" id="{A641C6F5-8E0F-44F1-AA2D-CDACB157CEE2}"/>
+                <a16:creationId xmlns:a16="http://schemas.microsoft.com/office/drawing/2014/main" id="{72A3A22E-2892-495F-AE55-45F9DA96DC0D}"/>
               </a:ext>
             </a:extLst>
           </p:cNvPr>
@@ -14240,7 +14240,7 @@
           <p:cNvPr id="10" name="">
             <a:extLst xmlns:a="http://schemas.openxmlformats.org/drawingml/2006/main">
               <a:ext uri="{FF2B5EF4-FFF2-40B4-BE49-F238E27FC236}">
-                <a16:creationId xmlns:a16="http://schemas.microsoft.com/office/drawing/2014/main" id="{9DF96B93-C699-4D2B-AAD6-72086B6CD0A4}"/>
+                <a16:creationId xmlns:a16="http://schemas.microsoft.com/office/drawing/2014/main" id="{F694ABF6-B794-4C67-8663-DAE2368A79E0}"/>
               </a:ext>
             </a:extLst>
           </p:cNvPr>
@@ -14320,7 +14320,7 @@
           <p:cNvPr id="11" name="">
             <a:extLst xmlns:a="http://schemas.openxmlformats.org/drawingml/2006/main">
               <a:ext uri="{FF2B5EF4-FFF2-40B4-BE49-F238E27FC236}">
-                <a16:creationId xmlns:a16="http://schemas.microsoft.com/office/drawing/2014/main" id="{37912FAF-D351-4523-9C22-225328523E05}"/>
+                <a16:creationId xmlns:a16="http://schemas.microsoft.com/office/drawing/2014/main" id="{1919A2ED-E613-40BD-8EA0-1CCAFF8B3543}"/>
               </a:ext>
             </a:extLst>
           </p:cNvPr>
@@ -14417,7 +14417,7 @@
           <p:cNvPr id="12" name="">
             <a:extLst xmlns:a="http://schemas.openxmlformats.org/drawingml/2006/main">
               <a:ext uri="{FF2B5EF4-FFF2-40B4-BE49-F238E27FC236}">
-                <a16:creationId xmlns:a16="http://schemas.microsoft.com/office/drawing/2014/main" id="{3515CC37-80D8-4C61-8041-A5B1D5FFF4CE}"/>
+                <a16:creationId xmlns:a16="http://schemas.microsoft.com/office/drawing/2014/main" id="{786D0B12-6D87-40CE-84B6-2E9F6CA34EE9}"/>
               </a:ext>
             </a:extLst>
           </p:cNvPr>
@@ -14473,7 +14473,7 @@
     </p:spTree>
     <p:extLst>
       <p:ext uri="{BB962C8B-B14F-4D97-AF65-F5344CB8AC3E}">
-        <p14:creationId xmlns:p14="http://schemas.microsoft.com/office/powerpoint/2010/main" val="751904355"/>
+        <p14:creationId xmlns:p14="http://schemas.microsoft.com/office/powerpoint/2010/main" val="1534595121"/>
       </p:ext>
     </p:extLst>
   </p:cSld>

</xml_diff>